<commit_message>
Polish manager handoff documentation
</commit_message>
<xml_diff>
--- a/fire_weather/docs/presentation/Fire Weather Monitoring Project.pptx
+++ b/fire_weather/docs/presentation/Fire Weather Monitoring Project.pptx
@@ -2,87 +2,87 @@
 <file path=ppt/presentation.xml><?xml version="1.0" encoding="utf-8"?>
 <p:presentation xmlns:p="http://schemas.openxmlformats.org/presentationml/2006/main" embedTrueTypeFonts="1" saveSubsetFonts="0">
   <p:sldMasterIdLst>
-    <p:sldMasterId xmlns:r="http://schemas.openxmlformats.org/officeDocument/2006/relationships" id="2147483648" r:id="Rac01e98d392e40e6"/>
+    <p:sldMasterId xmlns:r="http://schemas.openxmlformats.org/officeDocument/2006/relationships" id="2147483648" r:id="Ra3aca77a99384a57"/>
   </p:sldMasterIdLst>
   <p:notesMasterIdLst>
-    <p:notesMasterId xmlns:r="http://schemas.openxmlformats.org/officeDocument/2006/relationships" r:id="Rc463cfef08324b2a"/>
+    <p:notesMasterId xmlns:r="http://schemas.openxmlformats.org/officeDocument/2006/relationships" r:id="R48cbc8278bcc4ebc"/>
   </p:notesMasterIdLst>
   <p:sldIdLst>
-    <p:sldId xmlns:r="http://schemas.openxmlformats.org/officeDocument/2006/relationships" id="256" r:id="Ra37ef5608ca648ae"/>
-    <p:sldId xmlns:r="http://schemas.openxmlformats.org/officeDocument/2006/relationships" id="257" r:id="R76e0c38529d846f7"/>
-    <p:sldId xmlns:r="http://schemas.openxmlformats.org/officeDocument/2006/relationships" id="258" r:id="R1d1b6907d3d5491f"/>
-    <p:sldId xmlns:r="http://schemas.openxmlformats.org/officeDocument/2006/relationships" id="259" r:id="Rd98b1e95007f41e6"/>
-    <p:sldId xmlns:r="http://schemas.openxmlformats.org/officeDocument/2006/relationships" id="260" r:id="Rcda842e4f1874a19"/>
-    <p:sldId xmlns:r="http://schemas.openxmlformats.org/officeDocument/2006/relationships" id="261" r:id="R45ce9c60cf16479d"/>
-    <p:sldId xmlns:r="http://schemas.openxmlformats.org/officeDocument/2006/relationships" id="262" r:id="Rc0f0cfe1bc234e75"/>
-    <p:sldId xmlns:r="http://schemas.openxmlformats.org/officeDocument/2006/relationships" id="263" r:id="R5421b7f478c54ec0"/>
-    <p:sldId xmlns:r="http://schemas.openxmlformats.org/officeDocument/2006/relationships" id="264" r:id="R7f78ac4e95cc4a60"/>
-    <p:sldId xmlns:r="http://schemas.openxmlformats.org/officeDocument/2006/relationships" id="265" r:id="Rfd6122ae352043d1"/>
-    <p:sldId xmlns:r="http://schemas.openxmlformats.org/officeDocument/2006/relationships" id="266" r:id="R75efd3b8e9044bfb"/>
-    <p:sldId xmlns:r="http://schemas.openxmlformats.org/officeDocument/2006/relationships" id="267" r:id="R9585afc6cfae4559"/>
-    <p:sldId xmlns:r="http://schemas.openxmlformats.org/officeDocument/2006/relationships" id="268" r:id="Rc8212279c6a548f4"/>
-    <p:sldId xmlns:r="http://schemas.openxmlformats.org/officeDocument/2006/relationships" id="269" r:id="Rd592f6ea1cec4c7d"/>
-    <p:sldId xmlns:r="http://schemas.openxmlformats.org/officeDocument/2006/relationships" id="270" r:id="Rdf8280da5cfb42c2"/>
-    <p:sldId xmlns:r="http://schemas.openxmlformats.org/officeDocument/2006/relationships" id="271" r:id="Re1ffecc4e3b8428d"/>
-    <p:sldId xmlns:r="http://schemas.openxmlformats.org/officeDocument/2006/relationships" id="272" r:id="Re9b9fb638d354b9a"/>
-    <p:sldId xmlns:r="http://schemas.openxmlformats.org/officeDocument/2006/relationships" id="273" r:id="R9c95ee4d0c7641f5"/>
-    <p:sldId xmlns:r="http://schemas.openxmlformats.org/officeDocument/2006/relationships" id="274" r:id="Rc172c07b69034552"/>
-    <p:sldId xmlns:r="http://schemas.openxmlformats.org/officeDocument/2006/relationships" id="275" r:id="Rb25f6707fc694e17"/>
-    <p:sldId xmlns:r="http://schemas.openxmlformats.org/officeDocument/2006/relationships" id="276" r:id="Rd37b4f0adc19413f"/>
-    <p:sldId xmlns:r="http://schemas.openxmlformats.org/officeDocument/2006/relationships" id="277" r:id="R2f6645b299a54edb"/>
-    <p:sldId xmlns:r="http://schemas.openxmlformats.org/officeDocument/2006/relationships" id="278" r:id="R5d8d07838e0d473d"/>
-    <p:sldId xmlns:r="http://schemas.openxmlformats.org/officeDocument/2006/relationships" id="279" r:id="R37d54cb65c764ca4"/>
-    <p:sldId xmlns:r="http://schemas.openxmlformats.org/officeDocument/2006/relationships" id="280" r:id="R9394f9b65f10449f"/>
-    <p:sldId xmlns:r="http://schemas.openxmlformats.org/officeDocument/2006/relationships" id="281" r:id="Red3a44c7914c4acd"/>
-    <p:sldId xmlns:r="http://schemas.openxmlformats.org/officeDocument/2006/relationships" id="282" r:id="R2a59afcbca6e40fe"/>
+    <p:sldId xmlns:r="http://schemas.openxmlformats.org/officeDocument/2006/relationships" id="256" r:id="R1f3652fc458a4bdc"/>
+    <p:sldId xmlns:r="http://schemas.openxmlformats.org/officeDocument/2006/relationships" id="257" r:id="Rb0b79d55209f46e3"/>
+    <p:sldId xmlns:r="http://schemas.openxmlformats.org/officeDocument/2006/relationships" id="258" r:id="R29c64ad5a30d49b8"/>
+    <p:sldId xmlns:r="http://schemas.openxmlformats.org/officeDocument/2006/relationships" id="259" r:id="R0b11bf8e68bf4553"/>
+    <p:sldId xmlns:r="http://schemas.openxmlformats.org/officeDocument/2006/relationships" id="260" r:id="R683203a18e0f4e9b"/>
+    <p:sldId xmlns:r="http://schemas.openxmlformats.org/officeDocument/2006/relationships" id="261" r:id="R2d82dbbed71940c1"/>
+    <p:sldId xmlns:r="http://schemas.openxmlformats.org/officeDocument/2006/relationships" id="262" r:id="R67fd2f9c48f640a0"/>
+    <p:sldId xmlns:r="http://schemas.openxmlformats.org/officeDocument/2006/relationships" id="263" r:id="R26ec5c4d031240ea"/>
+    <p:sldId xmlns:r="http://schemas.openxmlformats.org/officeDocument/2006/relationships" id="264" r:id="R08adc2c3ed5a4aa4"/>
+    <p:sldId xmlns:r="http://schemas.openxmlformats.org/officeDocument/2006/relationships" id="265" r:id="Rd78bdca4db224349"/>
+    <p:sldId xmlns:r="http://schemas.openxmlformats.org/officeDocument/2006/relationships" id="266" r:id="R2620baebf8fa40da"/>
+    <p:sldId xmlns:r="http://schemas.openxmlformats.org/officeDocument/2006/relationships" id="267" r:id="R713cd7779d874b64"/>
+    <p:sldId xmlns:r="http://schemas.openxmlformats.org/officeDocument/2006/relationships" id="268" r:id="R539808fa10f54cda"/>
+    <p:sldId xmlns:r="http://schemas.openxmlformats.org/officeDocument/2006/relationships" id="269" r:id="R9a3a313946f2496d"/>
+    <p:sldId xmlns:r="http://schemas.openxmlformats.org/officeDocument/2006/relationships" id="270" r:id="R6b64436fac1f4d7a"/>
+    <p:sldId xmlns:r="http://schemas.openxmlformats.org/officeDocument/2006/relationships" id="271" r:id="Rd6cc2f732f90477c"/>
+    <p:sldId xmlns:r="http://schemas.openxmlformats.org/officeDocument/2006/relationships" id="272" r:id="R02c1dd5c11c44515"/>
+    <p:sldId xmlns:r="http://schemas.openxmlformats.org/officeDocument/2006/relationships" id="273" r:id="Read74eeb4f43460f"/>
+    <p:sldId xmlns:r="http://schemas.openxmlformats.org/officeDocument/2006/relationships" id="274" r:id="Rc7d92ab8193d4fdf"/>
+    <p:sldId xmlns:r="http://schemas.openxmlformats.org/officeDocument/2006/relationships" id="275" r:id="Rad7f1f4682e949be"/>
+    <p:sldId xmlns:r="http://schemas.openxmlformats.org/officeDocument/2006/relationships" id="276" r:id="R5d8d197a3dfb40ad"/>
+    <p:sldId xmlns:r="http://schemas.openxmlformats.org/officeDocument/2006/relationships" id="277" r:id="R35b3f68a02cb4b0d"/>
+    <p:sldId xmlns:r="http://schemas.openxmlformats.org/officeDocument/2006/relationships" id="278" r:id="Rd5d58d21ba694cf3"/>
+    <p:sldId xmlns:r="http://schemas.openxmlformats.org/officeDocument/2006/relationships" id="279" r:id="R8f513f16aaf348b2"/>
+    <p:sldId xmlns:r="http://schemas.openxmlformats.org/officeDocument/2006/relationships" id="280" r:id="R13149cb04ebe4b23"/>
+    <p:sldId xmlns:r="http://schemas.openxmlformats.org/officeDocument/2006/relationships" id="281" r:id="R7a34a7368e484959"/>
+    <p:sldId xmlns:r="http://schemas.openxmlformats.org/officeDocument/2006/relationships" id="282" r:id="Rcbe8cdc8f96f4d52"/>
   </p:sldIdLst>
   <p:sldSz cx="12192000" cy="6858000"/>
   <p:notesSz cx="6858000" cy="9144000"/>
   <p:embeddedFontLst>
     <p:embeddedFont>
       <p:font typeface="Manrope SemiBold"/>
-      <p:regular xmlns:r="http://schemas.openxmlformats.org/officeDocument/2006/relationships" r:id="Rf76d7316e03342fb"/>
-      <p:bold xmlns:r="http://schemas.openxmlformats.org/officeDocument/2006/relationships" r:id="Rca38da86a3a544b6"/>
+      <p:regular xmlns:r="http://schemas.openxmlformats.org/officeDocument/2006/relationships" r:id="Rdcc3a7badc814950"/>
+      <p:bold xmlns:r="http://schemas.openxmlformats.org/officeDocument/2006/relationships" r:id="R0c6c62208e774b60"/>
     </p:embeddedFont>
     <p:embeddedFont>
       <p:font typeface="Inter"/>
-      <p:regular xmlns:r="http://schemas.openxmlformats.org/officeDocument/2006/relationships" r:id="Rf5a980f7c4604314"/>
-      <p:bold xmlns:r="http://schemas.openxmlformats.org/officeDocument/2006/relationships" r:id="Ra5efd65e44ff4a75"/>
-      <p:italic xmlns:r="http://schemas.openxmlformats.org/officeDocument/2006/relationships" r:id="Redbe5dd485394e33"/>
-      <p:boldItalic xmlns:r="http://schemas.openxmlformats.org/officeDocument/2006/relationships" r:id="Ra4958aec84804a02"/>
+      <p:regular xmlns:r="http://schemas.openxmlformats.org/officeDocument/2006/relationships" r:id="R08bd3d3992f74c6e"/>
+      <p:bold xmlns:r="http://schemas.openxmlformats.org/officeDocument/2006/relationships" r:id="R796a12f2d56b4132"/>
+      <p:italic xmlns:r="http://schemas.openxmlformats.org/officeDocument/2006/relationships" r:id="R92066b9ba8ae445b"/>
+      <p:boldItalic xmlns:r="http://schemas.openxmlformats.org/officeDocument/2006/relationships" r:id="Rf25f589c6e0c4c21"/>
     </p:embeddedFont>
     <p:embeddedFont>
       <p:font typeface="Manrope"/>
-      <p:regular xmlns:r="http://schemas.openxmlformats.org/officeDocument/2006/relationships" r:id="R3f0f5ceb4cc14922"/>
-      <p:bold xmlns:r="http://schemas.openxmlformats.org/officeDocument/2006/relationships" r:id="Rb9776e8d3a3a42e5"/>
+      <p:regular xmlns:r="http://schemas.openxmlformats.org/officeDocument/2006/relationships" r:id="Rf88aa764330f43ea"/>
+      <p:bold xmlns:r="http://schemas.openxmlformats.org/officeDocument/2006/relationships" r:id="Ref770801c98f467f"/>
     </p:embeddedFont>
     <p:embeddedFont>
       <p:font typeface="Urbanist SemiBold"/>
-      <p:regular xmlns:r="http://schemas.openxmlformats.org/officeDocument/2006/relationships" r:id="Ra4f3065a8aac4101"/>
-      <p:bold xmlns:r="http://schemas.openxmlformats.org/officeDocument/2006/relationships" r:id="R6bdc656edd8f4921"/>
-      <p:italic xmlns:r="http://schemas.openxmlformats.org/officeDocument/2006/relationships" r:id="R402fa74314aa4935"/>
-      <p:boldItalic xmlns:r="http://schemas.openxmlformats.org/officeDocument/2006/relationships" r:id="Rd3fb4876df00443c"/>
+      <p:regular xmlns:r="http://schemas.openxmlformats.org/officeDocument/2006/relationships" r:id="R957d6c9439544b50"/>
+      <p:bold xmlns:r="http://schemas.openxmlformats.org/officeDocument/2006/relationships" r:id="R9034a5f33ccc4fc8"/>
+      <p:italic xmlns:r="http://schemas.openxmlformats.org/officeDocument/2006/relationships" r:id="Radf0d987e0404d7f"/>
+      <p:boldItalic xmlns:r="http://schemas.openxmlformats.org/officeDocument/2006/relationships" r:id="R9757eb4cc69c4332"/>
     </p:embeddedFont>
     <p:embeddedFont>
       <p:font typeface="Urbanist Medium"/>
-      <p:regular xmlns:r="http://schemas.openxmlformats.org/officeDocument/2006/relationships" r:id="R9b7c6dd539bb4c4d"/>
-      <p:bold xmlns:r="http://schemas.openxmlformats.org/officeDocument/2006/relationships" r:id="R60936f0ac1cb44d5"/>
-      <p:italic xmlns:r="http://schemas.openxmlformats.org/officeDocument/2006/relationships" r:id="Rb7edb9f632b74660"/>
-      <p:boldItalic xmlns:r="http://schemas.openxmlformats.org/officeDocument/2006/relationships" r:id="R605ff6da67a94cb7"/>
+      <p:regular xmlns:r="http://schemas.openxmlformats.org/officeDocument/2006/relationships" r:id="Rfa66cdb0d50a454a"/>
+      <p:bold xmlns:r="http://schemas.openxmlformats.org/officeDocument/2006/relationships" r:id="R8a6a0869fad24dca"/>
+      <p:italic xmlns:r="http://schemas.openxmlformats.org/officeDocument/2006/relationships" r:id="R11d2413a821e4cc5"/>
+      <p:boldItalic xmlns:r="http://schemas.openxmlformats.org/officeDocument/2006/relationships" r:id="R114a40f3a3754914"/>
     </p:embeddedFont>
     <p:embeddedFont>
       <p:font typeface="Urbanist"/>
-      <p:regular xmlns:r="http://schemas.openxmlformats.org/officeDocument/2006/relationships" r:id="R07a79144a71a46cf"/>
-      <p:bold xmlns:r="http://schemas.openxmlformats.org/officeDocument/2006/relationships" r:id="R41787abf51614d48"/>
-      <p:italic xmlns:r="http://schemas.openxmlformats.org/officeDocument/2006/relationships" r:id="R7a206bbefbc74e4a"/>
-      <p:boldItalic xmlns:r="http://schemas.openxmlformats.org/officeDocument/2006/relationships" r:id="R85f1fb3d258041a4"/>
+      <p:regular xmlns:r="http://schemas.openxmlformats.org/officeDocument/2006/relationships" r:id="Rbf4f7515c27843a3"/>
+      <p:bold xmlns:r="http://schemas.openxmlformats.org/officeDocument/2006/relationships" r:id="Re109c84dfdc440de"/>
+      <p:italic xmlns:r="http://schemas.openxmlformats.org/officeDocument/2006/relationships" r:id="R1c2676b285364826"/>
+      <p:boldItalic xmlns:r="http://schemas.openxmlformats.org/officeDocument/2006/relationships" r:id="R1ea320f84d2c4a7b"/>
     </p:embeddedFont>
     <p:embeddedFont>
       <p:font typeface="Poppins SemiBold"/>
-      <p:regular xmlns:r="http://schemas.openxmlformats.org/officeDocument/2006/relationships" r:id="Rb83975fd7aec4dd8"/>
-      <p:bold xmlns:r="http://schemas.openxmlformats.org/officeDocument/2006/relationships" r:id="Ree7f0a3b7d0f4dea"/>
-      <p:italic xmlns:r="http://schemas.openxmlformats.org/officeDocument/2006/relationships" r:id="Re426cebe55354ed7"/>
-      <p:boldItalic xmlns:r="http://schemas.openxmlformats.org/officeDocument/2006/relationships" r:id="R2b9b392f4fca49ca"/>
+      <p:regular xmlns:r="http://schemas.openxmlformats.org/officeDocument/2006/relationships" r:id="R748b64b382b24a1c"/>
+      <p:bold xmlns:r="http://schemas.openxmlformats.org/officeDocument/2006/relationships" r:id="R8ee75868b26743b7"/>
+      <p:italic xmlns:r="http://schemas.openxmlformats.org/officeDocument/2006/relationships" r:id="Rbec3436411ea4e6c"/>
+      <p:boldItalic xmlns:r="http://schemas.openxmlformats.org/officeDocument/2006/relationships" r:id="R727c0dd343a6455e"/>
     </p:embeddedFont>
   </p:embeddedFontLst>
 </p:presentation>
@@ -12800,17 +12800,17 @@
   </p:cSld>
   <p:clrMap bg1="lt1" tx1="dk1" bg2="dk2" tx2="lt2" accent1="accent1" accent2="accent2" accent3="accent3" accent4="accent4" accent5="accent5" accent6="accent6" hlink="hlink" folHlink="folHlink"/>
   <p:sldLayoutIdLst>
-    <p:sldLayoutId xmlns:r="http://schemas.openxmlformats.org/officeDocument/2006/relationships" id="2147483649" r:id="R4c8d29d1639241e9"/>
-    <p:sldLayoutId xmlns:r="http://schemas.openxmlformats.org/officeDocument/2006/relationships" id="2147483650" r:id="R023fa7bdc8ec46df"/>
-    <p:sldLayoutId xmlns:r="http://schemas.openxmlformats.org/officeDocument/2006/relationships" id="2147483651" r:id="R0946709a8b2d42be"/>
-    <p:sldLayoutId xmlns:r="http://schemas.openxmlformats.org/officeDocument/2006/relationships" id="2147483652" r:id="R36118a46fbf34fac"/>
-    <p:sldLayoutId xmlns:r="http://schemas.openxmlformats.org/officeDocument/2006/relationships" id="2147483653" r:id="R94fcd6f18b9c4bfe"/>
-    <p:sldLayoutId xmlns:r="http://schemas.openxmlformats.org/officeDocument/2006/relationships" id="2147483654" r:id="R2d6c49f68c53407a"/>
-    <p:sldLayoutId xmlns:r="http://schemas.openxmlformats.org/officeDocument/2006/relationships" id="2147483655" r:id="Rc10c4087b0b4414a"/>
-    <p:sldLayoutId xmlns:r="http://schemas.openxmlformats.org/officeDocument/2006/relationships" id="2147483656" r:id="R5ccfdcb5c58147a6"/>
-    <p:sldLayoutId xmlns:r="http://schemas.openxmlformats.org/officeDocument/2006/relationships" id="2147483657" r:id="Rbe7680cd0cb74321"/>
-    <p:sldLayoutId xmlns:r="http://schemas.openxmlformats.org/officeDocument/2006/relationships" id="2147483658" r:id="R056a416bb3834f8a"/>
-    <p:sldLayoutId xmlns:r="http://schemas.openxmlformats.org/officeDocument/2006/relationships" id="2147483659" r:id="R401deec24f9049de"/>
+    <p:sldLayoutId xmlns:r="http://schemas.openxmlformats.org/officeDocument/2006/relationships" id="2147483649" r:id="R970fa373686d44ae"/>
+    <p:sldLayoutId xmlns:r="http://schemas.openxmlformats.org/officeDocument/2006/relationships" id="2147483650" r:id="R1dcc0a88a8f841a4"/>
+    <p:sldLayoutId xmlns:r="http://schemas.openxmlformats.org/officeDocument/2006/relationships" id="2147483651" r:id="R4507860fea9a4c35"/>
+    <p:sldLayoutId xmlns:r="http://schemas.openxmlformats.org/officeDocument/2006/relationships" id="2147483652" r:id="R27f307ffdc0f4d61"/>
+    <p:sldLayoutId xmlns:r="http://schemas.openxmlformats.org/officeDocument/2006/relationships" id="2147483653" r:id="R4056b6e3fb4e49f8"/>
+    <p:sldLayoutId xmlns:r="http://schemas.openxmlformats.org/officeDocument/2006/relationships" id="2147483654" r:id="Re6564a742d05481f"/>
+    <p:sldLayoutId xmlns:r="http://schemas.openxmlformats.org/officeDocument/2006/relationships" id="2147483655" r:id="Re4199e4a1bca4d55"/>
+    <p:sldLayoutId xmlns:r="http://schemas.openxmlformats.org/officeDocument/2006/relationships" id="2147483656" r:id="R7d52a7081ca24d8c"/>
+    <p:sldLayoutId xmlns:r="http://schemas.openxmlformats.org/officeDocument/2006/relationships" id="2147483657" r:id="R2bd2a5216f79450e"/>
+    <p:sldLayoutId xmlns:r="http://schemas.openxmlformats.org/officeDocument/2006/relationships" id="2147483658" r:id="R26e8d1d81fdd4e87"/>
+    <p:sldLayoutId xmlns:r="http://schemas.openxmlformats.org/officeDocument/2006/relationships" id="2147483659" r:id="R5cd048f54edc4659"/>
   </p:sldLayoutIdLst>
   <p:hf sldNum="0" hdr="0" ftr="0" dt="0"/>
   <p:txStyles>
@@ -13768,7 +13768,7 @@
           <p:nvPr/>
         </p:nvPicPr>
         <p:blipFill rotWithShape="1">
-          <a:blip xmlns:r="http://schemas.openxmlformats.org/officeDocument/2006/relationships" xmlns:a="http://schemas.openxmlformats.org/drawingml/2006/main" r:embed="Rb2158f0768934a75">
+          <a:blip xmlns:r="http://schemas.openxmlformats.org/officeDocument/2006/relationships" xmlns:a="http://schemas.openxmlformats.org/drawingml/2006/main" r:embed="R7c7ea06b65e54fc6">
             <a:alphaModFix/>
           </a:blip>
           <a:srcRect xmlns:a="http://schemas.openxmlformats.org/drawingml/2006/main" l="0" t="0" r="0" b="0"/>
@@ -14064,7 +14064,7 @@
           <p:nvPr/>
         </p:nvPicPr>
         <p:blipFill rotWithShape="1">
-          <a:blip xmlns:r="http://schemas.openxmlformats.org/officeDocument/2006/relationships" xmlns:a="http://schemas.openxmlformats.org/drawingml/2006/main" r:embed="R53d870ad4af34b70">
+          <a:blip xmlns:r="http://schemas.openxmlformats.org/officeDocument/2006/relationships" xmlns:a="http://schemas.openxmlformats.org/drawingml/2006/main" r:embed="Rec363cd9e53c4322">
             <a:alphaModFix/>
           </a:blip>
           <a:srcRect xmlns:a="http://schemas.openxmlformats.org/drawingml/2006/main" l="0" t="0" r="0" b="0"/>
@@ -14092,7 +14092,7 @@
           <p:nvPr/>
         </p:nvPicPr>
         <p:blipFill rotWithShape="1">
-          <a:blip xmlns:r="http://schemas.openxmlformats.org/officeDocument/2006/relationships" xmlns:a="http://schemas.openxmlformats.org/drawingml/2006/main" r:embed="R52c33bb9da3f4d70">
+          <a:blip xmlns:r="http://schemas.openxmlformats.org/officeDocument/2006/relationships" xmlns:a="http://schemas.openxmlformats.org/drawingml/2006/main" r:embed="R3f075b0085b04c99">
             <a:alphaModFix/>
           </a:blip>
           <a:srcRect xmlns:a="http://schemas.openxmlformats.org/drawingml/2006/main" l="0" t="0" r="0" b="0"/>
@@ -14120,7 +14120,7 @@
           <p:nvPr/>
         </p:nvPicPr>
         <p:blipFill rotWithShape="1">
-          <a:blip xmlns:r="http://schemas.openxmlformats.org/officeDocument/2006/relationships" xmlns:a="http://schemas.openxmlformats.org/drawingml/2006/main" r:embed="R1966e6aeb7bf4cb3">
+          <a:blip xmlns:r="http://schemas.openxmlformats.org/officeDocument/2006/relationships" xmlns:a="http://schemas.openxmlformats.org/drawingml/2006/main" r:embed="Rbd795c5026164c04">
             <a:alphaModFix/>
           </a:blip>
           <a:srcRect xmlns:a="http://schemas.openxmlformats.org/drawingml/2006/main" l="0" t="0" r="0" b="0"/>
@@ -14148,7 +14148,7 @@
           <p:nvPr/>
         </p:nvPicPr>
         <p:blipFill rotWithShape="1">
-          <a:blip xmlns:r="http://schemas.openxmlformats.org/officeDocument/2006/relationships" xmlns:a="http://schemas.openxmlformats.org/drawingml/2006/main" r:embed="R52c33bb9da3f4d70">
+          <a:blip xmlns:r="http://schemas.openxmlformats.org/officeDocument/2006/relationships" xmlns:a="http://schemas.openxmlformats.org/drawingml/2006/main" r:embed="R3f075b0085b04c99">
             <a:alphaModFix/>
           </a:blip>
           <a:srcRect xmlns:a="http://schemas.openxmlformats.org/drawingml/2006/main" l="0" t="0" r="0" b="0"/>
@@ -14678,7 +14678,7 @@
           <p:nvPr/>
         </p:nvPicPr>
         <p:blipFill rotWithShape="1">
-          <a:blip xmlns:r="http://schemas.openxmlformats.org/officeDocument/2006/relationships" xmlns:a="http://schemas.openxmlformats.org/drawingml/2006/main" r:embed="Rf972921966b742b0">
+          <a:blip xmlns:r="http://schemas.openxmlformats.org/officeDocument/2006/relationships" xmlns:a="http://schemas.openxmlformats.org/drawingml/2006/main" r:embed="R057b5e3b570c45c2">
             <a:alphaModFix/>
           </a:blip>
           <a:srcRect xmlns:a="http://schemas.openxmlformats.org/drawingml/2006/main" l="0" t="0" r="0" b="0"/>
@@ -14706,7 +14706,7 @@
           <p:nvPr/>
         </p:nvPicPr>
         <p:blipFill rotWithShape="1">
-          <a:blip xmlns:r="http://schemas.openxmlformats.org/officeDocument/2006/relationships" xmlns:a="http://schemas.openxmlformats.org/drawingml/2006/main" r:embed="R63fb1b6801cd4e54">
+          <a:blip xmlns:r="http://schemas.openxmlformats.org/officeDocument/2006/relationships" xmlns:a="http://schemas.openxmlformats.org/drawingml/2006/main" r:embed="Recacd3794df64eb6">
             <a:alphaModFix/>
           </a:blip>
           <a:srcRect xmlns:a="http://schemas.openxmlformats.org/drawingml/2006/main" l="0" t="0" r="0" b="0"/>
@@ -14734,7 +14734,7 @@
           <p:nvPr/>
         </p:nvPicPr>
         <p:blipFill rotWithShape="1">
-          <a:blip xmlns:r="http://schemas.openxmlformats.org/officeDocument/2006/relationships" xmlns:a="http://schemas.openxmlformats.org/drawingml/2006/main" r:embed="R88aa1b9a4b1241ed">
+          <a:blip xmlns:r="http://schemas.openxmlformats.org/officeDocument/2006/relationships" xmlns:a="http://schemas.openxmlformats.org/drawingml/2006/main" r:embed="Rf1c2703bcb164984">
             <a:alphaModFix/>
           </a:blip>
           <a:srcRect xmlns:a="http://schemas.openxmlformats.org/drawingml/2006/main" l="0" t="0" r="0" b="0"/>
@@ -15778,7 +15778,7 @@
           <p:nvPr/>
         </p:nvPicPr>
         <p:blipFill rotWithShape="1">
-          <a:blip xmlns:r="http://schemas.openxmlformats.org/officeDocument/2006/relationships" xmlns:a="http://schemas.openxmlformats.org/drawingml/2006/main" r:embed="R126bec7176264a90">
+          <a:blip xmlns:r="http://schemas.openxmlformats.org/officeDocument/2006/relationships" xmlns:a="http://schemas.openxmlformats.org/drawingml/2006/main" r:embed="Rf61abf37bb3b4d2c">
             <a:alphaModFix/>
           </a:blip>
           <a:srcRect xmlns:a="http://schemas.openxmlformats.org/drawingml/2006/main" l="0" t="0" r="0" b="0"/>
@@ -15806,7 +15806,7 @@
           <p:nvPr/>
         </p:nvPicPr>
         <p:blipFill rotWithShape="1">
-          <a:blip xmlns:r="http://schemas.openxmlformats.org/officeDocument/2006/relationships" xmlns:a="http://schemas.openxmlformats.org/drawingml/2006/main" r:embed="Rc220edb5ad5541a6">
+          <a:blip xmlns:r="http://schemas.openxmlformats.org/officeDocument/2006/relationships" xmlns:a="http://schemas.openxmlformats.org/drawingml/2006/main" r:embed="R73dbabf291674409">
             <a:alphaModFix/>
           </a:blip>
           <a:srcRect xmlns:a="http://schemas.openxmlformats.org/drawingml/2006/main" l="0" t="0" r="0" b="0"/>
@@ -15834,7 +15834,7 @@
           <p:nvPr/>
         </p:nvPicPr>
         <p:blipFill rotWithShape="1">
-          <a:blip xmlns:r="http://schemas.openxmlformats.org/officeDocument/2006/relationships" xmlns:a="http://schemas.openxmlformats.org/drawingml/2006/main" r:embed="Rd73d45d61c714087">
+          <a:blip xmlns:r="http://schemas.openxmlformats.org/officeDocument/2006/relationships" xmlns:a="http://schemas.openxmlformats.org/drawingml/2006/main" r:embed="Ra08bd6632dca4464">
             <a:alphaModFix/>
           </a:blip>
           <a:srcRect xmlns:a="http://schemas.openxmlformats.org/drawingml/2006/main" l="0" t="0" r="0" b="0"/>
@@ -16154,7 +16154,7 @@
           <p:nvPr/>
         </p:nvPicPr>
         <p:blipFill rotWithShape="1">
-          <a:blip xmlns:r="http://schemas.openxmlformats.org/officeDocument/2006/relationships" xmlns:a="http://schemas.openxmlformats.org/drawingml/2006/main" r:embed="R433d2a0703344cd9">
+          <a:blip xmlns:r="http://schemas.openxmlformats.org/officeDocument/2006/relationships" xmlns:a="http://schemas.openxmlformats.org/drawingml/2006/main" r:embed="R4a18bf0aca66440a">
             <a:alphaModFix/>
           </a:blip>
           <a:srcRect xmlns:a="http://schemas.openxmlformats.org/drawingml/2006/main" l="0" t="0" r="0" b="0"/>
@@ -16182,7 +16182,7 @@
           <p:nvPr/>
         </p:nvPicPr>
         <p:blipFill rotWithShape="1">
-          <a:blip xmlns:r="http://schemas.openxmlformats.org/officeDocument/2006/relationships" xmlns:a="http://schemas.openxmlformats.org/drawingml/2006/main" r:embed="R433d2a0703344cd9">
+          <a:blip xmlns:r="http://schemas.openxmlformats.org/officeDocument/2006/relationships" xmlns:a="http://schemas.openxmlformats.org/drawingml/2006/main" r:embed="R4a18bf0aca66440a">
             <a:alphaModFix/>
           </a:blip>
           <a:srcRect xmlns:a="http://schemas.openxmlformats.org/drawingml/2006/main" l="0" t="0" r="0" b="0"/>
@@ -16210,7 +16210,7 @@
           <p:nvPr/>
         </p:nvPicPr>
         <p:blipFill rotWithShape="1">
-          <a:blip xmlns:r="http://schemas.openxmlformats.org/officeDocument/2006/relationships" xmlns:a="http://schemas.openxmlformats.org/drawingml/2006/main" r:embed="R433d2a0703344cd9">
+          <a:blip xmlns:r="http://schemas.openxmlformats.org/officeDocument/2006/relationships" xmlns:a="http://schemas.openxmlformats.org/drawingml/2006/main" r:embed="R4a18bf0aca66440a">
             <a:alphaModFix/>
           </a:blip>
           <a:srcRect xmlns:a="http://schemas.openxmlformats.org/drawingml/2006/main" l="0" t="0" r="0" b="0"/>
@@ -16373,7 +16373,7 @@
           <p:nvPr/>
         </p:nvPicPr>
         <p:blipFill rotWithShape="1">
-          <a:blip xmlns:r="http://schemas.openxmlformats.org/officeDocument/2006/relationships" xmlns:a="http://schemas.openxmlformats.org/drawingml/2006/main" r:embed="Ra9eabcddf203433c">
+          <a:blip xmlns:r="http://schemas.openxmlformats.org/officeDocument/2006/relationships" xmlns:a="http://schemas.openxmlformats.org/drawingml/2006/main" r:embed="R7ccb0f9410eb4f4c">
             <a:alphaModFix/>
           </a:blip>
           <a:srcRect xmlns:a="http://schemas.openxmlformats.org/drawingml/2006/main" l="0" t="0" r="0" b="0"/>
@@ -16607,7 +16607,7 @@
           <p:nvPr/>
         </p:nvPicPr>
         <p:blipFill rotWithShape="1">
-          <a:blip xmlns:r="http://schemas.openxmlformats.org/officeDocument/2006/relationships" xmlns:a="http://schemas.openxmlformats.org/drawingml/2006/main" r:embed="Rb7f20dd372c6469d">
+          <a:blip xmlns:r="http://schemas.openxmlformats.org/officeDocument/2006/relationships" xmlns:a="http://schemas.openxmlformats.org/drawingml/2006/main" r:embed="R2f3371a0d5074228">
             <a:alphaModFix/>
           </a:blip>
           <a:srcRect xmlns:a="http://schemas.openxmlformats.org/drawingml/2006/main" l="0" t="0" r="0" b="0"/>
@@ -16741,7 +16741,7 @@
           <p:nvPr/>
         </p:nvPicPr>
         <p:blipFill>
-          <a:blip xmlns:r="http://schemas.openxmlformats.org/officeDocument/2006/relationships" xmlns:a="http://schemas.openxmlformats.org/drawingml/2006/main" r:embed="R7f9ce65f285e4221">
+          <a:blip xmlns:r="http://schemas.openxmlformats.org/officeDocument/2006/relationships" xmlns:a="http://schemas.openxmlformats.org/drawingml/2006/main" r:embed="R82d09496cae9478a">
             <a:alphaModFix/>
           </a:blip>
           <a:stretch xmlns:a="http://schemas.openxmlformats.org/drawingml/2006/main">
@@ -16947,7 +16947,7 @@
           <p:nvPr/>
         </p:nvPicPr>
         <p:blipFill rotWithShape="1">
-          <a:blip xmlns:r="http://schemas.openxmlformats.org/officeDocument/2006/relationships" xmlns:a="http://schemas.openxmlformats.org/drawingml/2006/main" r:embed="R2d8b7486c81f4d03">
+          <a:blip xmlns:r="http://schemas.openxmlformats.org/officeDocument/2006/relationships" xmlns:a="http://schemas.openxmlformats.org/drawingml/2006/main" r:embed="Rfbc17be18277415d">
             <a:alphaModFix/>
           </a:blip>
           <a:srcRect xmlns:a="http://schemas.openxmlformats.org/drawingml/2006/main" l="0" t="0" r="0" b="0"/>
@@ -16975,7 +16975,7 @@
           <p:nvPr/>
         </p:nvPicPr>
         <p:blipFill rotWithShape="1">
-          <a:blip xmlns:r="http://schemas.openxmlformats.org/officeDocument/2006/relationships" xmlns:a="http://schemas.openxmlformats.org/drawingml/2006/main" r:embed="R2d8b7486c81f4d03">
+          <a:blip xmlns:r="http://schemas.openxmlformats.org/officeDocument/2006/relationships" xmlns:a="http://schemas.openxmlformats.org/drawingml/2006/main" r:embed="Rfbc17be18277415d">
             <a:alphaModFix/>
           </a:blip>
           <a:srcRect xmlns:a="http://schemas.openxmlformats.org/drawingml/2006/main" l="0" t="0" r="0" b="0"/>
@@ -17003,7 +17003,7 @@
           <p:nvPr/>
         </p:nvPicPr>
         <p:blipFill rotWithShape="1">
-          <a:blip xmlns:r="http://schemas.openxmlformats.org/officeDocument/2006/relationships" xmlns:a="http://schemas.openxmlformats.org/drawingml/2006/main" r:embed="R2d8b7486c81f4d03">
+          <a:blip xmlns:r="http://schemas.openxmlformats.org/officeDocument/2006/relationships" xmlns:a="http://schemas.openxmlformats.org/drawingml/2006/main" r:embed="Rfbc17be18277415d">
             <a:alphaModFix/>
           </a:blip>
           <a:srcRect xmlns:a="http://schemas.openxmlformats.org/drawingml/2006/main" l="0" t="0" r="0" b="0"/>
@@ -17177,7 +17177,7 @@
           <p:nvPr/>
         </p:nvPicPr>
         <p:blipFill>
-          <a:blip xmlns:r="http://schemas.openxmlformats.org/officeDocument/2006/relationships" xmlns:a="http://schemas.openxmlformats.org/drawingml/2006/main" r:embed="R61b29e1b2cb24541">
+          <a:blip xmlns:r="http://schemas.openxmlformats.org/officeDocument/2006/relationships" xmlns:a="http://schemas.openxmlformats.org/drawingml/2006/main" r:embed="R92b77b7bdb3b4ff4">
             <a:alphaModFix/>
           </a:blip>
           <a:stretch xmlns:a="http://schemas.openxmlformats.org/drawingml/2006/main">
@@ -17383,7 +17383,7 @@
           <p:nvPr/>
         </p:nvPicPr>
         <p:blipFill rotWithShape="1">
-          <a:blip xmlns:r="http://schemas.openxmlformats.org/officeDocument/2006/relationships" xmlns:a="http://schemas.openxmlformats.org/drawingml/2006/main" r:embed="R11f214fc67634d94">
+          <a:blip xmlns:r="http://schemas.openxmlformats.org/officeDocument/2006/relationships" xmlns:a="http://schemas.openxmlformats.org/drawingml/2006/main" r:embed="R9d942d9eb0474367">
             <a:alphaModFix/>
           </a:blip>
           <a:srcRect xmlns:a="http://schemas.openxmlformats.org/drawingml/2006/main" l="0" t="0" r="0" b="0"/>
@@ -17411,7 +17411,7 @@
           <p:nvPr/>
         </p:nvPicPr>
         <p:blipFill rotWithShape="1">
-          <a:blip xmlns:r="http://schemas.openxmlformats.org/officeDocument/2006/relationships" xmlns:a="http://schemas.openxmlformats.org/drawingml/2006/main" r:embed="R11f214fc67634d94">
+          <a:blip xmlns:r="http://schemas.openxmlformats.org/officeDocument/2006/relationships" xmlns:a="http://schemas.openxmlformats.org/drawingml/2006/main" r:embed="R9d942d9eb0474367">
             <a:alphaModFix/>
           </a:blip>
           <a:srcRect xmlns:a="http://schemas.openxmlformats.org/drawingml/2006/main" l="0" t="0" r="0" b="0"/>
@@ -17439,7 +17439,7 @@
           <p:nvPr/>
         </p:nvPicPr>
         <p:blipFill rotWithShape="1">
-          <a:blip xmlns:r="http://schemas.openxmlformats.org/officeDocument/2006/relationships" xmlns:a="http://schemas.openxmlformats.org/drawingml/2006/main" r:embed="R11f214fc67634d94">
+          <a:blip xmlns:r="http://schemas.openxmlformats.org/officeDocument/2006/relationships" xmlns:a="http://schemas.openxmlformats.org/drawingml/2006/main" r:embed="R9d942d9eb0474367">
             <a:alphaModFix/>
           </a:blip>
           <a:srcRect xmlns:a="http://schemas.openxmlformats.org/drawingml/2006/main" l="0" t="0" r="0" b="0"/>
@@ -17782,7 +17782,7 @@
           <p:nvPr/>
         </p:nvPicPr>
         <p:blipFill rotWithShape="1">
-          <a:blip xmlns:r="http://schemas.openxmlformats.org/officeDocument/2006/relationships" xmlns:a="http://schemas.openxmlformats.org/drawingml/2006/main" r:embed="R31e05aeda21d47ac">
+          <a:blip xmlns:r="http://schemas.openxmlformats.org/officeDocument/2006/relationships" xmlns:a="http://schemas.openxmlformats.org/drawingml/2006/main" r:embed="R61044bd001aa4b99">
             <a:alphaModFix/>
           </a:blip>
           <a:srcRect xmlns:a="http://schemas.openxmlformats.org/drawingml/2006/main" l="0" t="0" r="0" b="0"/>
@@ -17810,7 +17810,7 @@
           <p:nvPr/>
         </p:nvPicPr>
         <p:blipFill rotWithShape="1">
-          <a:blip xmlns:r="http://schemas.openxmlformats.org/officeDocument/2006/relationships" xmlns:a="http://schemas.openxmlformats.org/drawingml/2006/main" r:embed="R31e05aeda21d47ac">
+          <a:blip xmlns:r="http://schemas.openxmlformats.org/officeDocument/2006/relationships" xmlns:a="http://schemas.openxmlformats.org/drawingml/2006/main" r:embed="R61044bd001aa4b99">
             <a:alphaModFix/>
           </a:blip>
           <a:srcRect xmlns:a="http://schemas.openxmlformats.org/drawingml/2006/main" l="0" t="0" r="0" b="0"/>
@@ -17838,7 +17838,7 @@
           <p:nvPr/>
         </p:nvPicPr>
         <p:blipFill rotWithShape="1">
-          <a:blip xmlns:r="http://schemas.openxmlformats.org/officeDocument/2006/relationships" xmlns:a="http://schemas.openxmlformats.org/drawingml/2006/main" r:embed="R31e05aeda21d47ac">
+          <a:blip xmlns:r="http://schemas.openxmlformats.org/officeDocument/2006/relationships" xmlns:a="http://schemas.openxmlformats.org/drawingml/2006/main" r:embed="R61044bd001aa4b99">
             <a:alphaModFix/>
           </a:blip>
           <a:srcRect xmlns:a="http://schemas.openxmlformats.org/drawingml/2006/main" l="0" t="0" r="0" b="0"/>
@@ -17866,7 +17866,7 @@
           <p:nvPr/>
         </p:nvPicPr>
         <p:blipFill>
-          <a:blip xmlns:r="http://schemas.openxmlformats.org/officeDocument/2006/relationships" xmlns:a="http://schemas.openxmlformats.org/drawingml/2006/main" r:embed="R605570cb62394900">
+          <a:blip xmlns:r="http://schemas.openxmlformats.org/officeDocument/2006/relationships" xmlns:a="http://schemas.openxmlformats.org/drawingml/2006/main" r:embed="R9be07841e3e646be">
             <a:alphaModFix/>
           </a:blip>
           <a:stretch xmlns:a="http://schemas.openxmlformats.org/drawingml/2006/main">
@@ -18118,7 +18118,7 @@
           <p:nvPr/>
         </p:nvPicPr>
         <p:blipFill rotWithShape="1">
-          <a:blip xmlns:r="http://schemas.openxmlformats.org/officeDocument/2006/relationships" xmlns:a="http://schemas.openxmlformats.org/drawingml/2006/main" r:embed="R4ea9eb275a934048">
+          <a:blip xmlns:r="http://schemas.openxmlformats.org/officeDocument/2006/relationships" xmlns:a="http://schemas.openxmlformats.org/drawingml/2006/main" r:embed="Ra2f865a2f7bf4dc3">
             <a:alphaModFix/>
           </a:blip>
           <a:srcRect xmlns:a="http://schemas.openxmlformats.org/drawingml/2006/main" l="0" t="0" r="0" b="0"/>
@@ -18467,7 +18467,7 @@
           <p:nvPr/>
         </p:nvPicPr>
         <p:blipFill rotWithShape="1">
-          <a:blip xmlns:r="http://schemas.openxmlformats.org/officeDocument/2006/relationships" xmlns:a="http://schemas.openxmlformats.org/drawingml/2006/main" r:embed="Rdc861fe0eb764858">
+          <a:blip xmlns:r="http://schemas.openxmlformats.org/officeDocument/2006/relationships" xmlns:a="http://schemas.openxmlformats.org/drawingml/2006/main" r:embed="Ref18d61de1e84801">
             <a:alphaModFix/>
           </a:blip>
           <a:srcRect xmlns:a="http://schemas.openxmlformats.org/drawingml/2006/main" l="0" t="0" r="0" b="0"/>
@@ -18495,7 +18495,7 @@
           <p:nvPr/>
         </p:nvPicPr>
         <p:blipFill rotWithShape="1">
-          <a:blip xmlns:r="http://schemas.openxmlformats.org/officeDocument/2006/relationships" xmlns:a="http://schemas.openxmlformats.org/drawingml/2006/main" r:embed="Rdc861fe0eb764858">
+          <a:blip xmlns:r="http://schemas.openxmlformats.org/officeDocument/2006/relationships" xmlns:a="http://schemas.openxmlformats.org/drawingml/2006/main" r:embed="Ref18d61de1e84801">
             <a:alphaModFix/>
           </a:blip>
           <a:srcRect xmlns:a="http://schemas.openxmlformats.org/drawingml/2006/main" l="0" t="0" r="0" b="0"/>
@@ -18523,7 +18523,7 @@
           <p:nvPr/>
         </p:nvPicPr>
         <p:blipFill rotWithShape="1">
-          <a:blip xmlns:r="http://schemas.openxmlformats.org/officeDocument/2006/relationships" xmlns:a="http://schemas.openxmlformats.org/drawingml/2006/main" r:embed="Rdc861fe0eb764858">
+          <a:blip xmlns:r="http://schemas.openxmlformats.org/officeDocument/2006/relationships" xmlns:a="http://schemas.openxmlformats.org/drawingml/2006/main" r:embed="Ref18d61de1e84801">
             <a:alphaModFix/>
           </a:blip>
           <a:srcRect xmlns:a="http://schemas.openxmlformats.org/drawingml/2006/main" l="0" t="0" r="0" b="0"/>
@@ -18551,7 +18551,7 @@
           <p:nvPr/>
         </p:nvPicPr>
         <p:blipFill rotWithShape="1">
-          <a:blip xmlns:r="http://schemas.openxmlformats.org/officeDocument/2006/relationships" xmlns:a="http://schemas.openxmlformats.org/drawingml/2006/main" r:embed="Rdc861fe0eb764858">
+          <a:blip xmlns:r="http://schemas.openxmlformats.org/officeDocument/2006/relationships" xmlns:a="http://schemas.openxmlformats.org/drawingml/2006/main" r:embed="Ref18d61de1e84801">
             <a:alphaModFix/>
           </a:blip>
           <a:srcRect xmlns:a="http://schemas.openxmlformats.org/drawingml/2006/main" l="0" t="0" r="0" b="0"/>
@@ -18638,7 +18638,7 @@
           <p:nvPr/>
         </p:nvPicPr>
         <p:blipFill>
-          <a:blip xmlns:r="http://schemas.openxmlformats.org/officeDocument/2006/relationships" xmlns:a="http://schemas.openxmlformats.org/drawingml/2006/main" r:embed="R07ff25f021ac4a6a">
+          <a:blip xmlns:r="http://schemas.openxmlformats.org/officeDocument/2006/relationships" xmlns:a="http://schemas.openxmlformats.org/drawingml/2006/main" r:embed="R24a67a9875d14d26">
             <a:alphaModFix/>
           </a:blip>
           <a:stretch xmlns:a="http://schemas.openxmlformats.org/drawingml/2006/main">
@@ -18696,7 +18696,7 @@
           <p:nvPr/>
         </p:nvPicPr>
         <p:blipFill rotWithShape="1">
-          <a:blip xmlns:r="http://schemas.openxmlformats.org/officeDocument/2006/relationships" xmlns:a="http://schemas.openxmlformats.org/drawingml/2006/main" r:embed="R44cfe7fdc28f4908">
+          <a:blip xmlns:r="http://schemas.openxmlformats.org/officeDocument/2006/relationships" xmlns:a="http://schemas.openxmlformats.org/drawingml/2006/main" r:embed="R0d57c4d5d189429d">
             <a:alphaModFix/>
           </a:blip>
           <a:srcRect xmlns:a="http://schemas.openxmlformats.org/drawingml/2006/main" l="0" t="0" r="0" b="0"/>
@@ -19141,7 +19141,7 @@
           <p:nvPr/>
         </p:nvPicPr>
         <p:blipFill rotWithShape="1">
-          <a:blip xmlns:r="http://schemas.openxmlformats.org/officeDocument/2006/relationships" xmlns:a="http://schemas.openxmlformats.org/drawingml/2006/main" r:embed="Rcd8691fa42bd4eaa">
+          <a:blip xmlns:r="http://schemas.openxmlformats.org/officeDocument/2006/relationships" xmlns:a="http://schemas.openxmlformats.org/drawingml/2006/main" r:embed="R372f995b96da4d19">
             <a:alphaModFix/>
           </a:blip>
           <a:srcRect xmlns:a="http://schemas.openxmlformats.org/drawingml/2006/main" l="0" t="0" r="0" b="0"/>
@@ -19169,7 +19169,7 @@
           <p:nvPr/>
         </p:nvPicPr>
         <p:blipFill rotWithShape="1">
-          <a:blip xmlns:r="http://schemas.openxmlformats.org/officeDocument/2006/relationships" xmlns:a="http://schemas.openxmlformats.org/drawingml/2006/main" r:embed="Rcd8691fa42bd4eaa">
+          <a:blip xmlns:r="http://schemas.openxmlformats.org/officeDocument/2006/relationships" xmlns:a="http://schemas.openxmlformats.org/drawingml/2006/main" r:embed="R372f995b96da4d19">
             <a:alphaModFix/>
           </a:blip>
           <a:srcRect xmlns:a="http://schemas.openxmlformats.org/drawingml/2006/main" l="0" t="0" r="0" b="0"/>
@@ -19197,7 +19197,7 @@
           <p:nvPr/>
         </p:nvPicPr>
         <p:blipFill rotWithShape="1">
-          <a:blip xmlns:r="http://schemas.openxmlformats.org/officeDocument/2006/relationships" xmlns:a="http://schemas.openxmlformats.org/drawingml/2006/main" r:embed="Rcd8691fa42bd4eaa">
+          <a:blip xmlns:r="http://schemas.openxmlformats.org/officeDocument/2006/relationships" xmlns:a="http://schemas.openxmlformats.org/drawingml/2006/main" r:embed="R372f995b96da4d19">
             <a:alphaModFix/>
           </a:blip>
           <a:srcRect xmlns:a="http://schemas.openxmlformats.org/drawingml/2006/main" l="0" t="0" r="0" b="0"/>
@@ -19225,7 +19225,7 @@
           <p:nvPr/>
         </p:nvPicPr>
         <p:blipFill rotWithShape="1">
-          <a:blip xmlns:r="http://schemas.openxmlformats.org/officeDocument/2006/relationships" xmlns:a="http://schemas.openxmlformats.org/drawingml/2006/main" r:embed="Rcd8691fa42bd4eaa">
+          <a:blip xmlns:r="http://schemas.openxmlformats.org/officeDocument/2006/relationships" xmlns:a="http://schemas.openxmlformats.org/drawingml/2006/main" r:embed="R372f995b96da4d19">
             <a:alphaModFix/>
           </a:blip>
           <a:srcRect xmlns:a="http://schemas.openxmlformats.org/drawingml/2006/main" l="0" t="0" r="0" b="0"/>
@@ -19312,7 +19312,7 @@
           <p:nvPr/>
         </p:nvPicPr>
         <p:blipFill>
-          <a:blip xmlns:r="http://schemas.openxmlformats.org/officeDocument/2006/relationships" xmlns:a="http://schemas.openxmlformats.org/drawingml/2006/main" r:embed="R09e713ab8a1c4fb2">
+          <a:blip xmlns:r="http://schemas.openxmlformats.org/officeDocument/2006/relationships" xmlns:a="http://schemas.openxmlformats.org/drawingml/2006/main" r:embed="R693312c0bc144a44">
             <a:alphaModFix/>
           </a:blip>
           <a:stretch xmlns:a="http://schemas.openxmlformats.org/drawingml/2006/main">
@@ -19370,7 +19370,7 @@
           <p:nvPr/>
         </p:nvPicPr>
         <p:blipFill rotWithShape="1">
-          <a:blip xmlns:r="http://schemas.openxmlformats.org/officeDocument/2006/relationships" xmlns:a="http://schemas.openxmlformats.org/drawingml/2006/main" r:embed="R5468a54c889047dd">
+          <a:blip xmlns:r="http://schemas.openxmlformats.org/officeDocument/2006/relationships" xmlns:a="http://schemas.openxmlformats.org/drawingml/2006/main" r:embed="Ra4c1ebea94bf4212">
             <a:alphaModFix/>
           </a:blip>
           <a:srcRect xmlns:a="http://schemas.openxmlformats.org/drawingml/2006/main" l="0" t="0" r="0" b="0"/>
@@ -19604,7 +19604,7 @@
           <p:nvPr/>
         </p:nvPicPr>
         <p:blipFill rotWithShape="1">
-          <a:blip xmlns:r="http://schemas.openxmlformats.org/officeDocument/2006/relationships" xmlns:a="http://schemas.openxmlformats.org/drawingml/2006/main" r:embed="R8aef4a5954164f07">
+          <a:blip xmlns:r="http://schemas.openxmlformats.org/officeDocument/2006/relationships" xmlns:a="http://schemas.openxmlformats.org/drawingml/2006/main" r:embed="Rb722e5db2e9c41e5">
             <a:alphaModFix/>
           </a:blip>
           <a:srcRect xmlns:a="http://schemas.openxmlformats.org/drawingml/2006/main" l="0" t="0" r="0" b="0"/>
@@ -20133,7 +20133,7 @@
           <p:nvPr/>
         </p:nvPicPr>
         <p:blipFill rotWithShape="1">
-          <a:blip xmlns:r="http://schemas.openxmlformats.org/officeDocument/2006/relationships" xmlns:a="http://schemas.openxmlformats.org/drawingml/2006/main" r:embed="R8f6655d649714aea">
+          <a:blip xmlns:r="http://schemas.openxmlformats.org/officeDocument/2006/relationships" xmlns:a="http://schemas.openxmlformats.org/drawingml/2006/main" r:embed="R20ece13723e94be0">
             <a:alphaModFix/>
           </a:blip>
           <a:srcRect xmlns:a="http://schemas.openxmlformats.org/drawingml/2006/main" l="0" t="0" r="0" b="0"/>
@@ -20161,7 +20161,7 @@
           <p:nvPr/>
         </p:nvPicPr>
         <p:blipFill rotWithShape="1">
-          <a:blip xmlns:r="http://schemas.openxmlformats.org/officeDocument/2006/relationships" xmlns:a="http://schemas.openxmlformats.org/drawingml/2006/main" r:embed="R8f6655d649714aea">
+          <a:blip xmlns:r="http://schemas.openxmlformats.org/officeDocument/2006/relationships" xmlns:a="http://schemas.openxmlformats.org/drawingml/2006/main" r:embed="R20ece13723e94be0">
             <a:alphaModFix/>
           </a:blip>
           <a:srcRect xmlns:a="http://schemas.openxmlformats.org/drawingml/2006/main" l="0" t="0" r="0" b="0"/>
@@ -20189,7 +20189,7 @@
           <p:nvPr/>
         </p:nvPicPr>
         <p:blipFill rotWithShape="1">
-          <a:blip xmlns:r="http://schemas.openxmlformats.org/officeDocument/2006/relationships" xmlns:a="http://schemas.openxmlformats.org/drawingml/2006/main" r:embed="R8f6655d649714aea">
+          <a:blip xmlns:r="http://schemas.openxmlformats.org/officeDocument/2006/relationships" xmlns:a="http://schemas.openxmlformats.org/drawingml/2006/main" r:embed="R20ece13723e94be0">
             <a:alphaModFix/>
           </a:blip>
           <a:srcRect xmlns:a="http://schemas.openxmlformats.org/drawingml/2006/main" l="0" t="0" r="0" b="0"/>
@@ -20217,7 +20217,7 @@
           <p:nvPr/>
         </p:nvPicPr>
         <p:blipFill rotWithShape="1">
-          <a:blip xmlns:r="http://schemas.openxmlformats.org/officeDocument/2006/relationships" xmlns:a="http://schemas.openxmlformats.org/drawingml/2006/main" r:embed="R8f6655d649714aea">
+          <a:blip xmlns:r="http://schemas.openxmlformats.org/officeDocument/2006/relationships" xmlns:a="http://schemas.openxmlformats.org/drawingml/2006/main" r:embed="R20ece13723e94be0">
             <a:alphaModFix/>
           </a:blip>
           <a:srcRect xmlns:a="http://schemas.openxmlformats.org/drawingml/2006/main" l="0" t="0" r="0" b="0"/>
@@ -20304,7 +20304,7 @@
           <p:nvPr/>
         </p:nvPicPr>
         <p:blipFill>
-          <a:blip xmlns:r="http://schemas.openxmlformats.org/officeDocument/2006/relationships" xmlns:a="http://schemas.openxmlformats.org/drawingml/2006/main" r:embed="Ra8ec5c6cb0f548f3">
+          <a:blip xmlns:r="http://schemas.openxmlformats.org/officeDocument/2006/relationships" xmlns:a="http://schemas.openxmlformats.org/drawingml/2006/main" r:embed="R809f72ff51f74c99">
             <a:alphaModFix/>
           </a:blip>
           <a:stretch xmlns:a="http://schemas.openxmlformats.org/drawingml/2006/main">
@@ -21958,7 +21958,7 @@
           <p:nvPr/>
         </p:nvPicPr>
         <p:blipFill rotWithShape="1">
-          <a:blip xmlns:r="http://schemas.openxmlformats.org/officeDocument/2006/relationships" xmlns:a="http://schemas.openxmlformats.org/drawingml/2006/main" r:embed="R8a13ed17ffa04990">
+          <a:blip xmlns:r="http://schemas.openxmlformats.org/officeDocument/2006/relationships" xmlns:a="http://schemas.openxmlformats.org/drawingml/2006/main" r:embed="R37dbebf0ac864c24">
             <a:alphaModFix/>
           </a:blip>
           <a:srcRect xmlns:a="http://schemas.openxmlformats.org/drawingml/2006/main" l="0" t="0" r="0" b="0"/>
@@ -22240,7 +22240,7 @@
           <p:nvPr/>
         </p:nvPicPr>
         <p:blipFill rotWithShape="1">
-          <a:blip xmlns:r="http://schemas.openxmlformats.org/officeDocument/2006/relationships" xmlns:a="http://schemas.openxmlformats.org/drawingml/2006/main" r:embed="Rca6e3eb5886a48f1">
+          <a:blip xmlns:r="http://schemas.openxmlformats.org/officeDocument/2006/relationships" xmlns:a="http://schemas.openxmlformats.org/drawingml/2006/main" r:embed="Rf40af90b96894245">
             <a:alphaModFix/>
           </a:blip>
           <a:srcRect xmlns:a="http://schemas.openxmlformats.org/drawingml/2006/main" l="0" t="0" r="0" b="0"/>
@@ -22423,7 +22423,7 @@
                 <a:latin typeface="Manrope"/>
                 <a:ea typeface="Manrope"/>
                 <a:cs typeface="Manrope"/>
-                <a:hlinkClick xmlns:r="http://schemas.openxmlformats.org/officeDocument/2006/relationships" r:id="R6f7fa9940ee545b9"/>
+                <a:hlinkClick xmlns:r="http://schemas.openxmlformats.org/officeDocument/2006/relationships" r:id="Rdf1a0005d6294006"/>
               </a:rPr>
               <a:t>https</a:t>
             </a:r>
@@ -22435,7 +22435,7 @@
                 <a:latin typeface="Manrope"/>
                 <a:ea typeface="Manrope"/>
                 <a:cs typeface="Manrope"/>
-                <a:hlinkClick xmlns:r="http://schemas.openxmlformats.org/officeDocument/2006/relationships" r:id="R510aef5d80de4447"/>
+                <a:hlinkClick xmlns:r="http://schemas.openxmlformats.org/officeDocument/2006/relationships" r:id="R7e38b34db1da48ac"/>
               </a:rPr>
               <a:t>://www.theweathernetwork.com/en/news/weather/severe/how-the-30-30-30-rule-is-essential-for-wildfire-safety</a:t>
             </a:r>
@@ -22466,7 +22466,7 @@
                 <a:latin typeface="Manrope"/>
                 <a:ea typeface="Manrope"/>
                 <a:cs typeface="Manrope"/>
-                <a:hlinkClick xmlns:r="http://schemas.openxmlformats.org/officeDocument/2006/relationships" r:id="R7231d723cc384534"/>
+                <a:hlinkClick xmlns:r="http://schemas.openxmlformats.org/officeDocument/2006/relationships" r:id="R70c353bcdbef4f92"/>
               </a:rPr>
               <a:t>https://www.weather.gov/safety/wildfire-ww</a:t>
             </a:r>
@@ -22497,7 +22497,7 @@
                 <a:latin typeface="Manrope"/>
                 <a:ea typeface="Manrope"/>
                 <a:cs typeface="Manrope"/>
-                <a:hlinkClick xmlns:r="http://schemas.openxmlformats.org/officeDocument/2006/relationships" r:id="Rf5a037fed0e64f61"/>
+                <a:hlinkClick xmlns:r="http://schemas.openxmlformats.org/officeDocument/2006/relationships" r:id="R74937584e9ab455d"/>
               </a:rPr>
               <a:t>https://www.weather.gov/fire/</a:t>
             </a:r>
@@ -22528,7 +22528,7 @@
                 <a:latin typeface="Manrope"/>
                 <a:ea typeface="Manrope"/>
                 <a:cs typeface="Manrope"/>
-                <a:hlinkClick xmlns:r="http://schemas.openxmlformats.org/officeDocument/2006/relationships" r:id="Rc40b052cbe52490b"/>
+                <a:hlinkClick xmlns:r="http://schemas.openxmlformats.org/officeDocument/2006/relationships" r:id="R54c2a4bdf0d04084"/>
               </a:rPr>
               <a:t>https://firms.modaps.eosdis.nasa.gov/</a:t>
             </a:r>
@@ -22559,7 +22559,7 @@
                 <a:latin typeface="Manrope"/>
                 <a:ea typeface="Manrope"/>
                 <a:cs typeface="Manrope"/>
-                <a:hlinkClick xmlns:r="http://schemas.openxmlformats.org/officeDocument/2006/relationships" r:id="Rc2bf7064ed6d4101"/>
+                <a:hlinkClick xmlns:r="http://schemas.openxmlformats.org/officeDocument/2006/relationships" r:id="R5eb5fbcbc13f45bf"/>
               </a:rPr>
               <a:t>https://archive.ics.uci.edu/dataset/162/forest+fires</a:t>
             </a:r>
@@ -22590,7 +22590,7 @@
                 <a:latin typeface="Manrope"/>
                 <a:ea typeface="Manrope"/>
                 <a:cs typeface="Manrope"/>
-                <a:hlinkClick xmlns:r="http://schemas.openxmlformats.org/officeDocument/2006/relationships" r:id="Rbcc41795f8c044cd"/>
+                <a:hlinkClick xmlns:r="http://schemas.openxmlformats.org/officeDocument/2006/relationships" r:id="Rf13b30339c4f4930"/>
               </a:rPr>
               <a:t>https://www.kaggle.com/datasets/pankrzysiu/weather-archive-jena</a:t>
             </a:r>
@@ -22621,7 +22621,7 @@
                 <a:latin typeface="Manrope"/>
                 <a:ea typeface="Manrope"/>
                 <a:cs typeface="Manrope"/>
-                <a:hlinkClick xmlns:r="http://schemas.openxmlformats.org/officeDocument/2006/relationships" r:id="Recbc8cf12d7f416b"/>
+                <a:hlinkClick xmlns:r="http://schemas.openxmlformats.org/officeDocument/2006/relationships" r:id="R7cbed1ee7df74f68"/>
               </a:rPr>
               <a:t>https://www.w3schools.com/python/</a:t>
             </a:r>
@@ -22694,7 +22694,7 @@
           <p:nvPr/>
         </p:nvPicPr>
         <p:blipFill rotWithShape="1">
-          <a:blip xmlns:r="http://schemas.openxmlformats.org/officeDocument/2006/relationships" xmlns:a="http://schemas.openxmlformats.org/drawingml/2006/main" r:embed="R510997d2b952467e">
+          <a:blip xmlns:r="http://schemas.openxmlformats.org/officeDocument/2006/relationships" xmlns:a="http://schemas.openxmlformats.org/drawingml/2006/main" r:embed="R5d89b4cc29104e68">
             <a:alphaModFix/>
           </a:blip>
           <a:srcRect xmlns:a="http://schemas.openxmlformats.org/drawingml/2006/main" l="0" t="0" r="0" b="0"/>
@@ -22722,7 +22722,7 @@
           <p:nvPr/>
         </p:nvPicPr>
         <p:blipFill rotWithShape="1">
-          <a:blip xmlns:r="http://schemas.openxmlformats.org/officeDocument/2006/relationships" xmlns:a="http://schemas.openxmlformats.org/drawingml/2006/main" r:embed="R7c655255e17d4a46">
+          <a:blip xmlns:r="http://schemas.openxmlformats.org/officeDocument/2006/relationships" xmlns:a="http://schemas.openxmlformats.org/drawingml/2006/main" r:embed="Rde8f70e4603c487c">
             <a:alphaModFix/>
           </a:blip>
           <a:srcRect xmlns:a="http://schemas.openxmlformats.org/drawingml/2006/main" l="0" t="0" r="0" b="0"/>
@@ -22750,7 +22750,7 @@
           <p:nvPr/>
         </p:nvPicPr>
         <p:blipFill rotWithShape="1">
-          <a:blip xmlns:r="http://schemas.openxmlformats.org/officeDocument/2006/relationships" xmlns:a="http://schemas.openxmlformats.org/drawingml/2006/main" r:embed="Rff37683d97884ea9">
+          <a:blip xmlns:r="http://schemas.openxmlformats.org/officeDocument/2006/relationships" xmlns:a="http://schemas.openxmlformats.org/drawingml/2006/main" r:embed="R1fb71c1a8fe9438b">
             <a:alphaModFix/>
           </a:blip>
           <a:srcRect xmlns:a="http://schemas.openxmlformats.org/drawingml/2006/main" l="0" t="0" r="0" b="0"/>
@@ -22778,7 +22778,7 @@
           <p:nvPr/>
         </p:nvPicPr>
         <p:blipFill rotWithShape="1">
-          <a:blip xmlns:r="http://schemas.openxmlformats.org/officeDocument/2006/relationships" xmlns:a="http://schemas.openxmlformats.org/drawingml/2006/main" r:embed="Ra8cac8dc4cef4f17">
+          <a:blip xmlns:r="http://schemas.openxmlformats.org/officeDocument/2006/relationships" xmlns:a="http://schemas.openxmlformats.org/drawingml/2006/main" r:embed="R375cca847cb644ed">
             <a:alphaModFix/>
           </a:blip>
           <a:srcRect xmlns:a="http://schemas.openxmlformats.org/drawingml/2006/main" l="0" t="0" r="0" b="0"/>
@@ -22806,7 +22806,7 @@
           <p:nvPr/>
         </p:nvPicPr>
         <p:blipFill rotWithShape="1">
-          <a:blip xmlns:r="http://schemas.openxmlformats.org/officeDocument/2006/relationships" xmlns:a="http://schemas.openxmlformats.org/drawingml/2006/main" r:embed="Rcddc9edce1ca4d89">
+          <a:blip xmlns:r="http://schemas.openxmlformats.org/officeDocument/2006/relationships" xmlns:a="http://schemas.openxmlformats.org/drawingml/2006/main" r:embed="R874274fbd0a84f0f">
             <a:alphaModFix/>
           </a:blip>
           <a:srcRect xmlns:a="http://schemas.openxmlformats.org/drawingml/2006/main" l="0" t="0" r="0" b="0"/>
@@ -22834,7 +22834,7 @@
           <p:nvPr/>
         </p:nvPicPr>
         <p:blipFill rotWithShape="1">
-          <a:blip xmlns:r="http://schemas.openxmlformats.org/officeDocument/2006/relationships" xmlns:a="http://schemas.openxmlformats.org/drawingml/2006/main" r:embed="Ra4ea2d247d084804">
+          <a:blip xmlns:r="http://schemas.openxmlformats.org/officeDocument/2006/relationships" xmlns:a="http://schemas.openxmlformats.org/drawingml/2006/main" r:embed="R1003b7cddaaa4950">
             <a:alphaModFix/>
           </a:blip>
           <a:srcRect xmlns:a="http://schemas.openxmlformats.org/drawingml/2006/main" l="0" t="0" r="0" b="0"/>
@@ -22862,7 +22862,7 @@
           <p:nvPr/>
         </p:nvPicPr>
         <p:blipFill rotWithShape="1">
-          <a:blip xmlns:r="http://schemas.openxmlformats.org/officeDocument/2006/relationships" xmlns:a="http://schemas.openxmlformats.org/drawingml/2006/main" r:embed="Rd7d5c5ad08ad4f61">
+          <a:blip xmlns:r="http://schemas.openxmlformats.org/officeDocument/2006/relationships" xmlns:a="http://schemas.openxmlformats.org/drawingml/2006/main" r:embed="R412eee62d76f443a">
             <a:alphaModFix/>
           </a:blip>
           <a:srcRect xmlns:a="http://schemas.openxmlformats.org/drawingml/2006/main" l="0" t="0" r="0" b="0"/>
@@ -22890,7 +22890,7 @@
           <p:nvPr/>
         </p:nvPicPr>
         <p:blipFill rotWithShape="1">
-          <a:blip xmlns:r="http://schemas.openxmlformats.org/officeDocument/2006/relationships" xmlns:a="http://schemas.openxmlformats.org/drawingml/2006/main" r:embed="Rdd1844092af5405d">
+          <a:blip xmlns:r="http://schemas.openxmlformats.org/officeDocument/2006/relationships" xmlns:a="http://schemas.openxmlformats.org/drawingml/2006/main" r:embed="R5e290dd646d14e00">
             <a:alphaModFix/>
           </a:blip>
           <a:srcRect xmlns:a="http://schemas.openxmlformats.org/drawingml/2006/main" l="0" t="0" r="0" b="0"/>
@@ -22918,7 +22918,7 @@
           <p:nvPr/>
         </p:nvPicPr>
         <p:blipFill rotWithShape="1">
-          <a:blip xmlns:r="http://schemas.openxmlformats.org/officeDocument/2006/relationships" xmlns:a="http://schemas.openxmlformats.org/drawingml/2006/main" r:embed="R7247be3592c8409f">
+          <a:blip xmlns:r="http://schemas.openxmlformats.org/officeDocument/2006/relationships" xmlns:a="http://schemas.openxmlformats.org/drawingml/2006/main" r:embed="R7447bd8deb8f4331">
             <a:alphaModFix/>
           </a:blip>
           <a:srcRect xmlns:a="http://schemas.openxmlformats.org/drawingml/2006/main" l="0" t="0" r="0" b="0"/>
@@ -23643,7 +23643,7 @@
           <p:nvPr/>
         </p:nvPicPr>
         <p:blipFill rotWithShape="1">
-          <a:blip xmlns:r="http://schemas.openxmlformats.org/officeDocument/2006/relationships" xmlns:a="http://schemas.openxmlformats.org/drawingml/2006/main" r:embed="R8f92c3c59f7044f6">
+          <a:blip xmlns:r="http://schemas.openxmlformats.org/officeDocument/2006/relationships" xmlns:a="http://schemas.openxmlformats.org/drawingml/2006/main" r:embed="Ra0826e3afe82420a">
             <a:alphaModFix/>
           </a:blip>
           <a:srcRect xmlns:a="http://schemas.openxmlformats.org/drawingml/2006/main" l="0" t="0" r="0" b="0"/>
@@ -23727,7 +23727,7 @@
           <p:nvPr/>
         </p:nvPicPr>
         <p:blipFill rotWithShape="1">
-          <a:blip xmlns:r="http://schemas.openxmlformats.org/officeDocument/2006/relationships" xmlns:a="http://schemas.openxmlformats.org/drawingml/2006/main" r:embed="R92323c5212034e0c">
+          <a:blip xmlns:r="http://schemas.openxmlformats.org/officeDocument/2006/relationships" xmlns:a="http://schemas.openxmlformats.org/drawingml/2006/main" r:embed="R94225df1c9404845">
             <a:alphaModFix/>
           </a:blip>
           <a:srcRect xmlns:a="http://schemas.openxmlformats.org/drawingml/2006/main" l="0" t="0" r="0" b="0"/>
@@ -23811,7 +23811,7 @@
           <p:nvPr/>
         </p:nvPicPr>
         <p:blipFill rotWithShape="1">
-          <a:blip xmlns:r="http://schemas.openxmlformats.org/officeDocument/2006/relationships" xmlns:a="http://schemas.openxmlformats.org/drawingml/2006/main" r:embed="Rdf8215c4570440c3">
+          <a:blip xmlns:r="http://schemas.openxmlformats.org/officeDocument/2006/relationships" xmlns:a="http://schemas.openxmlformats.org/drawingml/2006/main" r:embed="Rcb5a108584254e08">
             <a:alphaModFix/>
           </a:blip>
           <a:srcRect xmlns:a="http://schemas.openxmlformats.org/drawingml/2006/main" l="0" t="0" r="0" b="0"/>
@@ -23895,7 +23895,7 @@
           <p:nvPr/>
         </p:nvPicPr>
         <p:blipFill rotWithShape="1">
-          <a:blip xmlns:r="http://schemas.openxmlformats.org/officeDocument/2006/relationships" xmlns:a="http://schemas.openxmlformats.org/drawingml/2006/main" r:embed="Rcb423dc2c1af4f29">
+          <a:blip xmlns:r="http://schemas.openxmlformats.org/officeDocument/2006/relationships" xmlns:a="http://schemas.openxmlformats.org/drawingml/2006/main" r:embed="R55aba92deb9a45ff">
             <a:alphaModFix/>
           </a:blip>
           <a:srcRect xmlns:a="http://schemas.openxmlformats.org/drawingml/2006/main" l="0" t="0" r="0" b="0"/>
@@ -23979,7 +23979,7 @@
           <p:nvPr/>
         </p:nvPicPr>
         <p:blipFill rotWithShape="1">
-          <a:blip xmlns:r="http://schemas.openxmlformats.org/officeDocument/2006/relationships" xmlns:a="http://schemas.openxmlformats.org/drawingml/2006/main" r:embed="Rfbbb9b22e8624d5d">
+          <a:blip xmlns:r="http://schemas.openxmlformats.org/officeDocument/2006/relationships" xmlns:a="http://schemas.openxmlformats.org/drawingml/2006/main" r:embed="R219fa6f5bdc44a58">
             <a:alphaModFix/>
           </a:blip>
           <a:srcRect xmlns:a="http://schemas.openxmlformats.org/drawingml/2006/main" l="0" t="0" r="0" b="0"/>
@@ -24063,7 +24063,7 @@
           <p:nvPr/>
         </p:nvPicPr>
         <p:blipFill rotWithShape="1">
-          <a:blip xmlns:r="http://schemas.openxmlformats.org/officeDocument/2006/relationships" xmlns:a="http://schemas.openxmlformats.org/drawingml/2006/main" r:embed="R95561ffa9bf743e9">
+          <a:blip xmlns:r="http://schemas.openxmlformats.org/officeDocument/2006/relationships" xmlns:a="http://schemas.openxmlformats.org/drawingml/2006/main" r:embed="R62eef5ecf8064fa8">
             <a:alphaModFix/>
           </a:blip>
           <a:srcRect xmlns:a="http://schemas.openxmlformats.org/drawingml/2006/main" l="0" t="0" r="0" b="0"/>
@@ -24147,7 +24147,7 @@
           <p:nvPr/>
         </p:nvPicPr>
         <p:blipFill rotWithShape="1">
-          <a:blip xmlns:r="http://schemas.openxmlformats.org/officeDocument/2006/relationships" xmlns:a="http://schemas.openxmlformats.org/drawingml/2006/main" r:embed="Rdee4d3d987c84a28">
+          <a:blip xmlns:r="http://schemas.openxmlformats.org/officeDocument/2006/relationships" xmlns:a="http://schemas.openxmlformats.org/drawingml/2006/main" r:embed="R41a87a90678443f0">
             <a:alphaModFix/>
           </a:blip>
           <a:srcRect xmlns:a="http://schemas.openxmlformats.org/drawingml/2006/main" l="0" t="0" r="0" b="0"/>
@@ -24231,7 +24231,7 @@
           <p:nvPr/>
         </p:nvPicPr>
         <p:blipFill rotWithShape="1">
-          <a:blip xmlns:r="http://schemas.openxmlformats.org/officeDocument/2006/relationships" xmlns:a="http://schemas.openxmlformats.org/drawingml/2006/main" r:embed="Rc1ee1b60a751421c">
+          <a:blip xmlns:r="http://schemas.openxmlformats.org/officeDocument/2006/relationships" xmlns:a="http://schemas.openxmlformats.org/drawingml/2006/main" r:embed="R757b21ad331848b8">
             <a:alphaModFix/>
           </a:blip>
           <a:srcRect xmlns:a="http://schemas.openxmlformats.org/drawingml/2006/main" l="0" t="0" r="0" b="0"/>
@@ -24315,7 +24315,7 @@
           <p:nvPr/>
         </p:nvPicPr>
         <p:blipFill rotWithShape="1">
-          <a:blip xmlns:r="http://schemas.openxmlformats.org/officeDocument/2006/relationships" xmlns:a="http://schemas.openxmlformats.org/drawingml/2006/main" r:embed="R6d78ec46c2f34a74">
+          <a:blip xmlns:r="http://schemas.openxmlformats.org/officeDocument/2006/relationships" xmlns:a="http://schemas.openxmlformats.org/drawingml/2006/main" r:embed="Rc3cbdc15c1ce4302">
             <a:alphaModFix/>
           </a:blip>
           <a:srcRect xmlns:a="http://schemas.openxmlformats.org/drawingml/2006/main" l="0" t="0" r="0" b="0"/>
@@ -24534,7 +24534,7 @@
           <p:nvPr/>
         </p:nvPicPr>
         <p:blipFill rotWithShape="1">
-          <a:blip xmlns:r="http://schemas.openxmlformats.org/officeDocument/2006/relationships" xmlns:a="http://schemas.openxmlformats.org/drawingml/2006/main" r:embed="R658d66edcde34dc8">
+          <a:blip xmlns:r="http://schemas.openxmlformats.org/officeDocument/2006/relationships" xmlns:a="http://schemas.openxmlformats.org/drawingml/2006/main" r:embed="R7c50bd3432cf4f32">
             <a:alphaModFix/>
           </a:blip>
           <a:srcRect xmlns:a="http://schemas.openxmlformats.org/drawingml/2006/main" l="0" t="0" r="0" b="0"/>
@@ -24562,7 +24562,7 @@
           <p:nvPr/>
         </p:nvPicPr>
         <p:blipFill rotWithShape="1">
-          <a:blip xmlns:r="http://schemas.openxmlformats.org/officeDocument/2006/relationships" xmlns:a="http://schemas.openxmlformats.org/drawingml/2006/main" r:embed="R430e30128062412a">
+          <a:blip xmlns:r="http://schemas.openxmlformats.org/officeDocument/2006/relationships" xmlns:a="http://schemas.openxmlformats.org/drawingml/2006/main" r:embed="R427209be68a84458">
             <a:alphaModFix/>
           </a:blip>
           <a:srcRect xmlns:a="http://schemas.openxmlformats.org/drawingml/2006/main" l="0" t="0" r="0" b="0"/>
@@ -24705,7 +24705,7 @@
           <p:nvPr/>
         </p:nvPicPr>
         <p:blipFill rotWithShape="1">
-          <a:blip xmlns:r="http://schemas.openxmlformats.org/officeDocument/2006/relationships" xmlns:a="http://schemas.openxmlformats.org/drawingml/2006/main" r:embed="R6da47711112645a4">
+          <a:blip xmlns:r="http://schemas.openxmlformats.org/officeDocument/2006/relationships" xmlns:a="http://schemas.openxmlformats.org/drawingml/2006/main" r:embed="R51795c51b86c4af5">
             <a:alphaModFix/>
           </a:blip>
           <a:srcRect xmlns:a="http://schemas.openxmlformats.org/drawingml/2006/main" l="0" t="0" r="0" b="0"/>
@@ -24943,7 +24943,7 @@
           <p:nvPr/>
         </p:nvPicPr>
         <p:blipFill rotWithShape="1">
-          <a:blip xmlns:r="http://schemas.openxmlformats.org/officeDocument/2006/relationships" xmlns:a="http://schemas.openxmlformats.org/drawingml/2006/main" r:embed="R13b31c0a157443c6">
+          <a:blip xmlns:r="http://schemas.openxmlformats.org/officeDocument/2006/relationships" xmlns:a="http://schemas.openxmlformats.org/drawingml/2006/main" r:embed="R85db763b017e493c">
             <a:alphaModFix/>
           </a:blip>
           <a:srcRect xmlns:a="http://schemas.openxmlformats.org/drawingml/2006/main" l="0" t="0" r="0" b="0"/>
@@ -24971,7 +24971,7 @@
           <p:nvPr/>
         </p:nvPicPr>
         <p:blipFill rotWithShape="1">
-          <a:blip xmlns:r="http://schemas.openxmlformats.org/officeDocument/2006/relationships" xmlns:a="http://schemas.openxmlformats.org/drawingml/2006/main" r:embed="R84b70dac80df4cf1">
+          <a:blip xmlns:r="http://schemas.openxmlformats.org/officeDocument/2006/relationships" xmlns:a="http://schemas.openxmlformats.org/drawingml/2006/main" r:embed="R60347da0903f46bf">
             <a:alphaModFix/>
           </a:blip>
           <a:srcRect xmlns:a="http://schemas.openxmlformats.org/drawingml/2006/main" l="0" t="0" r="0" b="0"/>
@@ -24999,7 +24999,7 @@
           <p:nvPr/>
         </p:nvPicPr>
         <p:blipFill rotWithShape="1">
-          <a:blip xmlns:r="http://schemas.openxmlformats.org/officeDocument/2006/relationships" xmlns:a="http://schemas.openxmlformats.org/drawingml/2006/main" r:embed="Re562e0e642394370">
+          <a:blip xmlns:r="http://schemas.openxmlformats.org/officeDocument/2006/relationships" xmlns:a="http://schemas.openxmlformats.org/drawingml/2006/main" r:embed="R28cb6b8744ba4a98">
             <a:alphaModFix/>
           </a:blip>
           <a:srcRect xmlns:a="http://schemas.openxmlformats.org/drawingml/2006/main" l="0" t="0" r="0" b="0"/>
@@ -25162,7 +25162,7 @@
           <p:nvPr/>
         </p:nvPicPr>
         <p:blipFill rotWithShape="1">
-          <a:blip xmlns:r="http://schemas.openxmlformats.org/officeDocument/2006/relationships" xmlns:a="http://schemas.openxmlformats.org/drawingml/2006/main" r:embed="R25d3464de6bc4e5c">
+          <a:blip xmlns:r="http://schemas.openxmlformats.org/officeDocument/2006/relationships" xmlns:a="http://schemas.openxmlformats.org/drawingml/2006/main" r:embed="R798e920fb9094456">
             <a:alphaModFix/>
           </a:blip>
           <a:srcRect xmlns:a="http://schemas.openxmlformats.org/drawingml/2006/main" l="0" t="0" r="0" b="0"/>
@@ -25190,7 +25190,7 @@
           <p:nvPr/>
         </p:nvPicPr>
         <p:blipFill rotWithShape="1">
-          <a:blip xmlns:r="http://schemas.openxmlformats.org/officeDocument/2006/relationships" xmlns:a="http://schemas.openxmlformats.org/drawingml/2006/main" r:embed="R2b22a84d9daa4cbe">
+          <a:blip xmlns:r="http://schemas.openxmlformats.org/officeDocument/2006/relationships" xmlns:a="http://schemas.openxmlformats.org/drawingml/2006/main" r:embed="Rfdbed08e3845462e">
             <a:alphaModFix/>
           </a:blip>
           <a:srcRect xmlns:a="http://schemas.openxmlformats.org/drawingml/2006/main" l="0" t="0" r="0" b="0"/>
@@ -25218,7 +25218,7 @@
           <p:nvPr/>
         </p:nvPicPr>
         <p:blipFill rotWithShape="1">
-          <a:blip xmlns:r="http://schemas.openxmlformats.org/officeDocument/2006/relationships" xmlns:a="http://schemas.openxmlformats.org/drawingml/2006/main" r:embed="Ra5054b647df44c4c">
+          <a:blip xmlns:r="http://schemas.openxmlformats.org/officeDocument/2006/relationships" xmlns:a="http://schemas.openxmlformats.org/drawingml/2006/main" r:embed="R1a3e22fbf6c548de">
             <a:alphaModFix/>
           </a:blip>
           <a:srcRect xmlns:a="http://schemas.openxmlformats.org/drawingml/2006/main" l="0" t="0" r="0" b="0"/>
@@ -25246,7 +25246,7 @@
           <p:nvPr/>
         </p:nvPicPr>
         <p:blipFill rotWithShape="1">
-          <a:blip xmlns:r="http://schemas.openxmlformats.org/officeDocument/2006/relationships" xmlns:a="http://schemas.openxmlformats.org/drawingml/2006/main" r:embed="Rfb0d3706f6eb46ed">
+          <a:blip xmlns:r="http://schemas.openxmlformats.org/officeDocument/2006/relationships" xmlns:a="http://schemas.openxmlformats.org/drawingml/2006/main" r:embed="R548a3770c6d243e7">
             <a:alphaModFix/>
           </a:blip>
           <a:srcRect xmlns:a="http://schemas.openxmlformats.org/drawingml/2006/main" l="0" t="0" r="0" b="0"/>
@@ -25274,7 +25274,7 @@
           <p:nvPr/>
         </p:nvPicPr>
         <p:blipFill rotWithShape="1">
-          <a:blip xmlns:r="http://schemas.openxmlformats.org/officeDocument/2006/relationships" xmlns:a="http://schemas.openxmlformats.org/drawingml/2006/main" r:embed="R5ae83a888fc04766">
+          <a:blip xmlns:r="http://schemas.openxmlformats.org/officeDocument/2006/relationships" xmlns:a="http://schemas.openxmlformats.org/drawingml/2006/main" r:embed="Rbbdc09732d0f4d58">
             <a:alphaModFix/>
           </a:blip>
           <a:srcRect xmlns:a="http://schemas.openxmlformats.org/drawingml/2006/main" l="0" t="0" r="0" b="0"/>
@@ -25417,7 +25417,7 @@
           <p:nvPr/>
         </p:nvPicPr>
         <p:blipFill rotWithShape="1">
-          <a:blip xmlns:r="http://schemas.openxmlformats.org/officeDocument/2006/relationships" xmlns:a="http://schemas.openxmlformats.org/drawingml/2006/main" r:embed="R17218dd7f04f40d4">
+          <a:blip xmlns:r="http://schemas.openxmlformats.org/officeDocument/2006/relationships" xmlns:a="http://schemas.openxmlformats.org/drawingml/2006/main" r:embed="R219e0cea82b84330">
             <a:alphaModFix/>
           </a:blip>
           <a:srcRect xmlns:a="http://schemas.openxmlformats.org/drawingml/2006/main" l="0" t="0" r="0" b="0"/>
@@ -25560,7 +25560,7 @@
           <p:nvPr/>
         </p:nvPicPr>
         <p:blipFill rotWithShape="1">
-          <a:blip xmlns:r="http://schemas.openxmlformats.org/officeDocument/2006/relationships" xmlns:a="http://schemas.openxmlformats.org/drawingml/2006/main" r:embed="Rae32390195b94859">
+          <a:blip xmlns:r="http://schemas.openxmlformats.org/officeDocument/2006/relationships" xmlns:a="http://schemas.openxmlformats.org/drawingml/2006/main" r:embed="Rccc1de4301de4272">
             <a:alphaModFix/>
           </a:blip>
           <a:srcRect xmlns:a="http://schemas.openxmlformats.org/drawingml/2006/main" l="0" t="0" r="0" b="0"/>
@@ -25838,7 +25838,7 @@
           <p:nvPr/>
         </p:nvPicPr>
         <p:blipFill rotWithShape="1">
-          <a:blip xmlns:r="http://schemas.openxmlformats.org/officeDocument/2006/relationships" xmlns:a="http://schemas.openxmlformats.org/drawingml/2006/main" r:embed="R1dbdf1a2ac154d70">
+          <a:blip xmlns:r="http://schemas.openxmlformats.org/officeDocument/2006/relationships" xmlns:a="http://schemas.openxmlformats.org/drawingml/2006/main" r:embed="Rdb3f82386e1644df">
             <a:alphaModFix/>
           </a:blip>
           <a:srcRect xmlns:a="http://schemas.openxmlformats.org/drawingml/2006/main" l="0" t="0" r="0" b="0"/>
@@ -26691,7 +26691,7 @@
           <p:nvPr/>
         </p:nvPicPr>
         <p:blipFill rotWithShape="1">
-          <a:blip xmlns:r="http://schemas.openxmlformats.org/officeDocument/2006/relationships" xmlns:a="http://schemas.openxmlformats.org/drawingml/2006/main" r:embed="R64250a8360504aa7">
+          <a:blip xmlns:r="http://schemas.openxmlformats.org/officeDocument/2006/relationships" xmlns:a="http://schemas.openxmlformats.org/drawingml/2006/main" r:embed="Rc94d8f88677748d1">
             <a:alphaModFix/>
           </a:blip>
           <a:srcRect xmlns:a="http://schemas.openxmlformats.org/drawingml/2006/main" l="0" t="0" r="0" b="0"/>
@@ -26719,7 +26719,7 @@
           <p:nvPr/>
         </p:nvPicPr>
         <p:blipFill rotWithShape="1">
-          <a:blip xmlns:r="http://schemas.openxmlformats.org/officeDocument/2006/relationships" xmlns:a="http://schemas.openxmlformats.org/drawingml/2006/main" r:embed="R9b687a683614483a">
+          <a:blip xmlns:r="http://schemas.openxmlformats.org/officeDocument/2006/relationships" xmlns:a="http://schemas.openxmlformats.org/drawingml/2006/main" r:embed="R466e8f276e2846cf">
             <a:alphaModFix/>
           </a:blip>
           <a:srcRect xmlns:a="http://schemas.openxmlformats.org/drawingml/2006/main" l="0" t="0" r="0" b="0"/>
@@ -26747,7 +26747,7 @@
           <p:nvPr/>
         </p:nvPicPr>
         <p:blipFill rotWithShape="1">
-          <a:blip xmlns:r="http://schemas.openxmlformats.org/officeDocument/2006/relationships" xmlns:a="http://schemas.openxmlformats.org/drawingml/2006/main" r:embed="R9b687a683614483a">
+          <a:blip xmlns:r="http://schemas.openxmlformats.org/officeDocument/2006/relationships" xmlns:a="http://schemas.openxmlformats.org/drawingml/2006/main" r:embed="R466e8f276e2846cf">
             <a:alphaModFix/>
           </a:blip>
           <a:srcRect xmlns:a="http://schemas.openxmlformats.org/drawingml/2006/main" l="0" t="0" r="0" b="0"/>
@@ -26775,7 +26775,7 @@
           <p:nvPr/>
         </p:nvPicPr>
         <p:blipFill rotWithShape="1">
-          <a:blip xmlns:r="http://schemas.openxmlformats.org/officeDocument/2006/relationships" xmlns:a="http://schemas.openxmlformats.org/drawingml/2006/main" r:embed="R9b687a683614483a">
+          <a:blip xmlns:r="http://schemas.openxmlformats.org/officeDocument/2006/relationships" xmlns:a="http://schemas.openxmlformats.org/drawingml/2006/main" r:embed="R466e8f276e2846cf">
             <a:alphaModFix/>
           </a:blip>
           <a:srcRect xmlns:a="http://schemas.openxmlformats.org/drawingml/2006/main" l="0" t="0" r="0" b="0"/>
@@ -26803,7 +26803,7 @@
           <p:nvPr/>
         </p:nvPicPr>
         <p:blipFill rotWithShape="1">
-          <a:blip xmlns:r="http://schemas.openxmlformats.org/officeDocument/2006/relationships" xmlns:a="http://schemas.openxmlformats.org/drawingml/2006/main" r:embed="R9b687a683614483a">
+          <a:blip xmlns:r="http://schemas.openxmlformats.org/officeDocument/2006/relationships" xmlns:a="http://schemas.openxmlformats.org/drawingml/2006/main" r:embed="R466e8f276e2846cf">
             <a:alphaModFix/>
           </a:blip>
           <a:srcRect xmlns:a="http://schemas.openxmlformats.org/drawingml/2006/main" l="0" t="0" r="0" b="0"/>
@@ -26932,7 +26932,7 @@
                 <a:ea typeface="Manrope"/>
                 <a:cs typeface="Manrope"/>
               </a:rPr>
-              <a:t>How many hourly periods meet the 30/30 screening condition: T &gt;= 30°C and RH &lt;= 30%?</a:t>
+              <a:t>How many hourly periods meet the 30 C / 30% project screen?</a:t>
             </a:r>
           </a:p>
         </p:txBody>
@@ -27047,7 +27047,7 @@
                 <a:ea typeface="Manrope"/>
                 <a:cs typeface="Manrope"/>
               </a:rPr>
-              <a:t>Do rapid 3-hour pressure drops appear before the driest hourly windows?</a:t>
+              <a:t>Do rapid three-hour pressure drops appear before the driest hourly windows?</a:t>
             </a:r>
           </a:p>
         </p:txBody>
@@ -27162,7 +27162,7 @@
                 <a:ea typeface="Manrope"/>
                 <a:cs typeface="Manrope"/>
               </a:rPr>
-              <a:t>During which hours do heat and low humidity combine into the strongest daily risk window?</a:t>
+              <a:t>Which hours show the strongest overlap of heat and low humidity?</a:t>
             </a:r>
           </a:p>
         </p:txBody>
@@ -27277,7 +27277,7 @@
                 <a:ea typeface="Manrope"/>
                 <a:cs typeface="Manrope"/>
               </a:rPr>
-              <a:t>Once the 30/30 screen is crossed, how long do continuous elevated-risk events last?</a:t>
+              <a:t>After the screen is crossed, how long do elevated conditions continue?</a:t>
             </a:r>
           </a:p>
         </p:txBody>
@@ -27461,8 +27461,8 @@
         </p:nvSpPr>
         <p:spPr>
           <a:xfrm xmlns:a="http://schemas.openxmlformats.org/drawingml/2006/main">
-            <a:off x="875000" y="6100000"/>
-            <a:ext cx="10299900" cy="470100"/>
+            <a:off x="875000" y="5943600"/>
+            <a:ext cx="10299900" cy="457200"/>
           </a:xfrm>
           <a:prstGeom xmlns:a="http://schemas.openxmlformats.org/drawingml/2006/main" prst="rect">
             <a:avLst/>
@@ -27488,7 +27488,7 @@
               <a:buNone/>
             </a:pPr>
             <a:r>
-              <a:rPr sz="1500" b="1">
+              <a:rPr sz="1350" b="1">
                 <a:solidFill>
                   <a:srgbClr val="FFFFFF"/>
                 </a:solidFill>
@@ -27496,18 +27496,7 @@
                 <a:ea typeface="Urbanist"/>
                 <a:cs typeface="Urbanist"/>
               </a:rPr>
-              <a:t>5. Seasonal Macro-Trends:</a:t>
-            </a:r>
-            <a:r>
-              <a:rPr sz="1500">
-                <a:solidFill>
-                  <a:srgbClr val="FFFFFF"/>
-                </a:solidFill>
-                <a:latin typeface="Urbanist"/>
-                <a:ea typeface="Urbanist"/>
-                <a:cs typeface="Urbanist"/>
-              </a:rPr>
-              <a:t> How do heat, humidity, and pressure baselines shift by season and year?</a:t>
+              <a:t>5. Seasonal trends: How do heat, humidity, and pressure shift by season and year?</a:t>
             </a:r>
           </a:p>
         </p:txBody>
@@ -27550,7 +27539,7 @@
           <p:nvPr/>
         </p:nvPicPr>
         <p:blipFill rotWithShape="1">
-          <a:blip xmlns:r="http://schemas.openxmlformats.org/officeDocument/2006/relationships" xmlns:a="http://schemas.openxmlformats.org/drawingml/2006/main" r:embed="R4db2ba6822f04423">
+          <a:blip xmlns:r="http://schemas.openxmlformats.org/officeDocument/2006/relationships" xmlns:a="http://schemas.openxmlformats.org/drawingml/2006/main" r:embed="R5a328ad2d38e473b">
             <a:alphaModFix/>
           </a:blip>
           <a:srcRect xmlns:a="http://schemas.openxmlformats.org/drawingml/2006/main" l="0" t="0" r="0" b="0"/>
@@ -27578,7 +27567,7 @@
           <p:nvPr/>
         </p:nvPicPr>
         <p:blipFill rotWithShape="1">
-          <a:blip xmlns:r="http://schemas.openxmlformats.org/officeDocument/2006/relationships" xmlns:a="http://schemas.openxmlformats.org/drawingml/2006/main" r:embed="Redbd66c06aa546ca">
+          <a:blip xmlns:r="http://schemas.openxmlformats.org/officeDocument/2006/relationships" xmlns:a="http://schemas.openxmlformats.org/drawingml/2006/main" r:embed="R1a5993a8bfc64025">
             <a:alphaModFix/>
           </a:blip>
           <a:srcRect xmlns:a="http://schemas.openxmlformats.org/drawingml/2006/main" l="0" t="0" r="0" b="0"/>
@@ -27707,7 +27696,7 @@
                 <a:ea typeface="Inter"/>
                 <a:cs typeface="Inter"/>
               </a:rPr>
-              <a:t>Simultaneous high heat ($T \ge 30^\circ\text{C}$) and low moisture ($\text{RH} \le 30\%$) events are rare but critical.</a:t>
+              <a:t>Simultaneous high heat (30 C or above) and low humidity (30% or below) are rare but important screening cases.</a:t>
             </a:r>
           </a:p>
         </p:txBody>
@@ -27822,7 +27811,7 @@
                 <a:ea typeface="Inter"/>
                 <a:cs typeface="Inter"/>
               </a:rPr>
-              <a:t>When the air is hot and dry, fuel moisture content (FMC) drops rapidly, allowing for nearly instantaneous ignition from spot embers.</a:t>
+              <a:t>Hot, dry air can reduce fine-fuel moisture and make ignition conditions more favorable.</a:t>
             </a:r>
           </a:p>
         </p:txBody>
@@ -27844,7 +27833,7 @@
         <p:spPr>
           <a:xfrm xmlns:a="http://schemas.openxmlformats.org/drawingml/2006/main">
             <a:off x="962025" y="3938587"/>
-            <a:ext cx="4896000" cy="231000"/>
+            <a:ext cx="4896000" cy="365760"/>
           </a:xfrm>
           <a:prstGeom xmlns:a="http://schemas.openxmlformats.org/drawingml/2006/main" prst="rect">
             <a:avLst/>
@@ -27881,7 +27870,7 @@
                 <a:ea typeface="Inter"/>
                 <a:cs typeface="Inter"/>
               </a:rPr>
-              <a:t>Only 26 out of 68,666 events meet this criteria.</a:t>
+              <a:t>Only 26 of 68,666 hourly events meet this criterion.</a:t>
             </a:r>
           </a:p>
         </p:txBody>
@@ -27962,7 +27951,7 @@
         <p:spPr>
           <a:xfrm xmlns:a="http://schemas.openxmlformats.org/drawingml/2006/main">
             <a:off x="962025" y="4929187"/>
-            <a:ext cx="4896000" cy="231000"/>
+            <a:ext cx="4896000" cy="365760"/>
           </a:xfrm>
           <a:prstGeom xmlns:a="http://schemas.openxmlformats.org/drawingml/2006/main" prst="rect">
             <a:avLst/>
@@ -27999,7 +27988,7 @@
                 <a:ea typeface="Inter"/>
                 <a:cs typeface="Inter"/>
               </a:rPr>
-              <a:t>Identified as the primary "Critical Danger" trigger.</a:t>
+              <a:t>Used as the project’s main heat-and-dryness screen.</a:t>
             </a:r>
           </a:p>
         </p:txBody>
@@ -28013,7 +28002,7 @@
           <p:nvPr/>
         </p:nvPicPr>
         <p:blipFill rotWithShape="1">
-          <a:blip xmlns:r="http://schemas.openxmlformats.org/officeDocument/2006/relationships" xmlns:a="http://schemas.openxmlformats.org/drawingml/2006/main" r:embed="Re8b4baa4e821447f">
+          <a:blip xmlns:r="http://schemas.openxmlformats.org/officeDocument/2006/relationships" xmlns:a="http://schemas.openxmlformats.org/drawingml/2006/main" r:embed="Rc298b3743edc4ae5">
             <a:alphaModFix/>
           </a:blip>
           <a:srcRect xmlns:a="http://schemas.openxmlformats.org/drawingml/2006/main" l="0" t="0" r="0" b="0"/>
@@ -28041,7 +28030,7 @@
           <p:nvPr/>
         </p:nvPicPr>
         <p:blipFill rotWithShape="1">
-          <a:blip xmlns:r="http://schemas.openxmlformats.org/officeDocument/2006/relationships" xmlns:a="http://schemas.openxmlformats.org/drawingml/2006/main" r:embed="Rc78380d2f2654267">
+          <a:blip xmlns:r="http://schemas.openxmlformats.org/officeDocument/2006/relationships" xmlns:a="http://schemas.openxmlformats.org/drawingml/2006/main" r:embed="R57febc3b435d4b36">
             <a:alphaModFix/>
           </a:blip>
           <a:srcRect xmlns:a="http://schemas.openxmlformats.org/drawingml/2006/main" l="0" t="0" r="0" b="0"/>
@@ -28069,7 +28058,7 @@
           <p:nvPr/>
         </p:nvPicPr>
         <p:blipFill rotWithShape="1">
-          <a:blip xmlns:r="http://schemas.openxmlformats.org/officeDocument/2006/relationships" xmlns:a="http://schemas.openxmlformats.org/drawingml/2006/main" r:embed="Rb7184eb3bdf74218">
+          <a:blip xmlns:r="http://schemas.openxmlformats.org/officeDocument/2006/relationships" xmlns:a="http://schemas.openxmlformats.org/drawingml/2006/main" r:embed="R7a066ebfa2fc44df">
             <a:alphaModFix/>
           </a:blip>
           <a:srcRect xmlns:a="http://schemas.openxmlformats.org/drawingml/2006/main" l="0" t="0" r="0" b="0"/>
@@ -28235,7 +28224,7 @@
           <p:nvPr/>
         </p:nvPicPr>
         <p:blipFill rotWithShape="1">
-          <a:blip xmlns:r="http://schemas.openxmlformats.org/officeDocument/2006/relationships" xmlns:a="http://schemas.openxmlformats.org/drawingml/2006/main" r:embed="R9bc627c474f14cd2">
+          <a:blip xmlns:r="http://schemas.openxmlformats.org/officeDocument/2006/relationships" xmlns:a="http://schemas.openxmlformats.org/drawingml/2006/main" r:embed="R85dffc396a884c17">
             <a:alphaModFix/>
           </a:blip>
           <a:srcRect xmlns:a="http://schemas.openxmlformats.org/drawingml/2006/main" l="0" t="0" r="0" b="0"/>
@@ -28263,7 +28252,7 @@
           <p:nvPr/>
         </p:nvPicPr>
         <p:blipFill rotWithShape="1">
-          <a:blip xmlns:r="http://schemas.openxmlformats.org/officeDocument/2006/relationships" xmlns:a="http://schemas.openxmlformats.org/drawingml/2006/main" r:embed="Rad33fbdaed154fd6">
+          <a:blip xmlns:r="http://schemas.openxmlformats.org/officeDocument/2006/relationships" xmlns:a="http://schemas.openxmlformats.org/drawingml/2006/main" r:embed="R22d3564fa4ef4ee0">
             <a:alphaModFix/>
           </a:blip>
           <a:srcRect xmlns:a="http://schemas.openxmlformats.org/drawingml/2006/main" l="0" t="0" r="0" b="0"/>
@@ -28585,7 +28574,7 @@
           <p:nvPr/>
         </p:nvPicPr>
         <p:blipFill rotWithShape="1">
-          <a:blip xmlns:r="http://schemas.openxmlformats.org/officeDocument/2006/relationships" xmlns:a="http://schemas.openxmlformats.org/drawingml/2006/main" r:embed="Rd4bb5a7cf5024501">
+          <a:blip xmlns:r="http://schemas.openxmlformats.org/officeDocument/2006/relationships" xmlns:a="http://schemas.openxmlformats.org/drawingml/2006/main" r:embed="R20549397a46d4d52">
             <a:alphaModFix/>
           </a:blip>
           <a:srcRect xmlns:a="http://schemas.openxmlformats.org/drawingml/2006/main" l="0" t="0" r="0" b="0"/>
@@ -28620,8 +28609,8 @@
         </p:nvSpPr>
         <p:spPr>
           <a:xfrm xmlns:a="http://schemas.openxmlformats.org/drawingml/2006/main">
-            <a:off x="581025" y="5429250"/>
-            <a:ext cx="5324475" cy="914400"/>
+            <a:off x="581025" y="5219700"/>
+            <a:ext cx="5324475" cy="876300"/>
           </a:xfrm>
           <a:prstGeom xmlns:a="http://schemas.openxmlformats.org/drawingml/2006/main" prst="rect">
             <a:avLst/>
@@ -28650,7 +28639,7 @@
               <a:buNone/>
             </a:pPr>
             <a:r>
-              <a:rPr>
+              <a:rPr sz="1350">
                 <a:solidFill>
                   <a:srgbClr val="CBD5E1"/>
                 </a:solidFill>
@@ -28658,7 +28647,7 @@
                 <a:ea typeface="Manrope"/>
                 <a:cs typeface="Manrope"/>
               </a:rPr>
-              <a:t>Claim: Highest daily vulnerability occurs from 13:00-16:00.</a:t>
+              <a:t>Claim: The strongest daily heat-and-dryness overlap appears around 13:00-16:00.</a:t>
             </a:r>
           </a:p>
           <a:p xmlns:a="http://schemas.openxmlformats.org/drawingml/2006/main">
@@ -28675,7 +28664,7 @@
               <a:buNone/>
             </a:pPr>
             <a:r>
-              <a:rPr>
+              <a:rPr sz="1350">
                 <a:solidFill>
                   <a:srgbClr val="CBD5E1"/>
                 </a:solidFill>
@@ -28683,7 +28672,7 @@
                 <a:ea typeface="Manrope"/>
                 <a:cs typeface="Manrope"/>
               </a:rPr>
-              <a:t>Evidence: Median temperature peaks as relative humidity reaches its daily low.</a:t>
+              <a:t>Evidence: Median temperature peaks while humidity reaches its daily low.</a:t>
             </a:r>
           </a:p>
         </p:txBody>
@@ -28704,8 +28693,8 @@
         </p:nvSpPr>
         <p:spPr>
           <a:xfrm xmlns:a="http://schemas.openxmlformats.org/drawingml/2006/main">
-            <a:off x="6286500" y="5429250"/>
-            <a:ext cx="5324475" cy="914400"/>
+            <a:off x="6286500" y="5353050"/>
+            <a:ext cx="5324475" cy="666750"/>
           </a:xfrm>
           <a:prstGeom xmlns:a="http://schemas.openxmlformats.org/drawingml/2006/main" prst="rect">
             <a:avLst/>
@@ -28734,7 +28723,7 @@
               <a:buNone/>
             </a:pPr>
             <a:r>
-              <a:rPr>
+              <a:rPr sz="1350">
                 <a:solidFill>
                   <a:srgbClr val="CBD5E1"/>
                 </a:solidFill>
@@ -28742,7 +28731,7 @@
                 <a:ea typeface="Manrope"/>
                 <a:cs typeface="Manrope"/>
               </a:rPr>
-              <a:t>Reasoning: Heat plus dry air lowers fine-fuel moisture, so warning sensitivity should be highest in the post-noon window.</a:t>
+              <a:t>Reasoning: This is the clearest afternoon screening window in the Jena dataset.</a:t>
             </a:r>
           </a:p>
         </p:txBody>
@@ -28756,7 +28745,7 @@
           <p:nvPr/>
         </p:nvPicPr>
         <p:blipFill rotWithShape="1">
-          <a:blip xmlns:r="http://schemas.openxmlformats.org/officeDocument/2006/relationships" xmlns:a="http://schemas.openxmlformats.org/drawingml/2006/main" r:embed="R59ebc130f16c4175">
+          <a:blip xmlns:r="http://schemas.openxmlformats.org/officeDocument/2006/relationships" xmlns:a="http://schemas.openxmlformats.org/drawingml/2006/main" r:embed="Ra76dce1a803b4a18">
             <a:alphaModFix/>
           </a:blip>
           <a:srcRect xmlns:a="http://schemas.openxmlformats.org/drawingml/2006/main" l="0" t="0" r="0" b="0"/>
@@ -28890,7 +28879,7 @@
           <p:nvPr/>
         </p:nvPicPr>
         <p:blipFill>
-          <a:blip xmlns:r="http://schemas.openxmlformats.org/officeDocument/2006/relationships" xmlns:a="http://schemas.openxmlformats.org/drawingml/2006/main" r:embed="R543777b821aa4a6c">
+          <a:blip xmlns:r="http://schemas.openxmlformats.org/officeDocument/2006/relationships" xmlns:a="http://schemas.openxmlformats.org/drawingml/2006/main" r:embed="R8007ca7670644ccd">
             <a:alphaModFix/>
           </a:blip>
           <a:stretch xmlns:a="http://schemas.openxmlformats.org/drawingml/2006/main">

</xml_diff>

<commit_message>
Update project documentation and setup
</commit_message>
<xml_diff>
--- a/fire_weather/docs/presentation/Fire Weather Monitoring Project.pptx
+++ b/fire_weather/docs/presentation/Fire Weather Monitoring Project.pptx
@@ -2,87 +2,87 @@
 <file path=ppt/presentation.xml><?xml version="1.0" encoding="utf-8"?>
 <p:presentation xmlns:p="http://schemas.openxmlformats.org/presentationml/2006/main" embedTrueTypeFonts="1" saveSubsetFonts="0">
   <p:sldMasterIdLst>
-    <p:sldMasterId xmlns:r="http://schemas.openxmlformats.org/officeDocument/2006/relationships" id="2147483648" r:id="Rac01e98d392e40e6"/>
+    <p:sldMasterId xmlns:r="http://schemas.openxmlformats.org/officeDocument/2006/relationships" id="2147483648" r:id="Ra3aca77a99384a57"/>
   </p:sldMasterIdLst>
   <p:notesMasterIdLst>
-    <p:notesMasterId xmlns:r="http://schemas.openxmlformats.org/officeDocument/2006/relationships" r:id="Rc463cfef08324b2a"/>
+    <p:notesMasterId xmlns:r="http://schemas.openxmlformats.org/officeDocument/2006/relationships" r:id="R48cbc8278bcc4ebc"/>
   </p:notesMasterIdLst>
   <p:sldIdLst>
-    <p:sldId xmlns:r="http://schemas.openxmlformats.org/officeDocument/2006/relationships" id="256" r:id="Ra37ef5608ca648ae"/>
-    <p:sldId xmlns:r="http://schemas.openxmlformats.org/officeDocument/2006/relationships" id="257" r:id="R76e0c38529d846f7"/>
-    <p:sldId xmlns:r="http://schemas.openxmlformats.org/officeDocument/2006/relationships" id="258" r:id="R1d1b6907d3d5491f"/>
-    <p:sldId xmlns:r="http://schemas.openxmlformats.org/officeDocument/2006/relationships" id="259" r:id="Rd98b1e95007f41e6"/>
-    <p:sldId xmlns:r="http://schemas.openxmlformats.org/officeDocument/2006/relationships" id="260" r:id="Rcda842e4f1874a19"/>
-    <p:sldId xmlns:r="http://schemas.openxmlformats.org/officeDocument/2006/relationships" id="261" r:id="R45ce9c60cf16479d"/>
-    <p:sldId xmlns:r="http://schemas.openxmlformats.org/officeDocument/2006/relationships" id="262" r:id="Rc0f0cfe1bc234e75"/>
-    <p:sldId xmlns:r="http://schemas.openxmlformats.org/officeDocument/2006/relationships" id="263" r:id="R5421b7f478c54ec0"/>
-    <p:sldId xmlns:r="http://schemas.openxmlformats.org/officeDocument/2006/relationships" id="264" r:id="R7f78ac4e95cc4a60"/>
-    <p:sldId xmlns:r="http://schemas.openxmlformats.org/officeDocument/2006/relationships" id="265" r:id="Rfd6122ae352043d1"/>
-    <p:sldId xmlns:r="http://schemas.openxmlformats.org/officeDocument/2006/relationships" id="266" r:id="R75efd3b8e9044bfb"/>
-    <p:sldId xmlns:r="http://schemas.openxmlformats.org/officeDocument/2006/relationships" id="267" r:id="R9585afc6cfae4559"/>
-    <p:sldId xmlns:r="http://schemas.openxmlformats.org/officeDocument/2006/relationships" id="268" r:id="Rc8212279c6a548f4"/>
-    <p:sldId xmlns:r="http://schemas.openxmlformats.org/officeDocument/2006/relationships" id="269" r:id="Rd592f6ea1cec4c7d"/>
-    <p:sldId xmlns:r="http://schemas.openxmlformats.org/officeDocument/2006/relationships" id="270" r:id="Rdf8280da5cfb42c2"/>
-    <p:sldId xmlns:r="http://schemas.openxmlformats.org/officeDocument/2006/relationships" id="271" r:id="Re1ffecc4e3b8428d"/>
-    <p:sldId xmlns:r="http://schemas.openxmlformats.org/officeDocument/2006/relationships" id="272" r:id="Re9b9fb638d354b9a"/>
-    <p:sldId xmlns:r="http://schemas.openxmlformats.org/officeDocument/2006/relationships" id="273" r:id="R9c95ee4d0c7641f5"/>
-    <p:sldId xmlns:r="http://schemas.openxmlformats.org/officeDocument/2006/relationships" id="274" r:id="Rc172c07b69034552"/>
-    <p:sldId xmlns:r="http://schemas.openxmlformats.org/officeDocument/2006/relationships" id="275" r:id="Rb25f6707fc694e17"/>
-    <p:sldId xmlns:r="http://schemas.openxmlformats.org/officeDocument/2006/relationships" id="276" r:id="Rd37b4f0adc19413f"/>
-    <p:sldId xmlns:r="http://schemas.openxmlformats.org/officeDocument/2006/relationships" id="277" r:id="R2f6645b299a54edb"/>
-    <p:sldId xmlns:r="http://schemas.openxmlformats.org/officeDocument/2006/relationships" id="278" r:id="R5d8d07838e0d473d"/>
-    <p:sldId xmlns:r="http://schemas.openxmlformats.org/officeDocument/2006/relationships" id="279" r:id="R37d54cb65c764ca4"/>
-    <p:sldId xmlns:r="http://schemas.openxmlformats.org/officeDocument/2006/relationships" id="280" r:id="R9394f9b65f10449f"/>
-    <p:sldId xmlns:r="http://schemas.openxmlformats.org/officeDocument/2006/relationships" id="281" r:id="Red3a44c7914c4acd"/>
-    <p:sldId xmlns:r="http://schemas.openxmlformats.org/officeDocument/2006/relationships" id="282" r:id="R2a59afcbca6e40fe"/>
+    <p:sldId xmlns:r="http://schemas.openxmlformats.org/officeDocument/2006/relationships" id="256" r:id="R1f3652fc458a4bdc"/>
+    <p:sldId xmlns:r="http://schemas.openxmlformats.org/officeDocument/2006/relationships" id="257" r:id="Rb0b79d55209f46e3"/>
+    <p:sldId xmlns:r="http://schemas.openxmlformats.org/officeDocument/2006/relationships" id="258" r:id="R29c64ad5a30d49b8"/>
+    <p:sldId xmlns:r="http://schemas.openxmlformats.org/officeDocument/2006/relationships" id="259" r:id="R0b11bf8e68bf4553"/>
+    <p:sldId xmlns:r="http://schemas.openxmlformats.org/officeDocument/2006/relationships" id="260" r:id="R683203a18e0f4e9b"/>
+    <p:sldId xmlns:r="http://schemas.openxmlformats.org/officeDocument/2006/relationships" id="261" r:id="R2d82dbbed71940c1"/>
+    <p:sldId xmlns:r="http://schemas.openxmlformats.org/officeDocument/2006/relationships" id="262" r:id="R67fd2f9c48f640a0"/>
+    <p:sldId xmlns:r="http://schemas.openxmlformats.org/officeDocument/2006/relationships" id="263" r:id="R26ec5c4d031240ea"/>
+    <p:sldId xmlns:r="http://schemas.openxmlformats.org/officeDocument/2006/relationships" id="264" r:id="R08adc2c3ed5a4aa4"/>
+    <p:sldId xmlns:r="http://schemas.openxmlformats.org/officeDocument/2006/relationships" id="265" r:id="Rd78bdca4db224349"/>
+    <p:sldId xmlns:r="http://schemas.openxmlformats.org/officeDocument/2006/relationships" id="266" r:id="R2620baebf8fa40da"/>
+    <p:sldId xmlns:r="http://schemas.openxmlformats.org/officeDocument/2006/relationships" id="267" r:id="R713cd7779d874b64"/>
+    <p:sldId xmlns:r="http://schemas.openxmlformats.org/officeDocument/2006/relationships" id="268" r:id="R539808fa10f54cda"/>
+    <p:sldId xmlns:r="http://schemas.openxmlformats.org/officeDocument/2006/relationships" id="269" r:id="R9a3a313946f2496d"/>
+    <p:sldId xmlns:r="http://schemas.openxmlformats.org/officeDocument/2006/relationships" id="270" r:id="R6b64436fac1f4d7a"/>
+    <p:sldId xmlns:r="http://schemas.openxmlformats.org/officeDocument/2006/relationships" id="271" r:id="Rd6cc2f732f90477c"/>
+    <p:sldId xmlns:r="http://schemas.openxmlformats.org/officeDocument/2006/relationships" id="272" r:id="R02c1dd5c11c44515"/>
+    <p:sldId xmlns:r="http://schemas.openxmlformats.org/officeDocument/2006/relationships" id="273" r:id="Read74eeb4f43460f"/>
+    <p:sldId xmlns:r="http://schemas.openxmlformats.org/officeDocument/2006/relationships" id="274" r:id="Rc7d92ab8193d4fdf"/>
+    <p:sldId xmlns:r="http://schemas.openxmlformats.org/officeDocument/2006/relationships" id="275" r:id="Rad7f1f4682e949be"/>
+    <p:sldId xmlns:r="http://schemas.openxmlformats.org/officeDocument/2006/relationships" id="276" r:id="R5d8d197a3dfb40ad"/>
+    <p:sldId xmlns:r="http://schemas.openxmlformats.org/officeDocument/2006/relationships" id="277" r:id="R35b3f68a02cb4b0d"/>
+    <p:sldId xmlns:r="http://schemas.openxmlformats.org/officeDocument/2006/relationships" id="278" r:id="Rd5d58d21ba694cf3"/>
+    <p:sldId xmlns:r="http://schemas.openxmlformats.org/officeDocument/2006/relationships" id="279" r:id="R8f513f16aaf348b2"/>
+    <p:sldId xmlns:r="http://schemas.openxmlformats.org/officeDocument/2006/relationships" id="280" r:id="R13149cb04ebe4b23"/>
+    <p:sldId xmlns:r="http://schemas.openxmlformats.org/officeDocument/2006/relationships" id="281" r:id="R7a34a7368e484959"/>
+    <p:sldId xmlns:r="http://schemas.openxmlformats.org/officeDocument/2006/relationships" id="282" r:id="Rcbe8cdc8f96f4d52"/>
   </p:sldIdLst>
   <p:sldSz cx="12192000" cy="6858000"/>
   <p:notesSz cx="6858000" cy="9144000"/>
   <p:embeddedFontLst>
     <p:embeddedFont>
       <p:font typeface="Manrope SemiBold"/>
-      <p:regular xmlns:r="http://schemas.openxmlformats.org/officeDocument/2006/relationships" r:id="Rf76d7316e03342fb"/>
-      <p:bold xmlns:r="http://schemas.openxmlformats.org/officeDocument/2006/relationships" r:id="Rca38da86a3a544b6"/>
+      <p:regular xmlns:r="http://schemas.openxmlformats.org/officeDocument/2006/relationships" r:id="Rdcc3a7badc814950"/>
+      <p:bold xmlns:r="http://schemas.openxmlformats.org/officeDocument/2006/relationships" r:id="R0c6c62208e774b60"/>
     </p:embeddedFont>
     <p:embeddedFont>
       <p:font typeface="Inter"/>
-      <p:regular xmlns:r="http://schemas.openxmlformats.org/officeDocument/2006/relationships" r:id="Rf5a980f7c4604314"/>
-      <p:bold xmlns:r="http://schemas.openxmlformats.org/officeDocument/2006/relationships" r:id="Ra5efd65e44ff4a75"/>
-      <p:italic xmlns:r="http://schemas.openxmlformats.org/officeDocument/2006/relationships" r:id="Redbe5dd485394e33"/>
-      <p:boldItalic xmlns:r="http://schemas.openxmlformats.org/officeDocument/2006/relationships" r:id="Ra4958aec84804a02"/>
+      <p:regular xmlns:r="http://schemas.openxmlformats.org/officeDocument/2006/relationships" r:id="R08bd3d3992f74c6e"/>
+      <p:bold xmlns:r="http://schemas.openxmlformats.org/officeDocument/2006/relationships" r:id="R796a12f2d56b4132"/>
+      <p:italic xmlns:r="http://schemas.openxmlformats.org/officeDocument/2006/relationships" r:id="R92066b9ba8ae445b"/>
+      <p:boldItalic xmlns:r="http://schemas.openxmlformats.org/officeDocument/2006/relationships" r:id="Rf25f589c6e0c4c21"/>
     </p:embeddedFont>
     <p:embeddedFont>
       <p:font typeface="Manrope"/>
-      <p:regular xmlns:r="http://schemas.openxmlformats.org/officeDocument/2006/relationships" r:id="R3f0f5ceb4cc14922"/>
-      <p:bold xmlns:r="http://schemas.openxmlformats.org/officeDocument/2006/relationships" r:id="Rb9776e8d3a3a42e5"/>
+      <p:regular xmlns:r="http://schemas.openxmlformats.org/officeDocument/2006/relationships" r:id="Rf88aa764330f43ea"/>
+      <p:bold xmlns:r="http://schemas.openxmlformats.org/officeDocument/2006/relationships" r:id="Ref770801c98f467f"/>
     </p:embeddedFont>
     <p:embeddedFont>
       <p:font typeface="Urbanist SemiBold"/>
-      <p:regular xmlns:r="http://schemas.openxmlformats.org/officeDocument/2006/relationships" r:id="Ra4f3065a8aac4101"/>
-      <p:bold xmlns:r="http://schemas.openxmlformats.org/officeDocument/2006/relationships" r:id="R6bdc656edd8f4921"/>
-      <p:italic xmlns:r="http://schemas.openxmlformats.org/officeDocument/2006/relationships" r:id="R402fa74314aa4935"/>
-      <p:boldItalic xmlns:r="http://schemas.openxmlformats.org/officeDocument/2006/relationships" r:id="Rd3fb4876df00443c"/>
+      <p:regular xmlns:r="http://schemas.openxmlformats.org/officeDocument/2006/relationships" r:id="R957d6c9439544b50"/>
+      <p:bold xmlns:r="http://schemas.openxmlformats.org/officeDocument/2006/relationships" r:id="R9034a5f33ccc4fc8"/>
+      <p:italic xmlns:r="http://schemas.openxmlformats.org/officeDocument/2006/relationships" r:id="Radf0d987e0404d7f"/>
+      <p:boldItalic xmlns:r="http://schemas.openxmlformats.org/officeDocument/2006/relationships" r:id="R9757eb4cc69c4332"/>
     </p:embeddedFont>
     <p:embeddedFont>
       <p:font typeface="Urbanist Medium"/>
-      <p:regular xmlns:r="http://schemas.openxmlformats.org/officeDocument/2006/relationships" r:id="R9b7c6dd539bb4c4d"/>
-      <p:bold xmlns:r="http://schemas.openxmlformats.org/officeDocument/2006/relationships" r:id="R60936f0ac1cb44d5"/>
-      <p:italic xmlns:r="http://schemas.openxmlformats.org/officeDocument/2006/relationships" r:id="Rb7edb9f632b74660"/>
-      <p:boldItalic xmlns:r="http://schemas.openxmlformats.org/officeDocument/2006/relationships" r:id="R605ff6da67a94cb7"/>
+      <p:regular xmlns:r="http://schemas.openxmlformats.org/officeDocument/2006/relationships" r:id="Rfa66cdb0d50a454a"/>
+      <p:bold xmlns:r="http://schemas.openxmlformats.org/officeDocument/2006/relationships" r:id="R8a6a0869fad24dca"/>
+      <p:italic xmlns:r="http://schemas.openxmlformats.org/officeDocument/2006/relationships" r:id="R11d2413a821e4cc5"/>
+      <p:boldItalic xmlns:r="http://schemas.openxmlformats.org/officeDocument/2006/relationships" r:id="R114a40f3a3754914"/>
     </p:embeddedFont>
     <p:embeddedFont>
       <p:font typeface="Urbanist"/>
-      <p:regular xmlns:r="http://schemas.openxmlformats.org/officeDocument/2006/relationships" r:id="R07a79144a71a46cf"/>
-      <p:bold xmlns:r="http://schemas.openxmlformats.org/officeDocument/2006/relationships" r:id="R41787abf51614d48"/>
-      <p:italic xmlns:r="http://schemas.openxmlformats.org/officeDocument/2006/relationships" r:id="R7a206bbefbc74e4a"/>
-      <p:boldItalic xmlns:r="http://schemas.openxmlformats.org/officeDocument/2006/relationships" r:id="R85f1fb3d258041a4"/>
+      <p:regular xmlns:r="http://schemas.openxmlformats.org/officeDocument/2006/relationships" r:id="Rbf4f7515c27843a3"/>
+      <p:bold xmlns:r="http://schemas.openxmlformats.org/officeDocument/2006/relationships" r:id="Re109c84dfdc440de"/>
+      <p:italic xmlns:r="http://schemas.openxmlformats.org/officeDocument/2006/relationships" r:id="R1c2676b285364826"/>
+      <p:boldItalic xmlns:r="http://schemas.openxmlformats.org/officeDocument/2006/relationships" r:id="R1ea320f84d2c4a7b"/>
     </p:embeddedFont>
     <p:embeddedFont>
       <p:font typeface="Poppins SemiBold"/>
-      <p:regular xmlns:r="http://schemas.openxmlformats.org/officeDocument/2006/relationships" r:id="Rb83975fd7aec4dd8"/>
-      <p:bold xmlns:r="http://schemas.openxmlformats.org/officeDocument/2006/relationships" r:id="Ree7f0a3b7d0f4dea"/>
-      <p:italic xmlns:r="http://schemas.openxmlformats.org/officeDocument/2006/relationships" r:id="Re426cebe55354ed7"/>
-      <p:boldItalic xmlns:r="http://schemas.openxmlformats.org/officeDocument/2006/relationships" r:id="R2b9b392f4fca49ca"/>
+      <p:regular xmlns:r="http://schemas.openxmlformats.org/officeDocument/2006/relationships" r:id="R748b64b382b24a1c"/>
+      <p:bold xmlns:r="http://schemas.openxmlformats.org/officeDocument/2006/relationships" r:id="R8ee75868b26743b7"/>
+      <p:italic xmlns:r="http://schemas.openxmlformats.org/officeDocument/2006/relationships" r:id="Rbec3436411ea4e6c"/>
+      <p:boldItalic xmlns:r="http://schemas.openxmlformats.org/officeDocument/2006/relationships" r:id="R727c0dd343a6455e"/>
     </p:embeddedFont>
   </p:embeddedFontLst>
 </p:presentation>
@@ -12800,17 +12800,17 @@
   </p:cSld>
   <p:clrMap bg1="lt1" tx1="dk1" bg2="dk2" tx2="lt2" accent1="accent1" accent2="accent2" accent3="accent3" accent4="accent4" accent5="accent5" accent6="accent6" hlink="hlink" folHlink="folHlink"/>
   <p:sldLayoutIdLst>
-    <p:sldLayoutId xmlns:r="http://schemas.openxmlformats.org/officeDocument/2006/relationships" id="2147483649" r:id="R4c8d29d1639241e9"/>
-    <p:sldLayoutId xmlns:r="http://schemas.openxmlformats.org/officeDocument/2006/relationships" id="2147483650" r:id="R023fa7bdc8ec46df"/>
-    <p:sldLayoutId xmlns:r="http://schemas.openxmlformats.org/officeDocument/2006/relationships" id="2147483651" r:id="R0946709a8b2d42be"/>
-    <p:sldLayoutId xmlns:r="http://schemas.openxmlformats.org/officeDocument/2006/relationships" id="2147483652" r:id="R36118a46fbf34fac"/>
-    <p:sldLayoutId xmlns:r="http://schemas.openxmlformats.org/officeDocument/2006/relationships" id="2147483653" r:id="R94fcd6f18b9c4bfe"/>
-    <p:sldLayoutId xmlns:r="http://schemas.openxmlformats.org/officeDocument/2006/relationships" id="2147483654" r:id="R2d6c49f68c53407a"/>
-    <p:sldLayoutId xmlns:r="http://schemas.openxmlformats.org/officeDocument/2006/relationships" id="2147483655" r:id="Rc10c4087b0b4414a"/>
-    <p:sldLayoutId xmlns:r="http://schemas.openxmlformats.org/officeDocument/2006/relationships" id="2147483656" r:id="R5ccfdcb5c58147a6"/>
-    <p:sldLayoutId xmlns:r="http://schemas.openxmlformats.org/officeDocument/2006/relationships" id="2147483657" r:id="Rbe7680cd0cb74321"/>
-    <p:sldLayoutId xmlns:r="http://schemas.openxmlformats.org/officeDocument/2006/relationships" id="2147483658" r:id="R056a416bb3834f8a"/>
-    <p:sldLayoutId xmlns:r="http://schemas.openxmlformats.org/officeDocument/2006/relationships" id="2147483659" r:id="R401deec24f9049de"/>
+    <p:sldLayoutId xmlns:r="http://schemas.openxmlformats.org/officeDocument/2006/relationships" id="2147483649" r:id="R970fa373686d44ae"/>
+    <p:sldLayoutId xmlns:r="http://schemas.openxmlformats.org/officeDocument/2006/relationships" id="2147483650" r:id="R1dcc0a88a8f841a4"/>
+    <p:sldLayoutId xmlns:r="http://schemas.openxmlformats.org/officeDocument/2006/relationships" id="2147483651" r:id="R4507860fea9a4c35"/>
+    <p:sldLayoutId xmlns:r="http://schemas.openxmlformats.org/officeDocument/2006/relationships" id="2147483652" r:id="R27f307ffdc0f4d61"/>
+    <p:sldLayoutId xmlns:r="http://schemas.openxmlformats.org/officeDocument/2006/relationships" id="2147483653" r:id="R4056b6e3fb4e49f8"/>
+    <p:sldLayoutId xmlns:r="http://schemas.openxmlformats.org/officeDocument/2006/relationships" id="2147483654" r:id="Re6564a742d05481f"/>
+    <p:sldLayoutId xmlns:r="http://schemas.openxmlformats.org/officeDocument/2006/relationships" id="2147483655" r:id="Re4199e4a1bca4d55"/>
+    <p:sldLayoutId xmlns:r="http://schemas.openxmlformats.org/officeDocument/2006/relationships" id="2147483656" r:id="R7d52a7081ca24d8c"/>
+    <p:sldLayoutId xmlns:r="http://schemas.openxmlformats.org/officeDocument/2006/relationships" id="2147483657" r:id="R2bd2a5216f79450e"/>
+    <p:sldLayoutId xmlns:r="http://schemas.openxmlformats.org/officeDocument/2006/relationships" id="2147483658" r:id="R26e8d1d81fdd4e87"/>
+    <p:sldLayoutId xmlns:r="http://schemas.openxmlformats.org/officeDocument/2006/relationships" id="2147483659" r:id="R5cd048f54edc4659"/>
   </p:sldLayoutIdLst>
   <p:hf sldNum="0" hdr="0" ftr="0" dt="0"/>
   <p:txStyles>
@@ -13768,7 +13768,7 @@
           <p:nvPr/>
         </p:nvPicPr>
         <p:blipFill rotWithShape="1">
-          <a:blip xmlns:r="http://schemas.openxmlformats.org/officeDocument/2006/relationships" xmlns:a="http://schemas.openxmlformats.org/drawingml/2006/main" r:embed="Rb2158f0768934a75">
+          <a:blip xmlns:r="http://schemas.openxmlformats.org/officeDocument/2006/relationships" xmlns:a="http://schemas.openxmlformats.org/drawingml/2006/main" r:embed="R7c7ea06b65e54fc6">
             <a:alphaModFix/>
           </a:blip>
           <a:srcRect xmlns:a="http://schemas.openxmlformats.org/drawingml/2006/main" l="0" t="0" r="0" b="0"/>
@@ -14064,7 +14064,7 @@
           <p:nvPr/>
         </p:nvPicPr>
         <p:blipFill rotWithShape="1">
-          <a:blip xmlns:r="http://schemas.openxmlformats.org/officeDocument/2006/relationships" xmlns:a="http://schemas.openxmlformats.org/drawingml/2006/main" r:embed="R53d870ad4af34b70">
+          <a:blip xmlns:r="http://schemas.openxmlformats.org/officeDocument/2006/relationships" xmlns:a="http://schemas.openxmlformats.org/drawingml/2006/main" r:embed="Rec363cd9e53c4322">
             <a:alphaModFix/>
           </a:blip>
           <a:srcRect xmlns:a="http://schemas.openxmlformats.org/drawingml/2006/main" l="0" t="0" r="0" b="0"/>
@@ -14092,7 +14092,7 @@
           <p:nvPr/>
         </p:nvPicPr>
         <p:blipFill rotWithShape="1">
-          <a:blip xmlns:r="http://schemas.openxmlformats.org/officeDocument/2006/relationships" xmlns:a="http://schemas.openxmlformats.org/drawingml/2006/main" r:embed="R52c33bb9da3f4d70">
+          <a:blip xmlns:r="http://schemas.openxmlformats.org/officeDocument/2006/relationships" xmlns:a="http://schemas.openxmlformats.org/drawingml/2006/main" r:embed="R3f075b0085b04c99">
             <a:alphaModFix/>
           </a:blip>
           <a:srcRect xmlns:a="http://schemas.openxmlformats.org/drawingml/2006/main" l="0" t="0" r="0" b="0"/>
@@ -14120,7 +14120,7 @@
           <p:nvPr/>
         </p:nvPicPr>
         <p:blipFill rotWithShape="1">
-          <a:blip xmlns:r="http://schemas.openxmlformats.org/officeDocument/2006/relationships" xmlns:a="http://schemas.openxmlformats.org/drawingml/2006/main" r:embed="R1966e6aeb7bf4cb3">
+          <a:blip xmlns:r="http://schemas.openxmlformats.org/officeDocument/2006/relationships" xmlns:a="http://schemas.openxmlformats.org/drawingml/2006/main" r:embed="Rbd795c5026164c04">
             <a:alphaModFix/>
           </a:blip>
           <a:srcRect xmlns:a="http://schemas.openxmlformats.org/drawingml/2006/main" l="0" t="0" r="0" b="0"/>
@@ -14148,7 +14148,7 @@
           <p:nvPr/>
         </p:nvPicPr>
         <p:blipFill rotWithShape="1">
-          <a:blip xmlns:r="http://schemas.openxmlformats.org/officeDocument/2006/relationships" xmlns:a="http://schemas.openxmlformats.org/drawingml/2006/main" r:embed="R52c33bb9da3f4d70">
+          <a:blip xmlns:r="http://schemas.openxmlformats.org/officeDocument/2006/relationships" xmlns:a="http://schemas.openxmlformats.org/drawingml/2006/main" r:embed="R3f075b0085b04c99">
             <a:alphaModFix/>
           </a:blip>
           <a:srcRect xmlns:a="http://schemas.openxmlformats.org/drawingml/2006/main" l="0" t="0" r="0" b="0"/>
@@ -14678,7 +14678,7 @@
           <p:nvPr/>
         </p:nvPicPr>
         <p:blipFill rotWithShape="1">
-          <a:blip xmlns:r="http://schemas.openxmlformats.org/officeDocument/2006/relationships" xmlns:a="http://schemas.openxmlformats.org/drawingml/2006/main" r:embed="Rf972921966b742b0">
+          <a:blip xmlns:r="http://schemas.openxmlformats.org/officeDocument/2006/relationships" xmlns:a="http://schemas.openxmlformats.org/drawingml/2006/main" r:embed="R057b5e3b570c45c2">
             <a:alphaModFix/>
           </a:blip>
           <a:srcRect xmlns:a="http://schemas.openxmlformats.org/drawingml/2006/main" l="0" t="0" r="0" b="0"/>
@@ -14706,7 +14706,7 @@
           <p:nvPr/>
         </p:nvPicPr>
         <p:blipFill rotWithShape="1">
-          <a:blip xmlns:r="http://schemas.openxmlformats.org/officeDocument/2006/relationships" xmlns:a="http://schemas.openxmlformats.org/drawingml/2006/main" r:embed="R63fb1b6801cd4e54">
+          <a:blip xmlns:r="http://schemas.openxmlformats.org/officeDocument/2006/relationships" xmlns:a="http://schemas.openxmlformats.org/drawingml/2006/main" r:embed="Recacd3794df64eb6">
             <a:alphaModFix/>
           </a:blip>
           <a:srcRect xmlns:a="http://schemas.openxmlformats.org/drawingml/2006/main" l="0" t="0" r="0" b="0"/>
@@ -14734,7 +14734,7 @@
           <p:nvPr/>
         </p:nvPicPr>
         <p:blipFill rotWithShape="1">
-          <a:blip xmlns:r="http://schemas.openxmlformats.org/officeDocument/2006/relationships" xmlns:a="http://schemas.openxmlformats.org/drawingml/2006/main" r:embed="R88aa1b9a4b1241ed">
+          <a:blip xmlns:r="http://schemas.openxmlformats.org/officeDocument/2006/relationships" xmlns:a="http://schemas.openxmlformats.org/drawingml/2006/main" r:embed="Rf1c2703bcb164984">
             <a:alphaModFix/>
           </a:blip>
           <a:srcRect xmlns:a="http://schemas.openxmlformats.org/drawingml/2006/main" l="0" t="0" r="0" b="0"/>
@@ -15778,7 +15778,7 @@
           <p:nvPr/>
         </p:nvPicPr>
         <p:blipFill rotWithShape="1">
-          <a:blip xmlns:r="http://schemas.openxmlformats.org/officeDocument/2006/relationships" xmlns:a="http://schemas.openxmlformats.org/drawingml/2006/main" r:embed="R126bec7176264a90">
+          <a:blip xmlns:r="http://schemas.openxmlformats.org/officeDocument/2006/relationships" xmlns:a="http://schemas.openxmlformats.org/drawingml/2006/main" r:embed="Rf61abf37bb3b4d2c">
             <a:alphaModFix/>
           </a:blip>
           <a:srcRect xmlns:a="http://schemas.openxmlformats.org/drawingml/2006/main" l="0" t="0" r="0" b="0"/>
@@ -15806,7 +15806,7 @@
           <p:nvPr/>
         </p:nvPicPr>
         <p:blipFill rotWithShape="1">
-          <a:blip xmlns:r="http://schemas.openxmlformats.org/officeDocument/2006/relationships" xmlns:a="http://schemas.openxmlformats.org/drawingml/2006/main" r:embed="Rc220edb5ad5541a6">
+          <a:blip xmlns:r="http://schemas.openxmlformats.org/officeDocument/2006/relationships" xmlns:a="http://schemas.openxmlformats.org/drawingml/2006/main" r:embed="R73dbabf291674409">
             <a:alphaModFix/>
           </a:blip>
           <a:srcRect xmlns:a="http://schemas.openxmlformats.org/drawingml/2006/main" l="0" t="0" r="0" b="0"/>
@@ -15834,7 +15834,7 @@
           <p:nvPr/>
         </p:nvPicPr>
         <p:blipFill rotWithShape="1">
-          <a:blip xmlns:r="http://schemas.openxmlformats.org/officeDocument/2006/relationships" xmlns:a="http://schemas.openxmlformats.org/drawingml/2006/main" r:embed="Rd73d45d61c714087">
+          <a:blip xmlns:r="http://schemas.openxmlformats.org/officeDocument/2006/relationships" xmlns:a="http://schemas.openxmlformats.org/drawingml/2006/main" r:embed="Ra08bd6632dca4464">
             <a:alphaModFix/>
           </a:blip>
           <a:srcRect xmlns:a="http://schemas.openxmlformats.org/drawingml/2006/main" l="0" t="0" r="0" b="0"/>
@@ -16154,7 +16154,7 @@
           <p:nvPr/>
         </p:nvPicPr>
         <p:blipFill rotWithShape="1">
-          <a:blip xmlns:r="http://schemas.openxmlformats.org/officeDocument/2006/relationships" xmlns:a="http://schemas.openxmlformats.org/drawingml/2006/main" r:embed="R433d2a0703344cd9">
+          <a:blip xmlns:r="http://schemas.openxmlformats.org/officeDocument/2006/relationships" xmlns:a="http://schemas.openxmlformats.org/drawingml/2006/main" r:embed="R4a18bf0aca66440a">
             <a:alphaModFix/>
           </a:blip>
           <a:srcRect xmlns:a="http://schemas.openxmlformats.org/drawingml/2006/main" l="0" t="0" r="0" b="0"/>
@@ -16182,7 +16182,7 @@
           <p:nvPr/>
         </p:nvPicPr>
         <p:blipFill rotWithShape="1">
-          <a:blip xmlns:r="http://schemas.openxmlformats.org/officeDocument/2006/relationships" xmlns:a="http://schemas.openxmlformats.org/drawingml/2006/main" r:embed="R433d2a0703344cd9">
+          <a:blip xmlns:r="http://schemas.openxmlformats.org/officeDocument/2006/relationships" xmlns:a="http://schemas.openxmlformats.org/drawingml/2006/main" r:embed="R4a18bf0aca66440a">
             <a:alphaModFix/>
           </a:blip>
           <a:srcRect xmlns:a="http://schemas.openxmlformats.org/drawingml/2006/main" l="0" t="0" r="0" b="0"/>
@@ -16210,7 +16210,7 @@
           <p:nvPr/>
         </p:nvPicPr>
         <p:blipFill rotWithShape="1">
-          <a:blip xmlns:r="http://schemas.openxmlformats.org/officeDocument/2006/relationships" xmlns:a="http://schemas.openxmlformats.org/drawingml/2006/main" r:embed="R433d2a0703344cd9">
+          <a:blip xmlns:r="http://schemas.openxmlformats.org/officeDocument/2006/relationships" xmlns:a="http://schemas.openxmlformats.org/drawingml/2006/main" r:embed="R4a18bf0aca66440a">
             <a:alphaModFix/>
           </a:blip>
           <a:srcRect xmlns:a="http://schemas.openxmlformats.org/drawingml/2006/main" l="0" t="0" r="0" b="0"/>
@@ -16373,7 +16373,7 @@
           <p:nvPr/>
         </p:nvPicPr>
         <p:blipFill rotWithShape="1">
-          <a:blip xmlns:r="http://schemas.openxmlformats.org/officeDocument/2006/relationships" xmlns:a="http://schemas.openxmlformats.org/drawingml/2006/main" r:embed="Ra9eabcddf203433c">
+          <a:blip xmlns:r="http://schemas.openxmlformats.org/officeDocument/2006/relationships" xmlns:a="http://schemas.openxmlformats.org/drawingml/2006/main" r:embed="R7ccb0f9410eb4f4c">
             <a:alphaModFix/>
           </a:blip>
           <a:srcRect xmlns:a="http://schemas.openxmlformats.org/drawingml/2006/main" l="0" t="0" r="0" b="0"/>
@@ -16607,7 +16607,7 @@
           <p:nvPr/>
         </p:nvPicPr>
         <p:blipFill rotWithShape="1">
-          <a:blip xmlns:r="http://schemas.openxmlformats.org/officeDocument/2006/relationships" xmlns:a="http://schemas.openxmlformats.org/drawingml/2006/main" r:embed="Rb7f20dd372c6469d">
+          <a:blip xmlns:r="http://schemas.openxmlformats.org/officeDocument/2006/relationships" xmlns:a="http://schemas.openxmlformats.org/drawingml/2006/main" r:embed="R2f3371a0d5074228">
             <a:alphaModFix/>
           </a:blip>
           <a:srcRect xmlns:a="http://schemas.openxmlformats.org/drawingml/2006/main" l="0" t="0" r="0" b="0"/>
@@ -16741,7 +16741,7 @@
           <p:nvPr/>
         </p:nvPicPr>
         <p:blipFill>
-          <a:blip xmlns:r="http://schemas.openxmlformats.org/officeDocument/2006/relationships" xmlns:a="http://schemas.openxmlformats.org/drawingml/2006/main" r:embed="R7f9ce65f285e4221">
+          <a:blip xmlns:r="http://schemas.openxmlformats.org/officeDocument/2006/relationships" xmlns:a="http://schemas.openxmlformats.org/drawingml/2006/main" r:embed="R82d09496cae9478a">
             <a:alphaModFix/>
           </a:blip>
           <a:stretch xmlns:a="http://schemas.openxmlformats.org/drawingml/2006/main">
@@ -16947,7 +16947,7 @@
           <p:nvPr/>
         </p:nvPicPr>
         <p:blipFill rotWithShape="1">
-          <a:blip xmlns:r="http://schemas.openxmlformats.org/officeDocument/2006/relationships" xmlns:a="http://schemas.openxmlformats.org/drawingml/2006/main" r:embed="R2d8b7486c81f4d03">
+          <a:blip xmlns:r="http://schemas.openxmlformats.org/officeDocument/2006/relationships" xmlns:a="http://schemas.openxmlformats.org/drawingml/2006/main" r:embed="Rfbc17be18277415d">
             <a:alphaModFix/>
           </a:blip>
           <a:srcRect xmlns:a="http://schemas.openxmlformats.org/drawingml/2006/main" l="0" t="0" r="0" b="0"/>
@@ -16975,7 +16975,7 @@
           <p:nvPr/>
         </p:nvPicPr>
         <p:blipFill rotWithShape="1">
-          <a:blip xmlns:r="http://schemas.openxmlformats.org/officeDocument/2006/relationships" xmlns:a="http://schemas.openxmlformats.org/drawingml/2006/main" r:embed="R2d8b7486c81f4d03">
+          <a:blip xmlns:r="http://schemas.openxmlformats.org/officeDocument/2006/relationships" xmlns:a="http://schemas.openxmlformats.org/drawingml/2006/main" r:embed="Rfbc17be18277415d">
             <a:alphaModFix/>
           </a:blip>
           <a:srcRect xmlns:a="http://schemas.openxmlformats.org/drawingml/2006/main" l="0" t="0" r="0" b="0"/>
@@ -17003,7 +17003,7 @@
           <p:nvPr/>
         </p:nvPicPr>
         <p:blipFill rotWithShape="1">
-          <a:blip xmlns:r="http://schemas.openxmlformats.org/officeDocument/2006/relationships" xmlns:a="http://schemas.openxmlformats.org/drawingml/2006/main" r:embed="R2d8b7486c81f4d03">
+          <a:blip xmlns:r="http://schemas.openxmlformats.org/officeDocument/2006/relationships" xmlns:a="http://schemas.openxmlformats.org/drawingml/2006/main" r:embed="Rfbc17be18277415d">
             <a:alphaModFix/>
           </a:blip>
           <a:srcRect xmlns:a="http://schemas.openxmlformats.org/drawingml/2006/main" l="0" t="0" r="0" b="0"/>
@@ -17177,7 +17177,7 @@
           <p:nvPr/>
         </p:nvPicPr>
         <p:blipFill>
-          <a:blip xmlns:r="http://schemas.openxmlformats.org/officeDocument/2006/relationships" xmlns:a="http://schemas.openxmlformats.org/drawingml/2006/main" r:embed="R61b29e1b2cb24541">
+          <a:blip xmlns:r="http://schemas.openxmlformats.org/officeDocument/2006/relationships" xmlns:a="http://schemas.openxmlformats.org/drawingml/2006/main" r:embed="R92b77b7bdb3b4ff4">
             <a:alphaModFix/>
           </a:blip>
           <a:stretch xmlns:a="http://schemas.openxmlformats.org/drawingml/2006/main">
@@ -17383,7 +17383,7 @@
           <p:nvPr/>
         </p:nvPicPr>
         <p:blipFill rotWithShape="1">
-          <a:blip xmlns:r="http://schemas.openxmlformats.org/officeDocument/2006/relationships" xmlns:a="http://schemas.openxmlformats.org/drawingml/2006/main" r:embed="R11f214fc67634d94">
+          <a:blip xmlns:r="http://schemas.openxmlformats.org/officeDocument/2006/relationships" xmlns:a="http://schemas.openxmlformats.org/drawingml/2006/main" r:embed="R9d942d9eb0474367">
             <a:alphaModFix/>
           </a:blip>
           <a:srcRect xmlns:a="http://schemas.openxmlformats.org/drawingml/2006/main" l="0" t="0" r="0" b="0"/>
@@ -17411,7 +17411,7 @@
           <p:nvPr/>
         </p:nvPicPr>
         <p:blipFill rotWithShape="1">
-          <a:blip xmlns:r="http://schemas.openxmlformats.org/officeDocument/2006/relationships" xmlns:a="http://schemas.openxmlformats.org/drawingml/2006/main" r:embed="R11f214fc67634d94">
+          <a:blip xmlns:r="http://schemas.openxmlformats.org/officeDocument/2006/relationships" xmlns:a="http://schemas.openxmlformats.org/drawingml/2006/main" r:embed="R9d942d9eb0474367">
             <a:alphaModFix/>
           </a:blip>
           <a:srcRect xmlns:a="http://schemas.openxmlformats.org/drawingml/2006/main" l="0" t="0" r="0" b="0"/>
@@ -17439,7 +17439,7 @@
           <p:nvPr/>
         </p:nvPicPr>
         <p:blipFill rotWithShape="1">
-          <a:blip xmlns:r="http://schemas.openxmlformats.org/officeDocument/2006/relationships" xmlns:a="http://schemas.openxmlformats.org/drawingml/2006/main" r:embed="R11f214fc67634d94">
+          <a:blip xmlns:r="http://schemas.openxmlformats.org/officeDocument/2006/relationships" xmlns:a="http://schemas.openxmlformats.org/drawingml/2006/main" r:embed="R9d942d9eb0474367">
             <a:alphaModFix/>
           </a:blip>
           <a:srcRect xmlns:a="http://schemas.openxmlformats.org/drawingml/2006/main" l="0" t="0" r="0" b="0"/>
@@ -17782,7 +17782,7 @@
           <p:nvPr/>
         </p:nvPicPr>
         <p:blipFill rotWithShape="1">
-          <a:blip xmlns:r="http://schemas.openxmlformats.org/officeDocument/2006/relationships" xmlns:a="http://schemas.openxmlformats.org/drawingml/2006/main" r:embed="R31e05aeda21d47ac">
+          <a:blip xmlns:r="http://schemas.openxmlformats.org/officeDocument/2006/relationships" xmlns:a="http://schemas.openxmlformats.org/drawingml/2006/main" r:embed="R61044bd001aa4b99">
             <a:alphaModFix/>
           </a:blip>
           <a:srcRect xmlns:a="http://schemas.openxmlformats.org/drawingml/2006/main" l="0" t="0" r="0" b="0"/>
@@ -17810,7 +17810,7 @@
           <p:nvPr/>
         </p:nvPicPr>
         <p:blipFill rotWithShape="1">
-          <a:blip xmlns:r="http://schemas.openxmlformats.org/officeDocument/2006/relationships" xmlns:a="http://schemas.openxmlformats.org/drawingml/2006/main" r:embed="R31e05aeda21d47ac">
+          <a:blip xmlns:r="http://schemas.openxmlformats.org/officeDocument/2006/relationships" xmlns:a="http://schemas.openxmlformats.org/drawingml/2006/main" r:embed="R61044bd001aa4b99">
             <a:alphaModFix/>
           </a:blip>
           <a:srcRect xmlns:a="http://schemas.openxmlformats.org/drawingml/2006/main" l="0" t="0" r="0" b="0"/>
@@ -17838,7 +17838,7 @@
           <p:nvPr/>
         </p:nvPicPr>
         <p:blipFill rotWithShape="1">
-          <a:blip xmlns:r="http://schemas.openxmlformats.org/officeDocument/2006/relationships" xmlns:a="http://schemas.openxmlformats.org/drawingml/2006/main" r:embed="R31e05aeda21d47ac">
+          <a:blip xmlns:r="http://schemas.openxmlformats.org/officeDocument/2006/relationships" xmlns:a="http://schemas.openxmlformats.org/drawingml/2006/main" r:embed="R61044bd001aa4b99">
             <a:alphaModFix/>
           </a:blip>
           <a:srcRect xmlns:a="http://schemas.openxmlformats.org/drawingml/2006/main" l="0" t="0" r="0" b="0"/>
@@ -17866,7 +17866,7 @@
           <p:nvPr/>
         </p:nvPicPr>
         <p:blipFill>
-          <a:blip xmlns:r="http://schemas.openxmlformats.org/officeDocument/2006/relationships" xmlns:a="http://schemas.openxmlformats.org/drawingml/2006/main" r:embed="R605570cb62394900">
+          <a:blip xmlns:r="http://schemas.openxmlformats.org/officeDocument/2006/relationships" xmlns:a="http://schemas.openxmlformats.org/drawingml/2006/main" r:embed="R9be07841e3e646be">
             <a:alphaModFix/>
           </a:blip>
           <a:stretch xmlns:a="http://schemas.openxmlformats.org/drawingml/2006/main">
@@ -18118,7 +18118,7 @@
           <p:nvPr/>
         </p:nvPicPr>
         <p:blipFill rotWithShape="1">
-          <a:blip xmlns:r="http://schemas.openxmlformats.org/officeDocument/2006/relationships" xmlns:a="http://schemas.openxmlformats.org/drawingml/2006/main" r:embed="R4ea9eb275a934048">
+          <a:blip xmlns:r="http://schemas.openxmlformats.org/officeDocument/2006/relationships" xmlns:a="http://schemas.openxmlformats.org/drawingml/2006/main" r:embed="Ra2f865a2f7bf4dc3">
             <a:alphaModFix/>
           </a:blip>
           <a:srcRect xmlns:a="http://schemas.openxmlformats.org/drawingml/2006/main" l="0" t="0" r="0" b="0"/>
@@ -18467,7 +18467,7 @@
           <p:nvPr/>
         </p:nvPicPr>
         <p:blipFill rotWithShape="1">
-          <a:blip xmlns:r="http://schemas.openxmlformats.org/officeDocument/2006/relationships" xmlns:a="http://schemas.openxmlformats.org/drawingml/2006/main" r:embed="Rdc861fe0eb764858">
+          <a:blip xmlns:r="http://schemas.openxmlformats.org/officeDocument/2006/relationships" xmlns:a="http://schemas.openxmlformats.org/drawingml/2006/main" r:embed="Ref18d61de1e84801">
             <a:alphaModFix/>
           </a:blip>
           <a:srcRect xmlns:a="http://schemas.openxmlformats.org/drawingml/2006/main" l="0" t="0" r="0" b="0"/>
@@ -18495,7 +18495,7 @@
           <p:nvPr/>
         </p:nvPicPr>
         <p:blipFill rotWithShape="1">
-          <a:blip xmlns:r="http://schemas.openxmlformats.org/officeDocument/2006/relationships" xmlns:a="http://schemas.openxmlformats.org/drawingml/2006/main" r:embed="Rdc861fe0eb764858">
+          <a:blip xmlns:r="http://schemas.openxmlformats.org/officeDocument/2006/relationships" xmlns:a="http://schemas.openxmlformats.org/drawingml/2006/main" r:embed="Ref18d61de1e84801">
             <a:alphaModFix/>
           </a:blip>
           <a:srcRect xmlns:a="http://schemas.openxmlformats.org/drawingml/2006/main" l="0" t="0" r="0" b="0"/>
@@ -18523,7 +18523,7 @@
           <p:nvPr/>
         </p:nvPicPr>
         <p:blipFill rotWithShape="1">
-          <a:blip xmlns:r="http://schemas.openxmlformats.org/officeDocument/2006/relationships" xmlns:a="http://schemas.openxmlformats.org/drawingml/2006/main" r:embed="Rdc861fe0eb764858">
+          <a:blip xmlns:r="http://schemas.openxmlformats.org/officeDocument/2006/relationships" xmlns:a="http://schemas.openxmlformats.org/drawingml/2006/main" r:embed="Ref18d61de1e84801">
             <a:alphaModFix/>
           </a:blip>
           <a:srcRect xmlns:a="http://schemas.openxmlformats.org/drawingml/2006/main" l="0" t="0" r="0" b="0"/>
@@ -18551,7 +18551,7 @@
           <p:nvPr/>
         </p:nvPicPr>
         <p:blipFill rotWithShape="1">
-          <a:blip xmlns:r="http://schemas.openxmlformats.org/officeDocument/2006/relationships" xmlns:a="http://schemas.openxmlformats.org/drawingml/2006/main" r:embed="Rdc861fe0eb764858">
+          <a:blip xmlns:r="http://schemas.openxmlformats.org/officeDocument/2006/relationships" xmlns:a="http://schemas.openxmlformats.org/drawingml/2006/main" r:embed="Ref18d61de1e84801">
             <a:alphaModFix/>
           </a:blip>
           <a:srcRect xmlns:a="http://schemas.openxmlformats.org/drawingml/2006/main" l="0" t="0" r="0" b="0"/>
@@ -18638,7 +18638,7 @@
           <p:nvPr/>
         </p:nvPicPr>
         <p:blipFill>
-          <a:blip xmlns:r="http://schemas.openxmlformats.org/officeDocument/2006/relationships" xmlns:a="http://schemas.openxmlformats.org/drawingml/2006/main" r:embed="R07ff25f021ac4a6a">
+          <a:blip xmlns:r="http://schemas.openxmlformats.org/officeDocument/2006/relationships" xmlns:a="http://schemas.openxmlformats.org/drawingml/2006/main" r:embed="R24a67a9875d14d26">
             <a:alphaModFix/>
           </a:blip>
           <a:stretch xmlns:a="http://schemas.openxmlformats.org/drawingml/2006/main">
@@ -18696,7 +18696,7 @@
           <p:nvPr/>
         </p:nvPicPr>
         <p:blipFill rotWithShape="1">
-          <a:blip xmlns:r="http://schemas.openxmlformats.org/officeDocument/2006/relationships" xmlns:a="http://schemas.openxmlformats.org/drawingml/2006/main" r:embed="R44cfe7fdc28f4908">
+          <a:blip xmlns:r="http://schemas.openxmlformats.org/officeDocument/2006/relationships" xmlns:a="http://schemas.openxmlformats.org/drawingml/2006/main" r:embed="R0d57c4d5d189429d">
             <a:alphaModFix/>
           </a:blip>
           <a:srcRect xmlns:a="http://schemas.openxmlformats.org/drawingml/2006/main" l="0" t="0" r="0" b="0"/>
@@ -19141,7 +19141,7 @@
           <p:nvPr/>
         </p:nvPicPr>
         <p:blipFill rotWithShape="1">
-          <a:blip xmlns:r="http://schemas.openxmlformats.org/officeDocument/2006/relationships" xmlns:a="http://schemas.openxmlformats.org/drawingml/2006/main" r:embed="Rcd8691fa42bd4eaa">
+          <a:blip xmlns:r="http://schemas.openxmlformats.org/officeDocument/2006/relationships" xmlns:a="http://schemas.openxmlformats.org/drawingml/2006/main" r:embed="R372f995b96da4d19">
             <a:alphaModFix/>
           </a:blip>
           <a:srcRect xmlns:a="http://schemas.openxmlformats.org/drawingml/2006/main" l="0" t="0" r="0" b="0"/>
@@ -19169,7 +19169,7 @@
           <p:nvPr/>
         </p:nvPicPr>
         <p:blipFill rotWithShape="1">
-          <a:blip xmlns:r="http://schemas.openxmlformats.org/officeDocument/2006/relationships" xmlns:a="http://schemas.openxmlformats.org/drawingml/2006/main" r:embed="Rcd8691fa42bd4eaa">
+          <a:blip xmlns:r="http://schemas.openxmlformats.org/officeDocument/2006/relationships" xmlns:a="http://schemas.openxmlformats.org/drawingml/2006/main" r:embed="R372f995b96da4d19">
             <a:alphaModFix/>
           </a:blip>
           <a:srcRect xmlns:a="http://schemas.openxmlformats.org/drawingml/2006/main" l="0" t="0" r="0" b="0"/>
@@ -19197,7 +19197,7 @@
           <p:nvPr/>
         </p:nvPicPr>
         <p:blipFill rotWithShape="1">
-          <a:blip xmlns:r="http://schemas.openxmlformats.org/officeDocument/2006/relationships" xmlns:a="http://schemas.openxmlformats.org/drawingml/2006/main" r:embed="Rcd8691fa42bd4eaa">
+          <a:blip xmlns:r="http://schemas.openxmlformats.org/officeDocument/2006/relationships" xmlns:a="http://schemas.openxmlformats.org/drawingml/2006/main" r:embed="R372f995b96da4d19">
             <a:alphaModFix/>
           </a:blip>
           <a:srcRect xmlns:a="http://schemas.openxmlformats.org/drawingml/2006/main" l="0" t="0" r="0" b="0"/>
@@ -19225,7 +19225,7 @@
           <p:nvPr/>
         </p:nvPicPr>
         <p:blipFill rotWithShape="1">
-          <a:blip xmlns:r="http://schemas.openxmlformats.org/officeDocument/2006/relationships" xmlns:a="http://schemas.openxmlformats.org/drawingml/2006/main" r:embed="Rcd8691fa42bd4eaa">
+          <a:blip xmlns:r="http://schemas.openxmlformats.org/officeDocument/2006/relationships" xmlns:a="http://schemas.openxmlformats.org/drawingml/2006/main" r:embed="R372f995b96da4d19">
             <a:alphaModFix/>
           </a:blip>
           <a:srcRect xmlns:a="http://schemas.openxmlformats.org/drawingml/2006/main" l="0" t="0" r="0" b="0"/>
@@ -19312,7 +19312,7 @@
           <p:nvPr/>
         </p:nvPicPr>
         <p:blipFill>
-          <a:blip xmlns:r="http://schemas.openxmlformats.org/officeDocument/2006/relationships" xmlns:a="http://schemas.openxmlformats.org/drawingml/2006/main" r:embed="R09e713ab8a1c4fb2">
+          <a:blip xmlns:r="http://schemas.openxmlformats.org/officeDocument/2006/relationships" xmlns:a="http://schemas.openxmlformats.org/drawingml/2006/main" r:embed="R693312c0bc144a44">
             <a:alphaModFix/>
           </a:blip>
           <a:stretch xmlns:a="http://schemas.openxmlformats.org/drawingml/2006/main">
@@ -19370,7 +19370,7 @@
           <p:nvPr/>
         </p:nvPicPr>
         <p:blipFill rotWithShape="1">
-          <a:blip xmlns:r="http://schemas.openxmlformats.org/officeDocument/2006/relationships" xmlns:a="http://schemas.openxmlformats.org/drawingml/2006/main" r:embed="R5468a54c889047dd">
+          <a:blip xmlns:r="http://schemas.openxmlformats.org/officeDocument/2006/relationships" xmlns:a="http://schemas.openxmlformats.org/drawingml/2006/main" r:embed="Ra4c1ebea94bf4212">
             <a:alphaModFix/>
           </a:blip>
           <a:srcRect xmlns:a="http://schemas.openxmlformats.org/drawingml/2006/main" l="0" t="0" r="0" b="0"/>
@@ -19604,7 +19604,7 @@
           <p:nvPr/>
         </p:nvPicPr>
         <p:blipFill rotWithShape="1">
-          <a:blip xmlns:r="http://schemas.openxmlformats.org/officeDocument/2006/relationships" xmlns:a="http://schemas.openxmlformats.org/drawingml/2006/main" r:embed="R8aef4a5954164f07">
+          <a:blip xmlns:r="http://schemas.openxmlformats.org/officeDocument/2006/relationships" xmlns:a="http://schemas.openxmlformats.org/drawingml/2006/main" r:embed="Rb722e5db2e9c41e5">
             <a:alphaModFix/>
           </a:blip>
           <a:srcRect xmlns:a="http://schemas.openxmlformats.org/drawingml/2006/main" l="0" t="0" r="0" b="0"/>
@@ -20133,7 +20133,7 @@
           <p:nvPr/>
         </p:nvPicPr>
         <p:blipFill rotWithShape="1">
-          <a:blip xmlns:r="http://schemas.openxmlformats.org/officeDocument/2006/relationships" xmlns:a="http://schemas.openxmlformats.org/drawingml/2006/main" r:embed="R8f6655d649714aea">
+          <a:blip xmlns:r="http://schemas.openxmlformats.org/officeDocument/2006/relationships" xmlns:a="http://schemas.openxmlformats.org/drawingml/2006/main" r:embed="R20ece13723e94be0">
             <a:alphaModFix/>
           </a:blip>
           <a:srcRect xmlns:a="http://schemas.openxmlformats.org/drawingml/2006/main" l="0" t="0" r="0" b="0"/>
@@ -20161,7 +20161,7 @@
           <p:nvPr/>
         </p:nvPicPr>
         <p:blipFill rotWithShape="1">
-          <a:blip xmlns:r="http://schemas.openxmlformats.org/officeDocument/2006/relationships" xmlns:a="http://schemas.openxmlformats.org/drawingml/2006/main" r:embed="R8f6655d649714aea">
+          <a:blip xmlns:r="http://schemas.openxmlformats.org/officeDocument/2006/relationships" xmlns:a="http://schemas.openxmlformats.org/drawingml/2006/main" r:embed="R20ece13723e94be0">
             <a:alphaModFix/>
           </a:blip>
           <a:srcRect xmlns:a="http://schemas.openxmlformats.org/drawingml/2006/main" l="0" t="0" r="0" b="0"/>
@@ -20189,7 +20189,7 @@
           <p:nvPr/>
         </p:nvPicPr>
         <p:blipFill rotWithShape="1">
-          <a:blip xmlns:r="http://schemas.openxmlformats.org/officeDocument/2006/relationships" xmlns:a="http://schemas.openxmlformats.org/drawingml/2006/main" r:embed="R8f6655d649714aea">
+          <a:blip xmlns:r="http://schemas.openxmlformats.org/officeDocument/2006/relationships" xmlns:a="http://schemas.openxmlformats.org/drawingml/2006/main" r:embed="R20ece13723e94be0">
             <a:alphaModFix/>
           </a:blip>
           <a:srcRect xmlns:a="http://schemas.openxmlformats.org/drawingml/2006/main" l="0" t="0" r="0" b="0"/>
@@ -20217,7 +20217,7 @@
           <p:nvPr/>
         </p:nvPicPr>
         <p:blipFill rotWithShape="1">
-          <a:blip xmlns:r="http://schemas.openxmlformats.org/officeDocument/2006/relationships" xmlns:a="http://schemas.openxmlformats.org/drawingml/2006/main" r:embed="R8f6655d649714aea">
+          <a:blip xmlns:r="http://schemas.openxmlformats.org/officeDocument/2006/relationships" xmlns:a="http://schemas.openxmlformats.org/drawingml/2006/main" r:embed="R20ece13723e94be0">
             <a:alphaModFix/>
           </a:blip>
           <a:srcRect xmlns:a="http://schemas.openxmlformats.org/drawingml/2006/main" l="0" t="0" r="0" b="0"/>
@@ -20304,7 +20304,7 @@
           <p:nvPr/>
         </p:nvPicPr>
         <p:blipFill>
-          <a:blip xmlns:r="http://schemas.openxmlformats.org/officeDocument/2006/relationships" xmlns:a="http://schemas.openxmlformats.org/drawingml/2006/main" r:embed="Ra8ec5c6cb0f548f3">
+          <a:blip xmlns:r="http://schemas.openxmlformats.org/officeDocument/2006/relationships" xmlns:a="http://schemas.openxmlformats.org/drawingml/2006/main" r:embed="R809f72ff51f74c99">
             <a:alphaModFix/>
           </a:blip>
           <a:stretch xmlns:a="http://schemas.openxmlformats.org/drawingml/2006/main">
@@ -21958,7 +21958,7 @@
           <p:nvPr/>
         </p:nvPicPr>
         <p:blipFill rotWithShape="1">
-          <a:blip xmlns:r="http://schemas.openxmlformats.org/officeDocument/2006/relationships" xmlns:a="http://schemas.openxmlformats.org/drawingml/2006/main" r:embed="R8a13ed17ffa04990">
+          <a:blip xmlns:r="http://schemas.openxmlformats.org/officeDocument/2006/relationships" xmlns:a="http://schemas.openxmlformats.org/drawingml/2006/main" r:embed="R37dbebf0ac864c24">
             <a:alphaModFix/>
           </a:blip>
           <a:srcRect xmlns:a="http://schemas.openxmlformats.org/drawingml/2006/main" l="0" t="0" r="0" b="0"/>
@@ -22240,7 +22240,7 @@
           <p:nvPr/>
         </p:nvPicPr>
         <p:blipFill rotWithShape="1">
-          <a:blip xmlns:r="http://schemas.openxmlformats.org/officeDocument/2006/relationships" xmlns:a="http://schemas.openxmlformats.org/drawingml/2006/main" r:embed="Rca6e3eb5886a48f1">
+          <a:blip xmlns:r="http://schemas.openxmlformats.org/officeDocument/2006/relationships" xmlns:a="http://schemas.openxmlformats.org/drawingml/2006/main" r:embed="Rf40af90b96894245">
             <a:alphaModFix/>
           </a:blip>
           <a:srcRect xmlns:a="http://schemas.openxmlformats.org/drawingml/2006/main" l="0" t="0" r="0" b="0"/>
@@ -22423,7 +22423,7 @@
                 <a:latin typeface="Manrope"/>
                 <a:ea typeface="Manrope"/>
                 <a:cs typeface="Manrope"/>
-                <a:hlinkClick xmlns:r="http://schemas.openxmlformats.org/officeDocument/2006/relationships" r:id="R6f7fa9940ee545b9"/>
+                <a:hlinkClick xmlns:r="http://schemas.openxmlformats.org/officeDocument/2006/relationships" r:id="Rdf1a0005d6294006"/>
               </a:rPr>
               <a:t>https</a:t>
             </a:r>
@@ -22435,7 +22435,7 @@
                 <a:latin typeface="Manrope"/>
                 <a:ea typeface="Manrope"/>
                 <a:cs typeface="Manrope"/>
-                <a:hlinkClick xmlns:r="http://schemas.openxmlformats.org/officeDocument/2006/relationships" r:id="R510aef5d80de4447"/>
+                <a:hlinkClick xmlns:r="http://schemas.openxmlformats.org/officeDocument/2006/relationships" r:id="R7e38b34db1da48ac"/>
               </a:rPr>
               <a:t>://www.theweathernetwork.com/en/news/weather/severe/how-the-30-30-30-rule-is-essential-for-wildfire-safety</a:t>
             </a:r>
@@ -22466,7 +22466,7 @@
                 <a:latin typeface="Manrope"/>
                 <a:ea typeface="Manrope"/>
                 <a:cs typeface="Manrope"/>
-                <a:hlinkClick xmlns:r="http://schemas.openxmlformats.org/officeDocument/2006/relationships" r:id="R7231d723cc384534"/>
+                <a:hlinkClick xmlns:r="http://schemas.openxmlformats.org/officeDocument/2006/relationships" r:id="R70c353bcdbef4f92"/>
               </a:rPr>
               <a:t>https://www.weather.gov/safety/wildfire-ww</a:t>
             </a:r>
@@ -22497,7 +22497,7 @@
                 <a:latin typeface="Manrope"/>
                 <a:ea typeface="Manrope"/>
                 <a:cs typeface="Manrope"/>
-                <a:hlinkClick xmlns:r="http://schemas.openxmlformats.org/officeDocument/2006/relationships" r:id="Rf5a037fed0e64f61"/>
+                <a:hlinkClick xmlns:r="http://schemas.openxmlformats.org/officeDocument/2006/relationships" r:id="R74937584e9ab455d"/>
               </a:rPr>
               <a:t>https://www.weather.gov/fire/</a:t>
             </a:r>
@@ -22528,7 +22528,7 @@
                 <a:latin typeface="Manrope"/>
                 <a:ea typeface="Manrope"/>
                 <a:cs typeface="Manrope"/>
-                <a:hlinkClick xmlns:r="http://schemas.openxmlformats.org/officeDocument/2006/relationships" r:id="Rc40b052cbe52490b"/>
+                <a:hlinkClick xmlns:r="http://schemas.openxmlformats.org/officeDocument/2006/relationships" r:id="R54c2a4bdf0d04084"/>
               </a:rPr>
               <a:t>https://firms.modaps.eosdis.nasa.gov/</a:t>
             </a:r>
@@ -22559,7 +22559,7 @@
                 <a:latin typeface="Manrope"/>
                 <a:ea typeface="Manrope"/>
                 <a:cs typeface="Manrope"/>
-                <a:hlinkClick xmlns:r="http://schemas.openxmlformats.org/officeDocument/2006/relationships" r:id="Rc2bf7064ed6d4101"/>
+                <a:hlinkClick xmlns:r="http://schemas.openxmlformats.org/officeDocument/2006/relationships" r:id="R5eb5fbcbc13f45bf"/>
               </a:rPr>
               <a:t>https://archive.ics.uci.edu/dataset/162/forest+fires</a:t>
             </a:r>
@@ -22590,7 +22590,7 @@
                 <a:latin typeface="Manrope"/>
                 <a:ea typeface="Manrope"/>
                 <a:cs typeface="Manrope"/>
-                <a:hlinkClick xmlns:r="http://schemas.openxmlformats.org/officeDocument/2006/relationships" r:id="Rbcc41795f8c044cd"/>
+                <a:hlinkClick xmlns:r="http://schemas.openxmlformats.org/officeDocument/2006/relationships" r:id="Rf13b30339c4f4930"/>
               </a:rPr>
               <a:t>https://www.kaggle.com/datasets/pankrzysiu/weather-archive-jena</a:t>
             </a:r>
@@ -22621,7 +22621,7 @@
                 <a:latin typeface="Manrope"/>
                 <a:ea typeface="Manrope"/>
                 <a:cs typeface="Manrope"/>
-                <a:hlinkClick xmlns:r="http://schemas.openxmlformats.org/officeDocument/2006/relationships" r:id="Recbc8cf12d7f416b"/>
+                <a:hlinkClick xmlns:r="http://schemas.openxmlformats.org/officeDocument/2006/relationships" r:id="R7cbed1ee7df74f68"/>
               </a:rPr>
               <a:t>https://www.w3schools.com/python/</a:t>
             </a:r>
@@ -22694,7 +22694,7 @@
           <p:nvPr/>
         </p:nvPicPr>
         <p:blipFill rotWithShape="1">
-          <a:blip xmlns:r="http://schemas.openxmlformats.org/officeDocument/2006/relationships" xmlns:a="http://schemas.openxmlformats.org/drawingml/2006/main" r:embed="R510997d2b952467e">
+          <a:blip xmlns:r="http://schemas.openxmlformats.org/officeDocument/2006/relationships" xmlns:a="http://schemas.openxmlformats.org/drawingml/2006/main" r:embed="R5d89b4cc29104e68">
             <a:alphaModFix/>
           </a:blip>
           <a:srcRect xmlns:a="http://schemas.openxmlformats.org/drawingml/2006/main" l="0" t="0" r="0" b="0"/>
@@ -22722,7 +22722,7 @@
           <p:nvPr/>
         </p:nvPicPr>
         <p:blipFill rotWithShape="1">
-          <a:blip xmlns:r="http://schemas.openxmlformats.org/officeDocument/2006/relationships" xmlns:a="http://schemas.openxmlformats.org/drawingml/2006/main" r:embed="R7c655255e17d4a46">
+          <a:blip xmlns:r="http://schemas.openxmlformats.org/officeDocument/2006/relationships" xmlns:a="http://schemas.openxmlformats.org/drawingml/2006/main" r:embed="Rde8f70e4603c487c">
             <a:alphaModFix/>
           </a:blip>
           <a:srcRect xmlns:a="http://schemas.openxmlformats.org/drawingml/2006/main" l="0" t="0" r="0" b="0"/>
@@ -22750,7 +22750,7 @@
           <p:nvPr/>
         </p:nvPicPr>
         <p:blipFill rotWithShape="1">
-          <a:blip xmlns:r="http://schemas.openxmlformats.org/officeDocument/2006/relationships" xmlns:a="http://schemas.openxmlformats.org/drawingml/2006/main" r:embed="Rff37683d97884ea9">
+          <a:blip xmlns:r="http://schemas.openxmlformats.org/officeDocument/2006/relationships" xmlns:a="http://schemas.openxmlformats.org/drawingml/2006/main" r:embed="R1fb71c1a8fe9438b">
             <a:alphaModFix/>
           </a:blip>
           <a:srcRect xmlns:a="http://schemas.openxmlformats.org/drawingml/2006/main" l="0" t="0" r="0" b="0"/>
@@ -22778,7 +22778,7 @@
           <p:nvPr/>
         </p:nvPicPr>
         <p:blipFill rotWithShape="1">
-          <a:blip xmlns:r="http://schemas.openxmlformats.org/officeDocument/2006/relationships" xmlns:a="http://schemas.openxmlformats.org/drawingml/2006/main" r:embed="Ra8cac8dc4cef4f17">
+          <a:blip xmlns:r="http://schemas.openxmlformats.org/officeDocument/2006/relationships" xmlns:a="http://schemas.openxmlformats.org/drawingml/2006/main" r:embed="R375cca847cb644ed">
             <a:alphaModFix/>
           </a:blip>
           <a:srcRect xmlns:a="http://schemas.openxmlformats.org/drawingml/2006/main" l="0" t="0" r="0" b="0"/>
@@ -22806,7 +22806,7 @@
           <p:nvPr/>
         </p:nvPicPr>
         <p:blipFill rotWithShape="1">
-          <a:blip xmlns:r="http://schemas.openxmlformats.org/officeDocument/2006/relationships" xmlns:a="http://schemas.openxmlformats.org/drawingml/2006/main" r:embed="Rcddc9edce1ca4d89">
+          <a:blip xmlns:r="http://schemas.openxmlformats.org/officeDocument/2006/relationships" xmlns:a="http://schemas.openxmlformats.org/drawingml/2006/main" r:embed="R874274fbd0a84f0f">
             <a:alphaModFix/>
           </a:blip>
           <a:srcRect xmlns:a="http://schemas.openxmlformats.org/drawingml/2006/main" l="0" t="0" r="0" b="0"/>
@@ -22834,7 +22834,7 @@
           <p:nvPr/>
         </p:nvPicPr>
         <p:blipFill rotWithShape="1">
-          <a:blip xmlns:r="http://schemas.openxmlformats.org/officeDocument/2006/relationships" xmlns:a="http://schemas.openxmlformats.org/drawingml/2006/main" r:embed="Ra4ea2d247d084804">
+          <a:blip xmlns:r="http://schemas.openxmlformats.org/officeDocument/2006/relationships" xmlns:a="http://schemas.openxmlformats.org/drawingml/2006/main" r:embed="R1003b7cddaaa4950">
             <a:alphaModFix/>
           </a:blip>
           <a:srcRect xmlns:a="http://schemas.openxmlformats.org/drawingml/2006/main" l="0" t="0" r="0" b="0"/>
@@ -22862,7 +22862,7 @@
           <p:nvPr/>
         </p:nvPicPr>
         <p:blipFill rotWithShape="1">
-          <a:blip xmlns:r="http://schemas.openxmlformats.org/officeDocument/2006/relationships" xmlns:a="http://schemas.openxmlformats.org/drawingml/2006/main" r:embed="Rd7d5c5ad08ad4f61">
+          <a:blip xmlns:r="http://schemas.openxmlformats.org/officeDocument/2006/relationships" xmlns:a="http://schemas.openxmlformats.org/drawingml/2006/main" r:embed="R412eee62d76f443a">
             <a:alphaModFix/>
           </a:blip>
           <a:srcRect xmlns:a="http://schemas.openxmlformats.org/drawingml/2006/main" l="0" t="0" r="0" b="0"/>
@@ -22890,7 +22890,7 @@
           <p:nvPr/>
         </p:nvPicPr>
         <p:blipFill rotWithShape="1">
-          <a:blip xmlns:r="http://schemas.openxmlformats.org/officeDocument/2006/relationships" xmlns:a="http://schemas.openxmlformats.org/drawingml/2006/main" r:embed="Rdd1844092af5405d">
+          <a:blip xmlns:r="http://schemas.openxmlformats.org/officeDocument/2006/relationships" xmlns:a="http://schemas.openxmlformats.org/drawingml/2006/main" r:embed="R5e290dd646d14e00">
             <a:alphaModFix/>
           </a:blip>
           <a:srcRect xmlns:a="http://schemas.openxmlformats.org/drawingml/2006/main" l="0" t="0" r="0" b="0"/>
@@ -22918,7 +22918,7 @@
           <p:nvPr/>
         </p:nvPicPr>
         <p:blipFill rotWithShape="1">
-          <a:blip xmlns:r="http://schemas.openxmlformats.org/officeDocument/2006/relationships" xmlns:a="http://schemas.openxmlformats.org/drawingml/2006/main" r:embed="R7247be3592c8409f">
+          <a:blip xmlns:r="http://schemas.openxmlformats.org/officeDocument/2006/relationships" xmlns:a="http://schemas.openxmlformats.org/drawingml/2006/main" r:embed="R7447bd8deb8f4331">
             <a:alphaModFix/>
           </a:blip>
           <a:srcRect xmlns:a="http://schemas.openxmlformats.org/drawingml/2006/main" l="0" t="0" r="0" b="0"/>
@@ -23643,7 +23643,7 @@
           <p:nvPr/>
         </p:nvPicPr>
         <p:blipFill rotWithShape="1">
-          <a:blip xmlns:r="http://schemas.openxmlformats.org/officeDocument/2006/relationships" xmlns:a="http://schemas.openxmlformats.org/drawingml/2006/main" r:embed="R8f92c3c59f7044f6">
+          <a:blip xmlns:r="http://schemas.openxmlformats.org/officeDocument/2006/relationships" xmlns:a="http://schemas.openxmlformats.org/drawingml/2006/main" r:embed="Ra0826e3afe82420a">
             <a:alphaModFix/>
           </a:blip>
           <a:srcRect xmlns:a="http://schemas.openxmlformats.org/drawingml/2006/main" l="0" t="0" r="0" b="0"/>
@@ -23727,7 +23727,7 @@
           <p:nvPr/>
         </p:nvPicPr>
         <p:blipFill rotWithShape="1">
-          <a:blip xmlns:r="http://schemas.openxmlformats.org/officeDocument/2006/relationships" xmlns:a="http://schemas.openxmlformats.org/drawingml/2006/main" r:embed="R92323c5212034e0c">
+          <a:blip xmlns:r="http://schemas.openxmlformats.org/officeDocument/2006/relationships" xmlns:a="http://schemas.openxmlformats.org/drawingml/2006/main" r:embed="R94225df1c9404845">
             <a:alphaModFix/>
           </a:blip>
           <a:srcRect xmlns:a="http://schemas.openxmlformats.org/drawingml/2006/main" l="0" t="0" r="0" b="0"/>
@@ -23811,7 +23811,7 @@
           <p:nvPr/>
         </p:nvPicPr>
         <p:blipFill rotWithShape="1">
-          <a:blip xmlns:r="http://schemas.openxmlformats.org/officeDocument/2006/relationships" xmlns:a="http://schemas.openxmlformats.org/drawingml/2006/main" r:embed="Rdf8215c4570440c3">
+          <a:blip xmlns:r="http://schemas.openxmlformats.org/officeDocument/2006/relationships" xmlns:a="http://schemas.openxmlformats.org/drawingml/2006/main" r:embed="Rcb5a108584254e08">
             <a:alphaModFix/>
           </a:blip>
           <a:srcRect xmlns:a="http://schemas.openxmlformats.org/drawingml/2006/main" l="0" t="0" r="0" b="0"/>
@@ -23895,7 +23895,7 @@
           <p:nvPr/>
         </p:nvPicPr>
         <p:blipFill rotWithShape="1">
-          <a:blip xmlns:r="http://schemas.openxmlformats.org/officeDocument/2006/relationships" xmlns:a="http://schemas.openxmlformats.org/drawingml/2006/main" r:embed="Rcb423dc2c1af4f29">
+          <a:blip xmlns:r="http://schemas.openxmlformats.org/officeDocument/2006/relationships" xmlns:a="http://schemas.openxmlformats.org/drawingml/2006/main" r:embed="R55aba92deb9a45ff">
             <a:alphaModFix/>
           </a:blip>
           <a:srcRect xmlns:a="http://schemas.openxmlformats.org/drawingml/2006/main" l="0" t="0" r="0" b="0"/>
@@ -23979,7 +23979,7 @@
           <p:nvPr/>
         </p:nvPicPr>
         <p:blipFill rotWithShape="1">
-          <a:blip xmlns:r="http://schemas.openxmlformats.org/officeDocument/2006/relationships" xmlns:a="http://schemas.openxmlformats.org/drawingml/2006/main" r:embed="Rfbbb9b22e8624d5d">
+          <a:blip xmlns:r="http://schemas.openxmlformats.org/officeDocument/2006/relationships" xmlns:a="http://schemas.openxmlformats.org/drawingml/2006/main" r:embed="R219fa6f5bdc44a58">
             <a:alphaModFix/>
           </a:blip>
           <a:srcRect xmlns:a="http://schemas.openxmlformats.org/drawingml/2006/main" l="0" t="0" r="0" b="0"/>
@@ -24063,7 +24063,7 @@
           <p:nvPr/>
         </p:nvPicPr>
         <p:blipFill rotWithShape="1">
-          <a:blip xmlns:r="http://schemas.openxmlformats.org/officeDocument/2006/relationships" xmlns:a="http://schemas.openxmlformats.org/drawingml/2006/main" r:embed="R95561ffa9bf743e9">
+          <a:blip xmlns:r="http://schemas.openxmlformats.org/officeDocument/2006/relationships" xmlns:a="http://schemas.openxmlformats.org/drawingml/2006/main" r:embed="R62eef5ecf8064fa8">
             <a:alphaModFix/>
           </a:blip>
           <a:srcRect xmlns:a="http://schemas.openxmlformats.org/drawingml/2006/main" l="0" t="0" r="0" b="0"/>
@@ -24147,7 +24147,7 @@
           <p:nvPr/>
         </p:nvPicPr>
         <p:blipFill rotWithShape="1">
-          <a:blip xmlns:r="http://schemas.openxmlformats.org/officeDocument/2006/relationships" xmlns:a="http://schemas.openxmlformats.org/drawingml/2006/main" r:embed="Rdee4d3d987c84a28">
+          <a:blip xmlns:r="http://schemas.openxmlformats.org/officeDocument/2006/relationships" xmlns:a="http://schemas.openxmlformats.org/drawingml/2006/main" r:embed="R41a87a90678443f0">
             <a:alphaModFix/>
           </a:blip>
           <a:srcRect xmlns:a="http://schemas.openxmlformats.org/drawingml/2006/main" l="0" t="0" r="0" b="0"/>
@@ -24231,7 +24231,7 @@
           <p:nvPr/>
         </p:nvPicPr>
         <p:blipFill rotWithShape="1">
-          <a:blip xmlns:r="http://schemas.openxmlformats.org/officeDocument/2006/relationships" xmlns:a="http://schemas.openxmlformats.org/drawingml/2006/main" r:embed="Rc1ee1b60a751421c">
+          <a:blip xmlns:r="http://schemas.openxmlformats.org/officeDocument/2006/relationships" xmlns:a="http://schemas.openxmlformats.org/drawingml/2006/main" r:embed="R757b21ad331848b8">
             <a:alphaModFix/>
           </a:blip>
           <a:srcRect xmlns:a="http://schemas.openxmlformats.org/drawingml/2006/main" l="0" t="0" r="0" b="0"/>
@@ -24315,7 +24315,7 @@
           <p:nvPr/>
         </p:nvPicPr>
         <p:blipFill rotWithShape="1">
-          <a:blip xmlns:r="http://schemas.openxmlformats.org/officeDocument/2006/relationships" xmlns:a="http://schemas.openxmlformats.org/drawingml/2006/main" r:embed="R6d78ec46c2f34a74">
+          <a:blip xmlns:r="http://schemas.openxmlformats.org/officeDocument/2006/relationships" xmlns:a="http://schemas.openxmlformats.org/drawingml/2006/main" r:embed="Rc3cbdc15c1ce4302">
             <a:alphaModFix/>
           </a:blip>
           <a:srcRect xmlns:a="http://schemas.openxmlformats.org/drawingml/2006/main" l="0" t="0" r="0" b="0"/>
@@ -24534,7 +24534,7 @@
           <p:nvPr/>
         </p:nvPicPr>
         <p:blipFill rotWithShape="1">
-          <a:blip xmlns:r="http://schemas.openxmlformats.org/officeDocument/2006/relationships" xmlns:a="http://schemas.openxmlformats.org/drawingml/2006/main" r:embed="R658d66edcde34dc8">
+          <a:blip xmlns:r="http://schemas.openxmlformats.org/officeDocument/2006/relationships" xmlns:a="http://schemas.openxmlformats.org/drawingml/2006/main" r:embed="R7c50bd3432cf4f32">
             <a:alphaModFix/>
           </a:blip>
           <a:srcRect xmlns:a="http://schemas.openxmlformats.org/drawingml/2006/main" l="0" t="0" r="0" b="0"/>
@@ -24562,7 +24562,7 @@
           <p:nvPr/>
         </p:nvPicPr>
         <p:blipFill rotWithShape="1">
-          <a:blip xmlns:r="http://schemas.openxmlformats.org/officeDocument/2006/relationships" xmlns:a="http://schemas.openxmlformats.org/drawingml/2006/main" r:embed="R430e30128062412a">
+          <a:blip xmlns:r="http://schemas.openxmlformats.org/officeDocument/2006/relationships" xmlns:a="http://schemas.openxmlformats.org/drawingml/2006/main" r:embed="R427209be68a84458">
             <a:alphaModFix/>
           </a:blip>
           <a:srcRect xmlns:a="http://schemas.openxmlformats.org/drawingml/2006/main" l="0" t="0" r="0" b="0"/>
@@ -24705,7 +24705,7 @@
           <p:nvPr/>
         </p:nvPicPr>
         <p:blipFill rotWithShape="1">
-          <a:blip xmlns:r="http://schemas.openxmlformats.org/officeDocument/2006/relationships" xmlns:a="http://schemas.openxmlformats.org/drawingml/2006/main" r:embed="R6da47711112645a4">
+          <a:blip xmlns:r="http://schemas.openxmlformats.org/officeDocument/2006/relationships" xmlns:a="http://schemas.openxmlformats.org/drawingml/2006/main" r:embed="R51795c51b86c4af5">
             <a:alphaModFix/>
           </a:blip>
           <a:srcRect xmlns:a="http://schemas.openxmlformats.org/drawingml/2006/main" l="0" t="0" r="0" b="0"/>
@@ -24943,7 +24943,7 @@
           <p:nvPr/>
         </p:nvPicPr>
         <p:blipFill rotWithShape="1">
-          <a:blip xmlns:r="http://schemas.openxmlformats.org/officeDocument/2006/relationships" xmlns:a="http://schemas.openxmlformats.org/drawingml/2006/main" r:embed="R13b31c0a157443c6">
+          <a:blip xmlns:r="http://schemas.openxmlformats.org/officeDocument/2006/relationships" xmlns:a="http://schemas.openxmlformats.org/drawingml/2006/main" r:embed="R85db763b017e493c">
             <a:alphaModFix/>
           </a:blip>
           <a:srcRect xmlns:a="http://schemas.openxmlformats.org/drawingml/2006/main" l="0" t="0" r="0" b="0"/>
@@ -24971,7 +24971,7 @@
           <p:nvPr/>
         </p:nvPicPr>
         <p:blipFill rotWithShape="1">
-          <a:blip xmlns:r="http://schemas.openxmlformats.org/officeDocument/2006/relationships" xmlns:a="http://schemas.openxmlformats.org/drawingml/2006/main" r:embed="R84b70dac80df4cf1">
+          <a:blip xmlns:r="http://schemas.openxmlformats.org/officeDocument/2006/relationships" xmlns:a="http://schemas.openxmlformats.org/drawingml/2006/main" r:embed="R60347da0903f46bf">
             <a:alphaModFix/>
           </a:blip>
           <a:srcRect xmlns:a="http://schemas.openxmlformats.org/drawingml/2006/main" l="0" t="0" r="0" b="0"/>
@@ -24999,7 +24999,7 @@
           <p:nvPr/>
         </p:nvPicPr>
         <p:blipFill rotWithShape="1">
-          <a:blip xmlns:r="http://schemas.openxmlformats.org/officeDocument/2006/relationships" xmlns:a="http://schemas.openxmlformats.org/drawingml/2006/main" r:embed="Re562e0e642394370">
+          <a:blip xmlns:r="http://schemas.openxmlformats.org/officeDocument/2006/relationships" xmlns:a="http://schemas.openxmlformats.org/drawingml/2006/main" r:embed="R28cb6b8744ba4a98">
             <a:alphaModFix/>
           </a:blip>
           <a:srcRect xmlns:a="http://schemas.openxmlformats.org/drawingml/2006/main" l="0" t="0" r="0" b="0"/>
@@ -25162,7 +25162,7 @@
           <p:nvPr/>
         </p:nvPicPr>
         <p:blipFill rotWithShape="1">
-          <a:blip xmlns:r="http://schemas.openxmlformats.org/officeDocument/2006/relationships" xmlns:a="http://schemas.openxmlformats.org/drawingml/2006/main" r:embed="R25d3464de6bc4e5c">
+          <a:blip xmlns:r="http://schemas.openxmlformats.org/officeDocument/2006/relationships" xmlns:a="http://schemas.openxmlformats.org/drawingml/2006/main" r:embed="R798e920fb9094456">
             <a:alphaModFix/>
           </a:blip>
           <a:srcRect xmlns:a="http://schemas.openxmlformats.org/drawingml/2006/main" l="0" t="0" r="0" b="0"/>
@@ -25190,7 +25190,7 @@
           <p:nvPr/>
         </p:nvPicPr>
         <p:blipFill rotWithShape="1">
-          <a:blip xmlns:r="http://schemas.openxmlformats.org/officeDocument/2006/relationships" xmlns:a="http://schemas.openxmlformats.org/drawingml/2006/main" r:embed="R2b22a84d9daa4cbe">
+          <a:blip xmlns:r="http://schemas.openxmlformats.org/officeDocument/2006/relationships" xmlns:a="http://schemas.openxmlformats.org/drawingml/2006/main" r:embed="Rfdbed08e3845462e">
             <a:alphaModFix/>
           </a:blip>
           <a:srcRect xmlns:a="http://schemas.openxmlformats.org/drawingml/2006/main" l="0" t="0" r="0" b="0"/>
@@ -25218,7 +25218,7 @@
           <p:nvPr/>
         </p:nvPicPr>
         <p:blipFill rotWithShape="1">
-          <a:blip xmlns:r="http://schemas.openxmlformats.org/officeDocument/2006/relationships" xmlns:a="http://schemas.openxmlformats.org/drawingml/2006/main" r:embed="Ra5054b647df44c4c">
+          <a:blip xmlns:r="http://schemas.openxmlformats.org/officeDocument/2006/relationships" xmlns:a="http://schemas.openxmlformats.org/drawingml/2006/main" r:embed="R1a3e22fbf6c548de">
             <a:alphaModFix/>
           </a:blip>
           <a:srcRect xmlns:a="http://schemas.openxmlformats.org/drawingml/2006/main" l="0" t="0" r="0" b="0"/>
@@ -25246,7 +25246,7 @@
           <p:nvPr/>
         </p:nvPicPr>
         <p:blipFill rotWithShape="1">
-          <a:blip xmlns:r="http://schemas.openxmlformats.org/officeDocument/2006/relationships" xmlns:a="http://schemas.openxmlformats.org/drawingml/2006/main" r:embed="Rfb0d3706f6eb46ed">
+          <a:blip xmlns:r="http://schemas.openxmlformats.org/officeDocument/2006/relationships" xmlns:a="http://schemas.openxmlformats.org/drawingml/2006/main" r:embed="R548a3770c6d243e7">
             <a:alphaModFix/>
           </a:blip>
           <a:srcRect xmlns:a="http://schemas.openxmlformats.org/drawingml/2006/main" l="0" t="0" r="0" b="0"/>
@@ -25274,7 +25274,7 @@
           <p:nvPr/>
         </p:nvPicPr>
         <p:blipFill rotWithShape="1">
-          <a:blip xmlns:r="http://schemas.openxmlformats.org/officeDocument/2006/relationships" xmlns:a="http://schemas.openxmlformats.org/drawingml/2006/main" r:embed="R5ae83a888fc04766">
+          <a:blip xmlns:r="http://schemas.openxmlformats.org/officeDocument/2006/relationships" xmlns:a="http://schemas.openxmlformats.org/drawingml/2006/main" r:embed="Rbbdc09732d0f4d58">
             <a:alphaModFix/>
           </a:blip>
           <a:srcRect xmlns:a="http://schemas.openxmlformats.org/drawingml/2006/main" l="0" t="0" r="0" b="0"/>
@@ -25417,7 +25417,7 @@
           <p:nvPr/>
         </p:nvPicPr>
         <p:blipFill rotWithShape="1">
-          <a:blip xmlns:r="http://schemas.openxmlformats.org/officeDocument/2006/relationships" xmlns:a="http://schemas.openxmlformats.org/drawingml/2006/main" r:embed="R17218dd7f04f40d4">
+          <a:blip xmlns:r="http://schemas.openxmlformats.org/officeDocument/2006/relationships" xmlns:a="http://schemas.openxmlformats.org/drawingml/2006/main" r:embed="R219e0cea82b84330">
             <a:alphaModFix/>
           </a:blip>
           <a:srcRect xmlns:a="http://schemas.openxmlformats.org/drawingml/2006/main" l="0" t="0" r="0" b="0"/>
@@ -25560,7 +25560,7 @@
           <p:nvPr/>
         </p:nvPicPr>
         <p:blipFill rotWithShape="1">
-          <a:blip xmlns:r="http://schemas.openxmlformats.org/officeDocument/2006/relationships" xmlns:a="http://schemas.openxmlformats.org/drawingml/2006/main" r:embed="Rae32390195b94859">
+          <a:blip xmlns:r="http://schemas.openxmlformats.org/officeDocument/2006/relationships" xmlns:a="http://schemas.openxmlformats.org/drawingml/2006/main" r:embed="Rccc1de4301de4272">
             <a:alphaModFix/>
           </a:blip>
           <a:srcRect xmlns:a="http://schemas.openxmlformats.org/drawingml/2006/main" l="0" t="0" r="0" b="0"/>
@@ -25838,7 +25838,7 @@
           <p:nvPr/>
         </p:nvPicPr>
         <p:blipFill rotWithShape="1">
-          <a:blip xmlns:r="http://schemas.openxmlformats.org/officeDocument/2006/relationships" xmlns:a="http://schemas.openxmlformats.org/drawingml/2006/main" r:embed="R1dbdf1a2ac154d70">
+          <a:blip xmlns:r="http://schemas.openxmlformats.org/officeDocument/2006/relationships" xmlns:a="http://schemas.openxmlformats.org/drawingml/2006/main" r:embed="Rdb3f82386e1644df">
             <a:alphaModFix/>
           </a:blip>
           <a:srcRect xmlns:a="http://schemas.openxmlformats.org/drawingml/2006/main" l="0" t="0" r="0" b="0"/>
@@ -26691,7 +26691,7 @@
           <p:nvPr/>
         </p:nvPicPr>
         <p:blipFill rotWithShape="1">
-          <a:blip xmlns:r="http://schemas.openxmlformats.org/officeDocument/2006/relationships" xmlns:a="http://schemas.openxmlformats.org/drawingml/2006/main" r:embed="R64250a8360504aa7">
+          <a:blip xmlns:r="http://schemas.openxmlformats.org/officeDocument/2006/relationships" xmlns:a="http://schemas.openxmlformats.org/drawingml/2006/main" r:embed="Rc94d8f88677748d1">
             <a:alphaModFix/>
           </a:blip>
           <a:srcRect xmlns:a="http://schemas.openxmlformats.org/drawingml/2006/main" l="0" t="0" r="0" b="0"/>
@@ -26719,7 +26719,7 @@
           <p:nvPr/>
         </p:nvPicPr>
         <p:blipFill rotWithShape="1">
-          <a:blip xmlns:r="http://schemas.openxmlformats.org/officeDocument/2006/relationships" xmlns:a="http://schemas.openxmlformats.org/drawingml/2006/main" r:embed="R9b687a683614483a">
+          <a:blip xmlns:r="http://schemas.openxmlformats.org/officeDocument/2006/relationships" xmlns:a="http://schemas.openxmlformats.org/drawingml/2006/main" r:embed="R466e8f276e2846cf">
             <a:alphaModFix/>
           </a:blip>
           <a:srcRect xmlns:a="http://schemas.openxmlformats.org/drawingml/2006/main" l="0" t="0" r="0" b="0"/>
@@ -26747,7 +26747,7 @@
           <p:nvPr/>
         </p:nvPicPr>
         <p:blipFill rotWithShape="1">
-          <a:blip xmlns:r="http://schemas.openxmlformats.org/officeDocument/2006/relationships" xmlns:a="http://schemas.openxmlformats.org/drawingml/2006/main" r:embed="R9b687a683614483a">
+          <a:blip xmlns:r="http://schemas.openxmlformats.org/officeDocument/2006/relationships" xmlns:a="http://schemas.openxmlformats.org/drawingml/2006/main" r:embed="R466e8f276e2846cf">
             <a:alphaModFix/>
           </a:blip>
           <a:srcRect xmlns:a="http://schemas.openxmlformats.org/drawingml/2006/main" l="0" t="0" r="0" b="0"/>
@@ -26775,7 +26775,7 @@
           <p:nvPr/>
         </p:nvPicPr>
         <p:blipFill rotWithShape="1">
-          <a:blip xmlns:r="http://schemas.openxmlformats.org/officeDocument/2006/relationships" xmlns:a="http://schemas.openxmlformats.org/drawingml/2006/main" r:embed="R9b687a683614483a">
+          <a:blip xmlns:r="http://schemas.openxmlformats.org/officeDocument/2006/relationships" xmlns:a="http://schemas.openxmlformats.org/drawingml/2006/main" r:embed="R466e8f276e2846cf">
             <a:alphaModFix/>
           </a:blip>
           <a:srcRect xmlns:a="http://schemas.openxmlformats.org/drawingml/2006/main" l="0" t="0" r="0" b="0"/>
@@ -26803,7 +26803,7 @@
           <p:nvPr/>
         </p:nvPicPr>
         <p:blipFill rotWithShape="1">
-          <a:blip xmlns:r="http://schemas.openxmlformats.org/officeDocument/2006/relationships" xmlns:a="http://schemas.openxmlformats.org/drawingml/2006/main" r:embed="R9b687a683614483a">
+          <a:blip xmlns:r="http://schemas.openxmlformats.org/officeDocument/2006/relationships" xmlns:a="http://schemas.openxmlformats.org/drawingml/2006/main" r:embed="R466e8f276e2846cf">
             <a:alphaModFix/>
           </a:blip>
           <a:srcRect xmlns:a="http://schemas.openxmlformats.org/drawingml/2006/main" l="0" t="0" r="0" b="0"/>
@@ -26932,7 +26932,7 @@
                 <a:ea typeface="Manrope"/>
                 <a:cs typeface="Manrope"/>
               </a:rPr>
-              <a:t>How many hourly periods meet the 30/30 screening condition: T &gt;= 30°C and RH &lt;= 30%?</a:t>
+              <a:t>How many hourly periods meet the 30 C / 30% project screen?</a:t>
             </a:r>
           </a:p>
         </p:txBody>
@@ -27047,7 +27047,7 @@
                 <a:ea typeface="Manrope"/>
                 <a:cs typeface="Manrope"/>
               </a:rPr>
-              <a:t>Do rapid 3-hour pressure drops appear before the driest hourly windows?</a:t>
+              <a:t>Do rapid three-hour pressure drops appear before the driest hourly windows?</a:t>
             </a:r>
           </a:p>
         </p:txBody>
@@ -27162,7 +27162,7 @@
                 <a:ea typeface="Manrope"/>
                 <a:cs typeface="Manrope"/>
               </a:rPr>
-              <a:t>During which hours do heat and low humidity combine into the strongest daily risk window?</a:t>
+              <a:t>Which hours show the strongest overlap of heat and low humidity?</a:t>
             </a:r>
           </a:p>
         </p:txBody>
@@ -27277,7 +27277,7 @@
                 <a:ea typeface="Manrope"/>
                 <a:cs typeface="Manrope"/>
               </a:rPr>
-              <a:t>Once the 30/30 screen is crossed, how long do continuous elevated-risk events last?</a:t>
+              <a:t>After the screen is crossed, how long do elevated conditions continue?</a:t>
             </a:r>
           </a:p>
         </p:txBody>
@@ -27461,8 +27461,8 @@
         </p:nvSpPr>
         <p:spPr>
           <a:xfrm xmlns:a="http://schemas.openxmlformats.org/drawingml/2006/main">
-            <a:off x="875000" y="6100000"/>
-            <a:ext cx="10299900" cy="470100"/>
+            <a:off x="875000" y="5943600"/>
+            <a:ext cx="10299900" cy="457200"/>
           </a:xfrm>
           <a:prstGeom xmlns:a="http://schemas.openxmlformats.org/drawingml/2006/main" prst="rect">
             <a:avLst/>
@@ -27488,7 +27488,7 @@
               <a:buNone/>
             </a:pPr>
             <a:r>
-              <a:rPr sz="1500" b="1">
+              <a:rPr sz="1350" b="1">
                 <a:solidFill>
                   <a:srgbClr val="FFFFFF"/>
                 </a:solidFill>
@@ -27496,18 +27496,7 @@
                 <a:ea typeface="Urbanist"/>
                 <a:cs typeface="Urbanist"/>
               </a:rPr>
-              <a:t>5. Seasonal Macro-Trends:</a:t>
-            </a:r>
-            <a:r>
-              <a:rPr sz="1500">
-                <a:solidFill>
-                  <a:srgbClr val="FFFFFF"/>
-                </a:solidFill>
-                <a:latin typeface="Urbanist"/>
-                <a:ea typeface="Urbanist"/>
-                <a:cs typeface="Urbanist"/>
-              </a:rPr>
-              <a:t> How do heat, humidity, and pressure baselines shift by season and year?</a:t>
+              <a:t>5. Seasonal trends: How do heat, humidity, and pressure shift by season and year?</a:t>
             </a:r>
           </a:p>
         </p:txBody>
@@ -27550,7 +27539,7 @@
           <p:nvPr/>
         </p:nvPicPr>
         <p:blipFill rotWithShape="1">
-          <a:blip xmlns:r="http://schemas.openxmlformats.org/officeDocument/2006/relationships" xmlns:a="http://schemas.openxmlformats.org/drawingml/2006/main" r:embed="R4db2ba6822f04423">
+          <a:blip xmlns:r="http://schemas.openxmlformats.org/officeDocument/2006/relationships" xmlns:a="http://schemas.openxmlformats.org/drawingml/2006/main" r:embed="R5a328ad2d38e473b">
             <a:alphaModFix/>
           </a:blip>
           <a:srcRect xmlns:a="http://schemas.openxmlformats.org/drawingml/2006/main" l="0" t="0" r="0" b="0"/>
@@ -27578,7 +27567,7 @@
           <p:nvPr/>
         </p:nvPicPr>
         <p:blipFill rotWithShape="1">
-          <a:blip xmlns:r="http://schemas.openxmlformats.org/officeDocument/2006/relationships" xmlns:a="http://schemas.openxmlformats.org/drawingml/2006/main" r:embed="Redbd66c06aa546ca">
+          <a:blip xmlns:r="http://schemas.openxmlformats.org/officeDocument/2006/relationships" xmlns:a="http://schemas.openxmlformats.org/drawingml/2006/main" r:embed="R1a5993a8bfc64025">
             <a:alphaModFix/>
           </a:blip>
           <a:srcRect xmlns:a="http://schemas.openxmlformats.org/drawingml/2006/main" l="0" t="0" r="0" b="0"/>
@@ -27707,7 +27696,7 @@
                 <a:ea typeface="Inter"/>
                 <a:cs typeface="Inter"/>
               </a:rPr>
-              <a:t>Simultaneous high heat ($T \ge 30^\circ\text{C}$) and low moisture ($\text{RH} \le 30\%$) events are rare but critical.</a:t>
+              <a:t>Simultaneous high heat (30 C or above) and low humidity (30% or below) are rare but important screening cases.</a:t>
             </a:r>
           </a:p>
         </p:txBody>
@@ -27822,7 +27811,7 @@
                 <a:ea typeface="Inter"/>
                 <a:cs typeface="Inter"/>
               </a:rPr>
-              <a:t>When the air is hot and dry, fuel moisture content (FMC) drops rapidly, allowing for nearly instantaneous ignition from spot embers.</a:t>
+              <a:t>Hot, dry air can reduce fine-fuel moisture and make ignition conditions more favorable.</a:t>
             </a:r>
           </a:p>
         </p:txBody>
@@ -27844,7 +27833,7 @@
         <p:spPr>
           <a:xfrm xmlns:a="http://schemas.openxmlformats.org/drawingml/2006/main">
             <a:off x="962025" y="3938587"/>
-            <a:ext cx="4896000" cy="231000"/>
+            <a:ext cx="4896000" cy="365760"/>
           </a:xfrm>
           <a:prstGeom xmlns:a="http://schemas.openxmlformats.org/drawingml/2006/main" prst="rect">
             <a:avLst/>
@@ -27881,7 +27870,7 @@
                 <a:ea typeface="Inter"/>
                 <a:cs typeface="Inter"/>
               </a:rPr>
-              <a:t>Only 26 out of 68,666 events meet this criteria.</a:t>
+              <a:t>Only 26 of 68,666 hourly events meet this criterion.</a:t>
             </a:r>
           </a:p>
         </p:txBody>
@@ -27962,7 +27951,7 @@
         <p:spPr>
           <a:xfrm xmlns:a="http://schemas.openxmlformats.org/drawingml/2006/main">
             <a:off x="962025" y="4929187"/>
-            <a:ext cx="4896000" cy="231000"/>
+            <a:ext cx="4896000" cy="365760"/>
           </a:xfrm>
           <a:prstGeom xmlns:a="http://schemas.openxmlformats.org/drawingml/2006/main" prst="rect">
             <a:avLst/>
@@ -27999,7 +27988,7 @@
                 <a:ea typeface="Inter"/>
                 <a:cs typeface="Inter"/>
               </a:rPr>
-              <a:t>Identified as the primary "Critical Danger" trigger.</a:t>
+              <a:t>Used as the project’s main heat-and-dryness screen.</a:t>
             </a:r>
           </a:p>
         </p:txBody>
@@ -28013,7 +28002,7 @@
           <p:nvPr/>
         </p:nvPicPr>
         <p:blipFill rotWithShape="1">
-          <a:blip xmlns:r="http://schemas.openxmlformats.org/officeDocument/2006/relationships" xmlns:a="http://schemas.openxmlformats.org/drawingml/2006/main" r:embed="Re8b4baa4e821447f">
+          <a:blip xmlns:r="http://schemas.openxmlformats.org/officeDocument/2006/relationships" xmlns:a="http://schemas.openxmlformats.org/drawingml/2006/main" r:embed="Rc298b3743edc4ae5">
             <a:alphaModFix/>
           </a:blip>
           <a:srcRect xmlns:a="http://schemas.openxmlformats.org/drawingml/2006/main" l="0" t="0" r="0" b="0"/>
@@ -28041,7 +28030,7 @@
           <p:nvPr/>
         </p:nvPicPr>
         <p:blipFill rotWithShape="1">
-          <a:blip xmlns:r="http://schemas.openxmlformats.org/officeDocument/2006/relationships" xmlns:a="http://schemas.openxmlformats.org/drawingml/2006/main" r:embed="Rc78380d2f2654267">
+          <a:blip xmlns:r="http://schemas.openxmlformats.org/officeDocument/2006/relationships" xmlns:a="http://schemas.openxmlformats.org/drawingml/2006/main" r:embed="R57febc3b435d4b36">
             <a:alphaModFix/>
           </a:blip>
           <a:srcRect xmlns:a="http://schemas.openxmlformats.org/drawingml/2006/main" l="0" t="0" r="0" b="0"/>
@@ -28069,7 +28058,7 @@
           <p:nvPr/>
         </p:nvPicPr>
         <p:blipFill rotWithShape="1">
-          <a:blip xmlns:r="http://schemas.openxmlformats.org/officeDocument/2006/relationships" xmlns:a="http://schemas.openxmlformats.org/drawingml/2006/main" r:embed="Rb7184eb3bdf74218">
+          <a:blip xmlns:r="http://schemas.openxmlformats.org/officeDocument/2006/relationships" xmlns:a="http://schemas.openxmlformats.org/drawingml/2006/main" r:embed="R7a066ebfa2fc44df">
             <a:alphaModFix/>
           </a:blip>
           <a:srcRect xmlns:a="http://schemas.openxmlformats.org/drawingml/2006/main" l="0" t="0" r="0" b="0"/>
@@ -28235,7 +28224,7 @@
           <p:nvPr/>
         </p:nvPicPr>
         <p:blipFill rotWithShape="1">
-          <a:blip xmlns:r="http://schemas.openxmlformats.org/officeDocument/2006/relationships" xmlns:a="http://schemas.openxmlformats.org/drawingml/2006/main" r:embed="R9bc627c474f14cd2">
+          <a:blip xmlns:r="http://schemas.openxmlformats.org/officeDocument/2006/relationships" xmlns:a="http://schemas.openxmlformats.org/drawingml/2006/main" r:embed="R85dffc396a884c17">
             <a:alphaModFix/>
           </a:blip>
           <a:srcRect xmlns:a="http://schemas.openxmlformats.org/drawingml/2006/main" l="0" t="0" r="0" b="0"/>
@@ -28263,7 +28252,7 @@
           <p:nvPr/>
         </p:nvPicPr>
         <p:blipFill rotWithShape="1">
-          <a:blip xmlns:r="http://schemas.openxmlformats.org/officeDocument/2006/relationships" xmlns:a="http://schemas.openxmlformats.org/drawingml/2006/main" r:embed="Rad33fbdaed154fd6">
+          <a:blip xmlns:r="http://schemas.openxmlformats.org/officeDocument/2006/relationships" xmlns:a="http://schemas.openxmlformats.org/drawingml/2006/main" r:embed="R22d3564fa4ef4ee0">
             <a:alphaModFix/>
           </a:blip>
           <a:srcRect xmlns:a="http://schemas.openxmlformats.org/drawingml/2006/main" l="0" t="0" r="0" b="0"/>
@@ -28585,7 +28574,7 @@
           <p:nvPr/>
         </p:nvPicPr>
         <p:blipFill rotWithShape="1">
-          <a:blip xmlns:r="http://schemas.openxmlformats.org/officeDocument/2006/relationships" xmlns:a="http://schemas.openxmlformats.org/drawingml/2006/main" r:embed="Rd4bb5a7cf5024501">
+          <a:blip xmlns:r="http://schemas.openxmlformats.org/officeDocument/2006/relationships" xmlns:a="http://schemas.openxmlformats.org/drawingml/2006/main" r:embed="R20549397a46d4d52">
             <a:alphaModFix/>
           </a:blip>
           <a:srcRect xmlns:a="http://schemas.openxmlformats.org/drawingml/2006/main" l="0" t="0" r="0" b="0"/>
@@ -28620,8 +28609,8 @@
         </p:nvSpPr>
         <p:spPr>
           <a:xfrm xmlns:a="http://schemas.openxmlformats.org/drawingml/2006/main">
-            <a:off x="581025" y="5429250"/>
-            <a:ext cx="5324475" cy="914400"/>
+            <a:off x="581025" y="5219700"/>
+            <a:ext cx="5324475" cy="876300"/>
           </a:xfrm>
           <a:prstGeom xmlns:a="http://schemas.openxmlformats.org/drawingml/2006/main" prst="rect">
             <a:avLst/>
@@ -28650,7 +28639,7 @@
               <a:buNone/>
             </a:pPr>
             <a:r>
-              <a:rPr>
+              <a:rPr sz="1350">
                 <a:solidFill>
                   <a:srgbClr val="CBD5E1"/>
                 </a:solidFill>
@@ -28658,7 +28647,7 @@
                 <a:ea typeface="Manrope"/>
                 <a:cs typeface="Manrope"/>
               </a:rPr>
-              <a:t>Claim: Highest daily vulnerability occurs from 13:00-16:00.</a:t>
+              <a:t>Claim: The strongest daily heat-and-dryness overlap appears around 13:00-16:00.</a:t>
             </a:r>
           </a:p>
           <a:p xmlns:a="http://schemas.openxmlformats.org/drawingml/2006/main">
@@ -28675,7 +28664,7 @@
               <a:buNone/>
             </a:pPr>
             <a:r>
-              <a:rPr>
+              <a:rPr sz="1350">
                 <a:solidFill>
                   <a:srgbClr val="CBD5E1"/>
                 </a:solidFill>
@@ -28683,7 +28672,7 @@
                 <a:ea typeface="Manrope"/>
                 <a:cs typeface="Manrope"/>
               </a:rPr>
-              <a:t>Evidence: Median temperature peaks as relative humidity reaches its daily low.</a:t>
+              <a:t>Evidence: Median temperature peaks while humidity reaches its daily low.</a:t>
             </a:r>
           </a:p>
         </p:txBody>
@@ -28704,8 +28693,8 @@
         </p:nvSpPr>
         <p:spPr>
           <a:xfrm xmlns:a="http://schemas.openxmlformats.org/drawingml/2006/main">
-            <a:off x="6286500" y="5429250"/>
-            <a:ext cx="5324475" cy="914400"/>
+            <a:off x="6286500" y="5353050"/>
+            <a:ext cx="5324475" cy="666750"/>
           </a:xfrm>
           <a:prstGeom xmlns:a="http://schemas.openxmlformats.org/drawingml/2006/main" prst="rect">
             <a:avLst/>
@@ -28734,7 +28723,7 @@
               <a:buNone/>
             </a:pPr>
             <a:r>
-              <a:rPr>
+              <a:rPr sz="1350">
                 <a:solidFill>
                   <a:srgbClr val="CBD5E1"/>
                 </a:solidFill>
@@ -28742,7 +28731,7 @@
                 <a:ea typeface="Manrope"/>
                 <a:cs typeface="Manrope"/>
               </a:rPr>
-              <a:t>Reasoning: Heat plus dry air lowers fine-fuel moisture, so warning sensitivity should be highest in the post-noon window.</a:t>
+              <a:t>Reasoning: This is the clearest afternoon screening window in the Jena dataset.</a:t>
             </a:r>
           </a:p>
         </p:txBody>
@@ -28756,7 +28745,7 @@
           <p:nvPr/>
         </p:nvPicPr>
         <p:blipFill rotWithShape="1">
-          <a:blip xmlns:r="http://schemas.openxmlformats.org/officeDocument/2006/relationships" xmlns:a="http://schemas.openxmlformats.org/drawingml/2006/main" r:embed="R59ebc130f16c4175">
+          <a:blip xmlns:r="http://schemas.openxmlformats.org/officeDocument/2006/relationships" xmlns:a="http://schemas.openxmlformats.org/drawingml/2006/main" r:embed="Ra76dce1a803b4a18">
             <a:alphaModFix/>
           </a:blip>
           <a:srcRect xmlns:a="http://schemas.openxmlformats.org/drawingml/2006/main" l="0" t="0" r="0" b="0"/>
@@ -28890,7 +28879,7 @@
           <p:nvPr/>
         </p:nvPicPr>
         <p:blipFill>
-          <a:blip xmlns:r="http://schemas.openxmlformats.org/officeDocument/2006/relationships" xmlns:a="http://schemas.openxmlformats.org/drawingml/2006/main" r:embed="R543777b821aa4a6c">
+          <a:blip xmlns:r="http://schemas.openxmlformats.org/officeDocument/2006/relationships" xmlns:a="http://schemas.openxmlformats.org/drawingml/2006/main" r:embed="R8007ca7670644ccd">
             <a:alphaModFix/>
           </a:blip>
           <a:stretch xmlns:a="http://schemas.openxmlformats.org/drawingml/2006/main">

</xml_diff>